<commit_message>
tried to make a class to streamline sample generation
Idea is you input a pdf and get samples from it.
</commit_message>
<xml_diff>
--- a/Poster.pptx
+++ b/Poster.pptx
@@ -117,7 +117,7 @@
 <file path=ppt/revisionInfo.xml><?xml version="1.0" encoding="utf-8"?>
 <p1510:revInfo xmlns:a="http://schemas.openxmlformats.org/drawingml/2006/main" xmlns:r="http://schemas.openxmlformats.org/officeDocument/2006/relationships" xmlns:p1510="http://schemas.microsoft.com/office/powerpoint/2015/10/main">
   <p1510:revLst>
-    <p1510:client id="{7885A197-381A-465D-A948-96F1A941B31A}" v="352" dt="2026-05-08T11:29:10.917"/>
+    <p1510:client id="{7885A197-381A-465D-A948-96F1A941B31A}" v="356" dt="2026-05-08T11:48:58.714"/>
   </p1510:revLst>
 </p1510:revInfo>
 </file>
@@ -127,12 +127,12 @@
   <pc:docChgLst>
     <pc:chgData name="Elja Meuter" userId="b1e1bb923a19bf75" providerId="LiveId" clId="{D71E6ABD-519B-41F0-9374-E926C1080144}"/>
     <pc:docChg chg="undo redo custSel addSld modSld">
-      <pc:chgData name="Elja Meuter" userId="b1e1bb923a19bf75" providerId="LiveId" clId="{D71E6ABD-519B-41F0-9374-E926C1080144}" dt="2026-05-08T11:31:16.251" v="6455" actId="13926"/>
+      <pc:chgData name="Elja Meuter" userId="b1e1bb923a19bf75" providerId="LiveId" clId="{D71E6ABD-519B-41F0-9374-E926C1080144}" dt="2026-05-08T11:48:58.714" v="6638"/>
       <pc:docMkLst>
         <pc:docMk/>
       </pc:docMkLst>
       <pc:sldChg chg="addSp delSp modSp mod setBg">
-        <pc:chgData name="Elja Meuter" userId="b1e1bb923a19bf75" providerId="LiveId" clId="{D71E6ABD-519B-41F0-9374-E926C1080144}" dt="2026-05-08T11:31:16.251" v="6455" actId="13926"/>
+        <pc:chgData name="Elja Meuter" userId="b1e1bb923a19bf75" providerId="LiveId" clId="{D71E6ABD-519B-41F0-9374-E926C1080144}" dt="2026-05-08T11:48:58.714" v="6638"/>
         <pc:sldMkLst>
           <pc:docMk/>
           <pc:sldMk cId="1631260291" sldId="256"/>
@@ -218,7 +218,7 @@
           </ac:spMkLst>
         </pc:spChg>
         <pc:spChg chg="add mod">
-          <ac:chgData name="Elja Meuter" userId="b1e1bb923a19bf75" providerId="LiveId" clId="{D71E6ABD-519B-41F0-9374-E926C1080144}" dt="2026-05-08T10:52:38.999" v="4800" actId="1036"/>
+          <ac:chgData name="Elja Meuter" userId="b1e1bb923a19bf75" providerId="LiveId" clId="{D71E6ABD-519B-41F0-9374-E926C1080144}" dt="2026-05-08T11:36:20.255" v="6634" actId="14100"/>
           <ac:spMkLst>
             <pc:docMk/>
             <pc:sldMk cId="1631260291" sldId="256"/>
@@ -369,6 +369,14 @@
             <ac:spMk id="22" creationId="{F8F838B8-E3B9-05F2-11B8-C74192335E71}"/>
           </ac:spMkLst>
         </pc:spChg>
+        <pc:spChg chg="add mod">
+          <ac:chgData name="Elja Meuter" userId="b1e1bb923a19bf75" providerId="LiveId" clId="{D71E6ABD-519B-41F0-9374-E926C1080144}" dt="2026-05-08T11:36:04.982" v="6633" actId="20577"/>
+          <ac:spMkLst>
+            <pc:docMk/>
+            <pc:sldMk cId="1631260291" sldId="256"/>
+            <ac:spMk id="22" creationId="{FF95607A-AB6C-1371-F2E6-5043AE7262D1}"/>
+          </ac:spMkLst>
+        </pc:spChg>
         <pc:spChg chg="add del mod">
           <ac:chgData name="Elja Meuter" userId="b1e1bb923a19bf75" providerId="LiveId" clId="{D71E6ABD-519B-41F0-9374-E926C1080144}" dt="2026-05-07T09:10:08.161" v="295" actId="478"/>
           <ac:spMkLst>
@@ -466,7 +474,7 @@
           </ac:spMkLst>
         </pc:spChg>
         <pc:spChg chg="add mod ord">
-          <ac:chgData name="Elja Meuter" userId="b1e1bb923a19bf75" providerId="LiveId" clId="{D71E6ABD-519B-41F0-9374-E926C1080144}" dt="2026-05-08T10:51:03.419" v="4786" actId="166"/>
+          <ac:chgData name="Elja Meuter" userId="b1e1bb923a19bf75" providerId="LiveId" clId="{D71E6ABD-519B-41F0-9374-E926C1080144}" dt="2026-05-08T11:36:30.877" v="6635" actId="1076"/>
           <ac:spMkLst>
             <pc:docMk/>
             <pc:sldMk cId="1631260291" sldId="256"/>
@@ -490,7 +498,7 @@
           </ac:spMkLst>
         </pc:spChg>
         <pc:spChg chg="add mod">
-          <ac:chgData name="Elja Meuter" userId="b1e1bb923a19bf75" providerId="LiveId" clId="{D71E6ABD-519B-41F0-9374-E926C1080144}" dt="2026-05-07T10:28:22.865" v="955" actId="14100"/>
+          <ac:chgData name="Elja Meuter" userId="b1e1bb923a19bf75" providerId="LiveId" clId="{D71E6ABD-519B-41F0-9374-E926C1080144}" dt="2026-05-08T11:34:54.164" v="6614" actId="14100"/>
           <ac:spMkLst>
             <pc:docMk/>
             <pc:sldMk cId="1631260291" sldId="256"/>
@@ -706,7 +714,7 @@
           </ac:graphicFrameMkLst>
         </pc:graphicFrameChg>
         <pc:graphicFrameChg chg="add mod modGraphic">
-          <ac:chgData name="Elja Meuter" userId="b1e1bb923a19bf75" providerId="LiveId" clId="{D71E6ABD-519B-41F0-9374-E926C1080144}" dt="2026-05-08T11:30:39.314" v="6430" actId="113"/>
+          <ac:chgData name="Elja Meuter" userId="b1e1bb923a19bf75" providerId="LiveId" clId="{D71E6ABD-519B-41F0-9374-E926C1080144}" dt="2026-05-08T11:48:58.714" v="6638"/>
           <ac:graphicFrameMkLst>
             <pc:docMk/>
             <pc:sldMk cId="1631260291" sldId="256"/>
@@ -4290,8 +4298,8 @@
         </p:nvSpPr>
         <p:spPr>
           <a:xfrm rot="20002223">
-            <a:off x="11564988" y="2885035"/>
-            <a:ext cx="14831729" cy="10484294"/>
+            <a:off x="11828207" y="2822741"/>
+            <a:ext cx="14831729" cy="11658798"/>
           </a:xfrm>
           <a:prstGeom prst="ellipse">
             <a:avLst/>
@@ -6223,8 +6231,8 @@
         </p:nvSpPr>
         <p:spPr>
           <a:xfrm>
-            <a:off x="12668251" y="6790592"/>
-            <a:ext cx="8080458" cy="1569660"/>
+            <a:off x="13065221" y="6790592"/>
+            <a:ext cx="7683487" cy="1938992"/>
           </a:xfrm>
           <a:prstGeom prst="rect">
             <a:avLst/>
@@ -6309,7 +6317,7 @@
         </p:nvSpPr>
         <p:spPr>
           <a:xfrm>
-            <a:off x="19611897" y="11354960"/>
+            <a:off x="19611897" y="12170075"/>
             <a:ext cx="3600000" cy="3600000"/>
           </a:xfrm>
           <a:prstGeom prst="ellipse">
@@ -6499,7 +6507,7 @@
           <p:nvPr>
             <p:extLst>
               <p:ext uri="{D42A27DB-BD31-4B8C-83A1-F6EECF244321}">
-                <p14:modId xmlns:p14="http://schemas.microsoft.com/office/powerpoint/2010/main" val="662832839"/>
+                <p14:modId xmlns:p14="http://schemas.microsoft.com/office/powerpoint/2010/main" val="3148053890"/>
               </p:ext>
             </p:extLst>
           </p:nvPr>
@@ -6624,6 +6632,22 @@
                         <a:latin typeface="Garamond" panose="02020404030301010803" pitchFamily="18" charset="0"/>
                       </a:endParaRPr>
                     </a:p>
+                    <a:p>
+                      <a:pPr algn="l"/>
+                      <a:r>
+                        <a:rPr lang="en-US" sz="2400" b="0" i="0" dirty="0">
+                          <a:solidFill>
+                            <a:srgbClr val="2A2A2A"/>
+                          </a:solidFill>
+                          <a:effectLst/>
+                          <a:latin typeface="Merriweather" panose="00000500000000000000" pitchFamily="2" charset="0"/>
+                        </a:rPr>
+                        <a:t>f visual orbits is strongly biased against large eccentricities.</a:t>
+                      </a:r>
+                      <a:endParaRPr lang="en-US" sz="2400" b="0" dirty="0">
+                        <a:latin typeface="Garamond" panose="02020404030301010803" pitchFamily="18" charset="0"/>
+                      </a:endParaRPr>
+                    </a:p>
                   </a:txBody>
                   <a:tcPr>
                     <a:lnL w="12700" cap="flat" cmpd="sng" algn="ctr">
@@ -6737,6 +6761,57 @@
                 <a:latin typeface="Garamond" panose="02020404030301010803" pitchFamily="18" charset="0"/>
               </a:rPr>
               <a:t>Short description of theoretical distributions found</a:t>
+            </a:r>
+          </a:p>
+        </p:txBody>
+      </p:sp>
+      <p:sp>
+        <p:nvSpPr>
+          <p:cNvPr id="22" name="Textfeld 21">
+            <a:extLst>
+              <a:ext uri="{FF2B5EF4-FFF2-40B4-BE49-F238E27FC236}">
+                <a16:creationId xmlns:a16="http://schemas.microsoft.com/office/drawing/2014/main" id="{FF95607A-AB6C-1371-F2E6-5043AE7262D1}"/>
+              </a:ext>
+            </a:extLst>
+          </p:cNvPr>
+          <p:cNvSpPr txBox="1"/>
+          <p:nvPr/>
+        </p:nvSpPr>
+        <p:spPr>
+          <a:xfrm>
+            <a:off x="14856740" y="12270316"/>
+            <a:ext cx="4755157" cy="1938992"/>
+          </a:xfrm>
+          <a:prstGeom prst="rect">
+            <a:avLst/>
+          </a:prstGeom>
+          <a:noFill/>
+        </p:spPr>
+        <p:txBody>
+          <a:bodyPr wrap="square" rtlCol="0">
+            <a:spAutoFit/>
+          </a:bodyPr>
+          <a:lstStyle/>
+          <a:p>
+            <a:r>
+              <a:rPr lang="en-US" sz="2400" b="1" i="1" dirty="0">
+                <a:latin typeface="Garamond" panose="02020404030301010803" pitchFamily="18" charset="0"/>
+              </a:rPr>
+              <a:t>Figure 1</a:t>
+            </a:r>
+            <a:r>
+              <a:rPr lang="en-US" sz="2400" dirty="0">
+                <a:latin typeface="Garamond" panose="02020404030301010803" pitchFamily="18" charset="0"/>
+              </a:rPr>
+              <a:t>. Spectroscopic binary stars detection explained. </a:t>
+            </a:r>
+          </a:p>
+          <a:p>
+            <a:r>
+              <a:rPr lang="en-US" sz="2400" dirty="0">
+                <a:latin typeface="Garamond" panose="02020404030301010803" pitchFamily="18" charset="0"/>
+              </a:rPr>
+              <a:t>We note that from the detection method alone we can already infer some biases.</a:t>
             </a:r>
           </a:p>
         </p:txBody>

</xml_diff>

<commit_message>
added interpretation of eccentricities
</commit_message>
<xml_diff>
--- a/Poster.pptx
+++ b/Poster.pptx
@@ -114,21 +114,37 @@
 </p:presentation>
 </file>
 
+<file path=ppt/revisionInfo.xml><?xml version="1.0" encoding="utf-8"?>
+<p1510:revInfo xmlns:a="http://schemas.openxmlformats.org/drawingml/2006/main" xmlns:r="http://schemas.openxmlformats.org/officeDocument/2006/relationships" xmlns:p1510="http://schemas.microsoft.com/office/powerpoint/2015/10/main">
+  <p1510:revLst>
+    <p1510:client id="{7885A197-381A-465D-A948-96F1A941B31A}" v="287" dt="2026-05-13T10:45:54.931"/>
+  </p1510:revLst>
+</p1510:revInfo>
+</file>
+
 <file path=ppt/changesInfos/changesInfo1.xml><?xml version="1.0" encoding="utf-8"?>
 <pc:chgInfo xmlns:a="http://schemas.openxmlformats.org/drawingml/2006/main" xmlns:r="http://schemas.openxmlformats.org/officeDocument/2006/relationships" xmlns:ac="http://schemas.microsoft.com/office/drawing/2013/main/command" xmlns:pc="http://schemas.microsoft.com/office/powerpoint/2013/main/command">
   <pc:docChgLst>
     <pc:chgData name="Elja Meuter" userId="b1e1bb923a19bf75" providerId="LiveId" clId="{D71E6ABD-519B-41F0-9374-E926C1080144}"/>
     <pc:docChg chg="undo redo custSel addSld modSld">
-      <pc:chgData name="Elja Meuter" userId="b1e1bb923a19bf75" providerId="LiveId" clId="{D71E6ABD-519B-41F0-9374-E926C1080144}" dt="2026-05-10T09:45:34.617" v="6643" actId="20577"/>
+      <pc:chgData name="Elja Meuter" userId="b1e1bb923a19bf75" providerId="LiveId" clId="{D71E6ABD-519B-41F0-9374-E926C1080144}" dt="2026-05-13T10:47:02.362" v="8408" actId="14100"/>
       <pc:docMkLst>
         <pc:docMk/>
       </pc:docMkLst>
       <pc:sldChg chg="addSp delSp modSp mod setBg">
-        <pc:chgData name="Elja Meuter" userId="b1e1bb923a19bf75" providerId="LiveId" clId="{D71E6ABD-519B-41F0-9374-E926C1080144}" dt="2026-05-10T09:45:34.617" v="6643" actId="20577"/>
+        <pc:chgData name="Elja Meuter" userId="b1e1bb923a19bf75" providerId="LiveId" clId="{D71E6ABD-519B-41F0-9374-E926C1080144}" dt="2026-05-13T10:47:02.362" v="8408" actId="14100"/>
         <pc:sldMkLst>
           <pc:docMk/>
           <pc:sldMk cId="1631260291" sldId="256"/>
         </pc:sldMkLst>
+        <pc:spChg chg="add mod">
+          <ac:chgData name="Elja Meuter" userId="b1e1bb923a19bf75" providerId="LiveId" clId="{D71E6ABD-519B-41F0-9374-E926C1080144}" dt="2026-05-13T10:46:07.828" v="8400" actId="2711"/>
+          <ac:spMkLst>
+            <pc:docMk/>
+            <pc:sldMk cId="1631260291" sldId="256"/>
+            <ac:spMk id="4" creationId="{3526855B-9F99-BDFF-14A5-A48A03F5DA01}"/>
+          </ac:spMkLst>
+        </pc:spChg>
         <pc:spChg chg="add mod">
           <ac:chgData name="Elja Meuter" userId="b1e1bb923a19bf75" providerId="LiveId" clId="{D71E6ABD-519B-41F0-9374-E926C1080144}" dt="2026-05-08T10:52:22.921" v="4790" actId="14100"/>
           <ac:spMkLst>
@@ -146,7 +162,7 @@
           </ac:spMkLst>
         </pc:spChg>
         <pc:spChg chg="add mod">
-          <ac:chgData name="Elja Meuter" userId="b1e1bb923a19bf75" providerId="LiveId" clId="{D71E6ABD-519B-41F0-9374-E926C1080144}" dt="2026-05-08T10:57:53.808" v="5172" actId="114"/>
+          <ac:chgData name="Elja Meuter" userId="b1e1bb923a19bf75" providerId="LiveId" clId="{D71E6ABD-519B-41F0-9374-E926C1080144}" dt="2026-05-13T10:46:40.569" v="8403" actId="1076"/>
           <ac:spMkLst>
             <pc:docMk/>
             <pc:sldMk cId="1631260291" sldId="256"/>
@@ -162,7 +178,7 @@
           </ac:spMkLst>
         </pc:spChg>
         <pc:spChg chg="add mod">
-          <ac:chgData name="Elja Meuter" userId="b1e1bb923a19bf75" providerId="LiveId" clId="{D71E6ABD-519B-41F0-9374-E926C1080144}" dt="2026-05-08T11:30:48.943" v="6432" actId="13926"/>
+          <ac:chgData name="Elja Meuter" userId="b1e1bb923a19bf75" providerId="LiveId" clId="{D71E6ABD-519B-41F0-9374-E926C1080144}" dt="2026-05-13T10:46:40.569" v="8403" actId="1076"/>
           <ac:spMkLst>
             <pc:docMk/>
             <pc:sldMk cId="1631260291" sldId="256"/>
@@ -186,7 +202,7 @@
           </ac:spMkLst>
         </pc:spChg>
         <pc:spChg chg="add mod ord">
-          <ac:chgData name="Elja Meuter" userId="b1e1bb923a19bf75" providerId="LiveId" clId="{D71E6ABD-519B-41F0-9374-E926C1080144}" dt="2026-05-07T09:52:37.171" v="500" actId="208"/>
+          <ac:chgData name="Elja Meuter" userId="b1e1bb923a19bf75" providerId="LiveId" clId="{D71E6ABD-519B-41F0-9374-E926C1080144}" dt="2026-05-13T10:46:40.569" v="8403" actId="1076"/>
           <ac:spMkLst>
             <pc:docMk/>
             <pc:sldMk cId="1631260291" sldId="256"/>
@@ -194,7 +210,7 @@
           </ac:spMkLst>
         </pc:spChg>
         <pc:spChg chg="add mod">
-          <ac:chgData name="Elja Meuter" userId="b1e1bb923a19bf75" providerId="LiveId" clId="{D71E6ABD-519B-41F0-9374-E926C1080144}" dt="2026-05-07T09:44:35.020" v="387" actId="14100"/>
+          <ac:chgData name="Elja Meuter" userId="b1e1bb923a19bf75" providerId="LiveId" clId="{D71E6ABD-519B-41F0-9374-E926C1080144}" dt="2026-05-13T10:47:02.362" v="8408" actId="14100"/>
           <ac:spMkLst>
             <pc:docMk/>
             <pc:sldMk cId="1631260291" sldId="256"/>
@@ -226,7 +242,7 @@
           </ac:spMkLst>
         </pc:spChg>
         <pc:spChg chg="add mod">
-          <ac:chgData name="Elja Meuter" userId="b1e1bb923a19bf75" providerId="LiveId" clId="{D71E6ABD-519B-41F0-9374-E926C1080144}" dt="2026-05-08T11:03:41.170" v="5272" actId="1076"/>
+          <ac:chgData name="Elja Meuter" userId="b1e1bb923a19bf75" providerId="LiveId" clId="{D71E6ABD-519B-41F0-9374-E926C1080144}" dt="2026-05-13T10:44:44.351" v="8383" actId="20577"/>
           <ac:spMkLst>
             <pc:docMk/>
             <pc:sldMk cId="1631260291" sldId="256"/>
@@ -242,7 +258,7 @@
           </ac:spMkLst>
         </pc:spChg>
         <pc:spChg chg="add mod">
-          <ac:chgData name="Elja Meuter" userId="b1e1bb923a19bf75" providerId="LiveId" clId="{D71E6ABD-519B-41F0-9374-E926C1080144}" dt="2026-05-08T10:58:02.902" v="5174" actId="20577"/>
+          <ac:chgData name="Elja Meuter" userId="b1e1bb923a19bf75" providerId="LiveId" clId="{D71E6ABD-519B-41F0-9374-E926C1080144}" dt="2026-05-13T10:46:40.569" v="8403" actId="1076"/>
           <ac:spMkLst>
             <pc:docMk/>
             <pc:sldMk cId="1631260291" sldId="256"/>
@@ -258,7 +274,7 @@
           </ac:spMkLst>
         </pc:spChg>
         <pc:spChg chg="add del mod">
-          <ac:chgData name="Elja Meuter" userId="b1e1bb923a19bf75" providerId="LiveId" clId="{D71E6ABD-519B-41F0-9374-E926C1080144}" dt="2026-05-08T11:31:16.251" v="6455" actId="13926"/>
+          <ac:chgData name="Elja Meuter" userId="b1e1bb923a19bf75" providerId="LiveId" clId="{D71E6ABD-519B-41F0-9374-E926C1080144}" dt="2026-05-13T10:45:49.558" v="8395" actId="21"/>
           <ac:spMkLst>
             <pc:docMk/>
             <pc:sldMk cId="1631260291" sldId="256"/>
@@ -273,8 +289,8 @@
             <ac:spMk id="82" creationId="{EDBEE8A4-9524-7B70-8E91-5870476C097D}"/>
           </ac:spMkLst>
         </pc:spChg>
-        <pc:graphicFrameChg chg="add mod modGraphic">
-          <ac:chgData name="Elja Meuter" userId="b1e1bb923a19bf75" providerId="LiveId" clId="{D71E6ABD-519B-41F0-9374-E926C1080144}" dt="2026-05-08T10:49:39.125" v="4769" actId="1076"/>
+        <pc:graphicFrameChg chg="add del mod modGraphic">
+          <ac:chgData name="Elja Meuter" userId="b1e1bb923a19bf75" providerId="LiveId" clId="{D71E6ABD-519B-41F0-9374-E926C1080144}" dt="2026-05-13T10:15:20.839" v="6917" actId="478"/>
           <ac:graphicFrameMkLst>
             <pc:docMk/>
             <pc:sldMk cId="1631260291" sldId="256"/>
@@ -282,7 +298,15 @@
           </ac:graphicFrameMkLst>
         </pc:graphicFrameChg>
         <pc:graphicFrameChg chg="add mod modGraphic">
-          <ac:chgData name="Elja Meuter" userId="b1e1bb923a19bf75" providerId="LiveId" clId="{D71E6ABD-519B-41F0-9374-E926C1080144}" dt="2026-05-08T11:48:58.714" v="6638"/>
+          <ac:chgData name="Elja Meuter" userId="b1e1bb923a19bf75" providerId="LiveId" clId="{D71E6ABD-519B-41F0-9374-E926C1080144}" dt="2026-05-13T10:46:40.569" v="8403" actId="1076"/>
+          <ac:graphicFrameMkLst>
+            <pc:docMk/>
+            <pc:sldMk cId="1631260291" sldId="256"/>
+            <ac:graphicFrameMk id="3" creationId="{94A2B041-0A3D-4469-7F39-F62F5BC2501A}"/>
+          </ac:graphicFrameMkLst>
+        </pc:graphicFrameChg>
+        <pc:graphicFrameChg chg="add mod modGraphic">
+          <ac:chgData name="Elja Meuter" userId="b1e1bb923a19bf75" providerId="LiveId" clId="{D71E6ABD-519B-41F0-9374-E926C1080144}" dt="2026-05-13T10:46:14.498" v="8401" actId="14100"/>
           <ac:graphicFrameMkLst>
             <pc:docMk/>
             <pc:sldMk cId="1631260291" sldId="256"/>
@@ -314,7 +338,7 @@
           </ac:picMkLst>
         </pc:picChg>
         <pc:picChg chg="add mod">
-          <ac:chgData name="Elja Meuter" userId="b1e1bb923a19bf75" providerId="LiveId" clId="{D71E6ABD-519B-41F0-9374-E926C1080144}" dt="2026-05-07T10:21:58.665" v="893" actId="1076"/>
+          <ac:chgData name="Elja Meuter" userId="b1e1bb923a19bf75" providerId="LiveId" clId="{D71E6ABD-519B-41F0-9374-E926C1080144}" dt="2026-05-13T10:45:16.999" v="8387" actId="1076"/>
           <ac:picMkLst>
             <pc:docMk/>
             <pc:sldMk cId="1631260291" sldId="256"/>
@@ -322,7 +346,7 @@
           </ac:picMkLst>
         </pc:picChg>
         <pc:picChg chg="add mod">
-          <ac:chgData name="Elja Meuter" userId="b1e1bb923a19bf75" providerId="LiveId" clId="{D71E6ABD-519B-41F0-9374-E926C1080144}" dt="2026-05-07T10:21:46.749" v="890" actId="1076"/>
+          <ac:chgData name="Elja Meuter" userId="b1e1bb923a19bf75" providerId="LiveId" clId="{D71E6ABD-519B-41F0-9374-E926C1080144}" dt="2026-05-13T10:46:20.477" v="8402" actId="1076"/>
           <ac:picMkLst>
             <pc:docMk/>
             <pc:sldMk cId="1631260291" sldId="256"/>
@@ -744,7 +768,7 @@
           <a:p>
             <a:fld id="{A1915611-89FC-422F-9E33-70C527C3BC07}" type="datetimeFigureOut">
               <a:rPr lang="en-US" smtClean="0"/>
-              <a:t>5/8/2026</a:t>
+              <a:t>5/13/2026</a:t>
             </a:fld>
             <a:endParaRPr lang="en-US"/>
           </a:p>
@@ -914,7 +938,7 @@
           <a:p>
             <a:fld id="{A1915611-89FC-422F-9E33-70C527C3BC07}" type="datetimeFigureOut">
               <a:rPr lang="en-US" smtClean="0"/>
-              <a:t>5/8/2026</a:t>
+              <a:t>5/13/2026</a:t>
             </a:fld>
             <a:endParaRPr lang="en-US"/>
           </a:p>
@@ -1094,7 +1118,7 @@
           <a:p>
             <a:fld id="{A1915611-89FC-422F-9E33-70C527C3BC07}" type="datetimeFigureOut">
               <a:rPr lang="en-US" smtClean="0"/>
-              <a:t>5/8/2026</a:t>
+              <a:t>5/13/2026</a:t>
             </a:fld>
             <a:endParaRPr lang="en-US"/>
           </a:p>
@@ -1264,7 +1288,7 @@
           <a:p>
             <a:fld id="{A1915611-89FC-422F-9E33-70C527C3BC07}" type="datetimeFigureOut">
               <a:rPr lang="en-US" smtClean="0"/>
-              <a:t>5/8/2026</a:t>
+              <a:t>5/13/2026</a:t>
             </a:fld>
             <a:endParaRPr lang="en-US"/>
           </a:p>
@@ -1510,7 +1534,7 @@
           <a:p>
             <a:fld id="{A1915611-89FC-422F-9E33-70C527C3BC07}" type="datetimeFigureOut">
               <a:rPr lang="en-US" smtClean="0"/>
-              <a:t>5/8/2026</a:t>
+              <a:t>5/13/2026</a:t>
             </a:fld>
             <a:endParaRPr lang="en-US"/>
           </a:p>
@@ -1742,7 +1766,7 @@
           <a:p>
             <a:fld id="{A1915611-89FC-422F-9E33-70C527C3BC07}" type="datetimeFigureOut">
               <a:rPr lang="en-US" smtClean="0"/>
-              <a:t>5/8/2026</a:t>
+              <a:t>5/13/2026</a:t>
             </a:fld>
             <a:endParaRPr lang="en-US"/>
           </a:p>
@@ -2109,7 +2133,7 @@
           <a:p>
             <a:fld id="{A1915611-89FC-422F-9E33-70C527C3BC07}" type="datetimeFigureOut">
               <a:rPr lang="en-US" smtClean="0"/>
-              <a:t>5/8/2026</a:t>
+              <a:t>5/13/2026</a:t>
             </a:fld>
             <a:endParaRPr lang="en-US"/>
           </a:p>
@@ -2227,7 +2251,7 @@
           <a:p>
             <a:fld id="{A1915611-89FC-422F-9E33-70C527C3BC07}" type="datetimeFigureOut">
               <a:rPr lang="en-US" smtClean="0"/>
-              <a:t>5/8/2026</a:t>
+              <a:t>5/13/2026</a:t>
             </a:fld>
             <a:endParaRPr lang="en-US"/>
           </a:p>
@@ -2322,7 +2346,7 @@
           <a:p>
             <a:fld id="{A1915611-89FC-422F-9E33-70C527C3BC07}" type="datetimeFigureOut">
               <a:rPr lang="en-US" smtClean="0"/>
-              <a:t>5/8/2026</a:t>
+              <a:t>5/13/2026</a:t>
             </a:fld>
             <a:endParaRPr lang="en-US"/>
           </a:p>
@@ -2599,7 +2623,7 @@
           <a:p>
             <a:fld id="{A1915611-89FC-422F-9E33-70C527C3BC07}" type="datetimeFigureOut">
               <a:rPr lang="en-US" smtClean="0"/>
-              <a:t>5/8/2026</a:t>
+              <a:t>5/13/2026</a:t>
             </a:fld>
             <a:endParaRPr lang="en-US"/>
           </a:p>
@@ -2856,7 +2880,7 @@
           <a:p>
             <a:fld id="{A1915611-89FC-422F-9E33-70C527C3BC07}" type="datetimeFigureOut">
               <a:rPr lang="en-US" smtClean="0"/>
-              <a:t>5/8/2026</a:t>
+              <a:t>5/13/2026</a:t>
             </a:fld>
             <a:endParaRPr lang="en-US"/>
           </a:p>
@@ -3069,7 +3093,7 @@
           <a:p>
             <a:fld id="{A1915611-89FC-422F-9E33-70C527C3BC07}" type="datetimeFigureOut">
               <a:rPr lang="en-US" smtClean="0"/>
-              <a:t>5/8/2026</a:t>
+              <a:t>5/13/2026</a:t>
             </a:fld>
             <a:endParaRPr lang="en-US"/>
           </a:p>
@@ -3496,8 +3520,8 @@
         </p:nvSpPr>
         <p:spPr>
           <a:xfrm rot="20002223">
-            <a:off x="-3765161" y="10355549"/>
-            <a:ext cx="19204405" cy="10591923"/>
+            <a:off x="-3893023" y="7568067"/>
+            <a:ext cx="18355988" cy="11287663"/>
           </a:xfrm>
           <a:prstGeom prst="ellipse">
             <a:avLst/>
@@ -3548,7 +3572,7 @@
         </p:nvSpPr>
         <p:spPr>
           <a:xfrm>
-            <a:off x="2773680" y="9757046"/>
+            <a:off x="2756742" y="7438264"/>
             <a:ext cx="1800000" cy="1800000"/>
           </a:xfrm>
           <a:prstGeom prst="ellipse">
@@ -3747,7 +3771,7 @@
         <p:spPr>
           <a:xfrm>
             <a:off x="603885" y="4220811"/>
-            <a:ext cx="11136183" cy="5201424"/>
+            <a:ext cx="11136183" cy="1815882"/>
           </a:xfrm>
           <a:prstGeom prst="rect">
             <a:avLst/>
@@ -3771,42 +3795,48 @@
             </a:r>
           </a:p>
           <a:p>
-            <a:r>
-              <a:rPr lang="en-US" sz="2400" i="1" dirty="0">
+            <a:pPr marL="0" marR="0" lvl="0" indent="0" algn="l" defTabSz="457200" rtl="0" eaLnBrk="1" fontAlgn="auto" latinLnBrk="0" hangingPunct="1">
+              <a:lnSpc>
+                <a:spcPct val="100000"/>
+              </a:lnSpc>
+              <a:spcBef>
+                <a:spcPts val="0"/>
+              </a:spcBef>
+              <a:spcAft>
+                <a:spcPts val="0"/>
+              </a:spcAft>
+              <a:buClrTx/>
+              <a:buSzTx/>
+              <a:buFontTx/>
+              <a:buNone/>
+              <a:tabLst/>
+              <a:defRPr/>
+            </a:pPr>
+            <a:r>
+              <a:rPr kumimoji="0" lang="en-US" sz="2400" b="0" i="0" u="none" strike="noStrike" kern="1200" cap="none" spc="0" normalizeH="0" baseline="0" noProof="0" dirty="0">
+                <a:ln>
+                  <a:noFill/>
+                </a:ln>
+                <a:solidFill>
+                  <a:prstClr val="black"/>
+                </a:solidFill>
+                <a:effectLst/>
+                <a:highlight>
+                  <a:srgbClr val="FFFF00"/>
+                </a:highlight>
+                <a:uLnTx/>
+                <a:uFillTx/>
                 <a:latin typeface="Garamond" panose="02020404030301010803" pitchFamily="18" charset="0"/>
+                <a:ea typeface="+mn-ea"/>
+                <a:cs typeface="+mn-cs"/>
               </a:rPr>
-              <a:t>Bias in the Sky </a:t>
-            </a:r>
-            <a:r>
-              <a:rPr lang="en-US" sz="2400" dirty="0">
-                <a:latin typeface="Garamond" panose="02020404030301010803" pitchFamily="18" charset="0"/>
-              </a:rPr>
-              <a:t>explores a common challenge in astronomy: the stars we observe are not always a fair representation of the stars that actually exist.</a:t>
-            </a:r>
-          </a:p>
-          <a:p>
-            <a:r>
-              <a:rPr lang="en-US" sz="2400" dirty="0">
-                <a:latin typeface="Garamond" panose="02020404030301010803" pitchFamily="18" charset="0"/>
-              </a:rPr>
-              <a:t>Astronomers rely on large binary star catalogues to study how pairs of stars form, evolve, and interact. But every telescope and detection method comes with its own observational bias - some binaries are easier to detect than others. As a result, catalogues can miss entire parts of the true binary star population.</a:t>
-            </a:r>
-          </a:p>
-          <a:p>
-            <a:r>
-              <a:rPr lang="en-US" sz="2400" dirty="0">
-                <a:latin typeface="Garamond" panose="02020404030301010803" pitchFamily="18" charset="0"/>
-              </a:rPr>
-              <a:t>Correcting for these biases is essential. However, each survey observes the sky in a different way, making it challenging to separate real astrophysical trends from observational effects.</a:t>
-            </a:r>
-          </a:p>
-          <a:p>
-            <a:r>
-              <a:rPr lang="en-US" sz="2400" dirty="0">
-                <a:latin typeface="Garamond" panose="02020404030301010803" pitchFamily="18" charset="0"/>
-              </a:rPr>
-              <a:t>This project investigates the observational bias present in the SB9 and ORB6 binary star catalogues by comparing them with theoretical binary star models. By quantifying these hidden selection effects, we aim to better uncover the true underlying distributions of binary star systems.</a:t>
-            </a:r>
+              <a:t>Short introduction</a:t>
+            </a:r>
+          </a:p>
+          <a:p>
+            <a:endParaRPr lang="en-US" sz="4400" b="1" dirty="0">
+              <a:latin typeface="Garamond" panose="02020404030301010803" pitchFamily="18" charset="0"/>
+            </a:endParaRPr>
           </a:p>
         </p:txBody>
       </p:sp>
@@ -3880,7 +3910,7 @@
         </p:nvSpPr>
         <p:spPr>
           <a:xfrm>
-            <a:off x="4589193" y="9923306"/>
+            <a:off x="4572255" y="7604524"/>
             <a:ext cx="7277051" cy="2246769"/>
           </a:xfrm>
           <a:prstGeom prst="rect">
@@ -4005,8 +4035,8 @@
         </p:blipFill>
         <p:spPr>
           <a:xfrm>
-            <a:off x="6543675" y="21548558"/>
-            <a:ext cx="6800419" cy="3918595"/>
+            <a:off x="8046720" y="17740215"/>
+            <a:ext cx="4944344" cy="2849072"/>
           </a:xfrm>
           <a:prstGeom prst="rect">
             <a:avLst/>
@@ -4051,8 +4081,8 @@
         </p:blipFill>
         <p:spPr>
           <a:xfrm>
-            <a:off x="13942577" y="21453090"/>
-            <a:ext cx="6806131" cy="3918595"/>
+            <a:off x="8181679" y="21060228"/>
+            <a:ext cx="4674426" cy="2691277"/>
           </a:xfrm>
           <a:prstGeom prst="rect">
             <a:avLst/>
@@ -4073,8 +4103,8 @@
         </p:nvSpPr>
         <p:spPr>
           <a:xfrm>
-            <a:off x="312830" y="25335548"/>
-            <a:ext cx="12213000" cy="1895391"/>
+            <a:off x="152158" y="20628764"/>
+            <a:ext cx="7567553" cy="3724096"/>
           </a:xfrm>
           <a:prstGeom prst="rect">
             <a:avLst/>
@@ -4094,35 +4124,29 @@
               <a:rPr lang="en-US" sz="4400" b="1" dirty="0">
                 <a:latin typeface="Garamond" panose="02020404030301010803" pitchFamily="18" charset="0"/>
               </a:rPr>
-              <a:t>Conclusion</a:t>
-            </a:r>
-          </a:p>
-          <a:p>
-            <a:pPr algn="just">
-              <a:spcAft>
-                <a:spcPts val="1125"/>
-              </a:spcAft>
-              <a:buNone/>
-            </a:pPr>
-            <a:r>
-              <a:rPr lang="en-US" sz="3200" dirty="0">
-                <a:highlight>
-                  <a:srgbClr val="FFFF00"/>
-                </a:highlight>
+              <a:t>Conclusion &amp; Discussion</a:t>
+            </a:r>
+          </a:p>
+          <a:p>
+            <a:r>
+              <a:rPr lang="en-US" sz="2400" dirty="0">
+                <a:latin typeface="Garamond" panose="02020404030301010803" pitchFamily="18" charset="0"/>
               </a:rPr>
-              <a:t>Put conclusion here </a:t>
-            </a:r>
-            <a:endParaRPr lang="en-US" sz="3200" dirty="0">
-              <a:solidFill>
-                <a:srgbClr val="000000"/>
-              </a:solidFill>
-              <a:highlight>
-                <a:srgbClr val="FFFF00"/>
-              </a:highlight>
-              <a:latin typeface="Open Sans" panose="020B0606030504020204" pitchFamily="34" charset="0"/>
+              <a:t>A preference for circular orbits in SB9, makes sense since these have the easiest RV curve to detect. Spectroscopic binaries are often close binaries, so circular orbits are much more likely. </a:t>
+            </a:r>
+          </a:p>
+          <a:p>
+            <a:endParaRPr lang="en-US" sz="2400" dirty="0">
+              <a:latin typeface="Garamond" panose="02020404030301010803" pitchFamily="18" charset="0"/>
             </a:endParaRPr>
           </a:p>
           <a:p>
+            <a:r>
+              <a:rPr lang="en-US" sz="2400" dirty="0">
+                <a:latin typeface="Garamond" panose="02020404030301010803" pitchFamily="18" charset="0"/>
+              </a:rPr>
+              <a:t>For ORB6 the bias towards lower eccentricities is much flatter, indicating that a larger period range is covered. The bias is most likely of computational origin since</a:t>
+            </a:r>
             <a:endParaRPr lang="en-US" sz="3200" dirty="0">
               <a:latin typeface="Garamond" panose="02020404030301010803" pitchFamily="18" charset="0"/>
             </a:endParaRPr>
@@ -4227,1237 +4251,6 @@
           </a:p>
         </p:txBody>
       </p:sp>
-      <mc:AlternateContent xmlns:mc="http://schemas.openxmlformats.org/markup-compatibility/2006">
-        <mc:Choice xmlns:a14="http://schemas.microsoft.com/office/drawing/2010/main" Requires="a14">
-          <p:graphicFrame>
-            <p:nvGraphicFramePr>
-              <p:cNvPr id="2" name="Tabelle 1">
-                <a:extLst>
-                  <a:ext uri="{FF2B5EF4-FFF2-40B4-BE49-F238E27FC236}">
-                    <a16:creationId xmlns:a16="http://schemas.microsoft.com/office/drawing/2014/main" id="{676EC7A9-7BA9-3282-F812-BF1EB6A556C5}"/>
-                  </a:ext>
-                </a:extLst>
-              </p:cNvPr>
-              <p:cNvGraphicFramePr>
-                <a:graphicFrameLocks noGrp="1"/>
-              </p:cNvGraphicFramePr>
-              <p:nvPr>
-                <p:extLst>
-                  <p:ext uri="{D42A27DB-BD31-4B8C-83A1-F6EECF244321}">
-                    <p14:modId xmlns:p14="http://schemas.microsoft.com/office/powerpoint/2010/main" val="2319209304"/>
-                  </p:ext>
-                </p:extLst>
-              </p:nvPr>
-            </p:nvGraphicFramePr>
-            <p:xfrm>
-              <a:off x="312829" y="13598088"/>
-              <a:ext cx="11427239" cy="4280104"/>
-            </p:xfrm>
-            <a:graphic>
-              <a:graphicData uri="http://schemas.openxmlformats.org/drawingml/2006/table">
-                <a:tbl>
-                  <a:tblPr firstRow="1" bandRow="1">
-                    <a:tableStyleId>{5940675A-B579-460E-94D1-54222C63F5DA}</a:tableStyleId>
-                  </a:tblPr>
-                  <a:tblGrid>
-                    <a:gridCol w="1924950">
-                      <a:extLst>
-                        <a:ext uri="{9D8B030D-6E8A-4147-A177-3AD203B41FA5}">
-                          <a16:colId xmlns:a16="http://schemas.microsoft.com/office/drawing/2014/main" val="1204722445"/>
-                        </a:ext>
-                      </a:extLst>
-                    </a:gridCol>
-                    <a:gridCol w="1924950">
-                      <a:extLst>
-                        <a:ext uri="{9D8B030D-6E8A-4147-A177-3AD203B41FA5}">
-                          <a16:colId xmlns:a16="http://schemas.microsoft.com/office/drawing/2014/main" val="3703163242"/>
-                        </a:ext>
-                      </a:extLst>
-                    </a:gridCol>
-                    <a:gridCol w="1924950">
-                      <a:extLst>
-                        <a:ext uri="{9D8B030D-6E8A-4147-A177-3AD203B41FA5}">
-                          <a16:colId xmlns:a16="http://schemas.microsoft.com/office/drawing/2014/main" val="1561748901"/>
-                        </a:ext>
-                      </a:extLst>
-                    </a:gridCol>
-                    <a:gridCol w="1924950">
-                      <a:extLst>
-                        <a:ext uri="{9D8B030D-6E8A-4147-A177-3AD203B41FA5}">
-                          <a16:colId xmlns:a16="http://schemas.microsoft.com/office/drawing/2014/main" val="1538840913"/>
-                        </a:ext>
-                      </a:extLst>
-                    </a:gridCol>
-                    <a:gridCol w="1924950">
-                      <a:extLst>
-                        <a:ext uri="{9D8B030D-6E8A-4147-A177-3AD203B41FA5}">
-                          <a16:colId xmlns:a16="http://schemas.microsoft.com/office/drawing/2014/main" val="381055411"/>
-                        </a:ext>
-                      </a:extLst>
-                    </a:gridCol>
-                    <a:gridCol w="1802489">
-                      <a:extLst>
-                        <a:ext uri="{9D8B030D-6E8A-4147-A177-3AD203B41FA5}">
-                          <a16:colId xmlns:a16="http://schemas.microsoft.com/office/drawing/2014/main" val="1848283666"/>
-                        </a:ext>
-                      </a:extLst>
-                    </a:gridCol>
-                  </a:tblGrid>
-                  <a:tr h="494132">
-                    <a:tc>
-                      <a:txBody>
-                        <a:bodyPr/>
-                        <a:lstStyle/>
-                        <a:p>
-                          <a:endParaRPr lang="en-US" sz="2400" dirty="0">
-                            <a:latin typeface="Garamond" panose="02020404030301010803" pitchFamily="18" charset="0"/>
-                          </a:endParaRPr>
-                        </a:p>
-                      </a:txBody>
-                      <a:tcPr/>
-                    </a:tc>
-                    <a:tc>
-                      <a:txBody>
-                        <a:bodyPr/>
-                        <a:lstStyle/>
-                        <a:p>
-                          <a:r>
-                            <a:rPr lang="en-US" sz="2400" dirty="0">
-                              <a:latin typeface="Garamond" panose="02020404030301010803" pitchFamily="18" charset="0"/>
-                            </a:rPr>
-                            <a:t>Eccentricity e</a:t>
-                          </a:r>
-                        </a:p>
-                      </a:txBody>
-                      <a:tcPr/>
-                    </a:tc>
-                    <a:tc>
-                      <a:txBody>
-                        <a:bodyPr/>
-                        <a:lstStyle/>
-                        <a:p>
-                          <a:r>
-                            <a:rPr lang="en-US" sz="2400" dirty="0">
-                              <a:latin typeface="Garamond" panose="02020404030301010803" pitchFamily="18" charset="0"/>
-                            </a:rPr>
-                            <a:t>Mass ratio q</a:t>
-                          </a:r>
-                        </a:p>
-                      </a:txBody>
-                      <a:tcPr/>
-                    </a:tc>
-                    <a:tc>
-                      <a:txBody>
-                        <a:bodyPr/>
-                        <a:lstStyle/>
-                        <a:p>
-                          <a:r>
-                            <a:rPr lang="en-US" sz="2400" dirty="0">
-                              <a:latin typeface="Garamond" panose="02020404030301010803" pitchFamily="18" charset="0"/>
-                            </a:rPr>
-                            <a:t>Orbital Period P</a:t>
-                          </a:r>
-                        </a:p>
-                      </a:txBody>
-                      <a:tcPr/>
-                    </a:tc>
-                    <a:tc>
-                      <a:txBody>
-                        <a:bodyPr/>
-                        <a:lstStyle/>
-                        <a:p>
-                          <a:r>
-                            <a:rPr lang="en-US" sz="2400" dirty="0">
-                              <a:latin typeface="Garamond" panose="02020404030301010803" pitchFamily="18" charset="0"/>
-                            </a:rPr>
-                            <a:t>Semi-major axis a</a:t>
-                          </a:r>
-                        </a:p>
-                      </a:txBody>
-                      <a:tcPr/>
-                    </a:tc>
-                    <a:tc>
-                      <a:txBody>
-                        <a:bodyPr/>
-                        <a:lstStyle/>
-                        <a:p>
-                          <a:r>
-                            <a:rPr lang="en-US" sz="2400" dirty="0">
-                              <a:latin typeface="Garamond" panose="02020404030301010803" pitchFamily="18" charset="0"/>
-                            </a:rPr>
-                            <a:t>Radius ratio R</a:t>
-                          </a:r>
-                        </a:p>
-                      </a:txBody>
-                      <a:tcPr/>
-                    </a:tc>
-                    <a:extLst>
-                      <a:ext uri="{0D108BD9-81ED-4DB2-BD59-A6C34878D82A}">
-                        <a16:rowId xmlns:a16="http://schemas.microsoft.com/office/drawing/2014/main" val="1142826704"/>
-                      </a:ext>
-                    </a:extLst>
-                  </a:tr>
-                  <a:tr h="494132">
-                    <a:tc>
-                      <a:txBody>
-                        <a:bodyPr/>
-                        <a:lstStyle/>
-                        <a:p>
-                          <a:r>
-                            <a:rPr lang="en-US" sz="2400" dirty="0">
-                              <a:latin typeface="Garamond" panose="02020404030301010803" pitchFamily="18" charset="0"/>
-                            </a:rPr>
-                            <a:t>Eccentricity e</a:t>
-                          </a:r>
-                        </a:p>
-                      </a:txBody>
-                      <a:tcPr/>
-                    </a:tc>
-                    <a:tc>
-                      <a:txBody>
-                        <a:bodyPr/>
-                        <a:lstStyle/>
-                        <a:p>
-                          <a:endParaRPr lang="en-US" sz="2400" dirty="0">
-                            <a:latin typeface="Garamond" panose="02020404030301010803" pitchFamily="18" charset="0"/>
-                          </a:endParaRPr>
-                        </a:p>
-                      </a:txBody>
-                      <a:tcPr/>
-                    </a:tc>
-                    <a:tc>
-                      <a:txBody>
-                        <a:bodyPr/>
-                        <a:lstStyle/>
-                        <a:p>
-                          <a:endParaRPr lang="en-US" sz="2400" dirty="0">
-                            <a:latin typeface="Garamond" panose="02020404030301010803" pitchFamily="18" charset="0"/>
-                          </a:endParaRPr>
-                        </a:p>
-                      </a:txBody>
-                      <a:tcPr/>
-                    </a:tc>
-                    <a:tc>
-                      <a:txBody>
-                        <a:bodyPr/>
-                        <a:lstStyle/>
-                        <a:p>
-                          <a14:m>
-                            <m:oMathPara xmlns:m="http://schemas.openxmlformats.org/officeDocument/2006/math">
-                              <m:oMathParaPr>
-                                <m:jc m:val="centerGroup"/>
-                              </m:oMathParaPr>
-                              <m:oMath xmlns:m="http://schemas.openxmlformats.org/officeDocument/2006/math">
-                                <m:r>
-                                  <a:rPr lang="en-US" sz="2400" b="0" i="1" smtClean="0">
-                                    <a:latin typeface="Cambria Math" panose="02040503050406030204" pitchFamily="18" charset="0"/>
-                                  </a:rPr>
-                                  <m:t>𝑃</m:t>
-                                </m:r>
-                                <m:r>
-                                  <a:rPr lang="en-US" sz="2400" b="0" i="1" smtClean="0">
-                                    <a:latin typeface="Cambria Math" panose="02040503050406030204" pitchFamily="18" charset="0"/>
-                                  </a:rPr>
-                                  <m:t>∝</m:t>
-                                </m:r>
-                                <m:sSup>
-                                  <m:sSupPr>
-                                    <m:ctrlPr>
-                                      <a:rPr lang="en-US" sz="2400" b="0" i="1" smtClean="0">
-                                        <a:latin typeface="Cambria Math" panose="02040503050406030204" pitchFamily="18" charset="0"/>
-                                      </a:rPr>
-                                    </m:ctrlPr>
-                                  </m:sSupPr>
-                                  <m:e>
-                                    <m:r>
-                                      <a:rPr lang="en-US" sz="2400" b="0" i="1" smtClean="0">
-                                        <a:latin typeface="Cambria Math" panose="02040503050406030204" pitchFamily="18" charset="0"/>
-                                      </a:rPr>
-                                      <m:t>𝑒</m:t>
-                                    </m:r>
-                                  </m:e>
-                                  <m:sup>
-                                    <m:r>
-                                      <a:rPr lang="en-US" sz="2400" b="0" i="1" smtClean="0">
-                                        <a:latin typeface="Cambria Math" panose="02040503050406030204" pitchFamily="18" charset="0"/>
-                                      </a:rPr>
-                                      <m:t>𝜂</m:t>
-                                    </m:r>
-                                  </m:sup>
-                                </m:sSup>
-                              </m:oMath>
-                            </m:oMathPara>
-                          </a14:m>
-                          <a:endParaRPr lang="en-US" sz="2400" dirty="0">
-                            <a:latin typeface="Garamond" panose="02020404030301010803" pitchFamily="18" charset="0"/>
-                          </a:endParaRPr>
-                        </a:p>
-                      </a:txBody>
-                      <a:tcPr/>
-                    </a:tc>
-                    <a:tc>
-                      <a:txBody>
-                        <a:bodyPr/>
-                        <a:lstStyle/>
-                        <a:p>
-                          <a:endParaRPr lang="en-US" sz="2400" dirty="0">
-                            <a:latin typeface="Garamond" panose="02020404030301010803" pitchFamily="18" charset="0"/>
-                          </a:endParaRPr>
-                        </a:p>
-                      </a:txBody>
-                      <a:tcPr/>
-                    </a:tc>
-                    <a:tc>
-                      <a:txBody>
-                        <a:bodyPr/>
-                        <a:lstStyle/>
-                        <a:p>
-                          <a:endParaRPr lang="en-US" sz="2400" dirty="0">
-                            <a:latin typeface="Garamond" panose="02020404030301010803" pitchFamily="18" charset="0"/>
-                          </a:endParaRPr>
-                        </a:p>
-                      </a:txBody>
-                      <a:tcPr/>
-                    </a:tc>
-                    <a:extLst>
-                      <a:ext uri="{0D108BD9-81ED-4DB2-BD59-A6C34878D82A}">
-                        <a16:rowId xmlns:a16="http://schemas.microsoft.com/office/drawing/2014/main" val="1417779945"/>
-                      </a:ext>
-                    </a:extLst>
-                  </a:tr>
-                  <a:tr h="494132">
-                    <a:tc>
-                      <a:txBody>
-                        <a:bodyPr/>
-                        <a:lstStyle/>
-                        <a:p>
-                          <a:r>
-                            <a:rPr lang="en-US" sz="2400" dirty="0">
-                              <a:latin typeface="Garamond" panose="02020404030301010803" pitchFamily="18" charset="0"/>
-                            </a:rPr>
-                            <a:t>Mass ratio q</a:t>
-                          </a:r>
-                        </a:p>
-                      </a:txBody>
-                      <a:tcPr/>
-                    </a:tc>
-                    <a:tc>
-                      <a:txBody>
-                        <a:bodyPr/>
-                        <a:lstStyle/>
-                        <a:p>
-                          <a:endParaRPr lang="en-US" sz="2400" dirty="0">
-                            <a:latin typeface="Garamond" panose="02020404030301010803" pitchFamily="18" charset="0"/>
-                          </a:endParaRPr>
-                        </a:p>
-                        <a:p>
-                          <a:endParaRPr lang="en-US" sz="2400" dirty="0">
-                            <a:latin typeface="Garamond" panose="02020404030301010803" pitchFamily="18" charset="0"/>
-                          </a:endParaRPr>
-                        </a:p>
-                      </a:txBody>
-                      <a:tcPr/>
-                    </a:tc>
-                    <a:tc>
-                      <a:txBody>
-                        <a:bodyPr/>
-                        <a:lstStyle/>
-                        <a:p>
-                          <a:endParaRPr lang="en-US" sz="2400" dirty="0">
-                            <a:latin typeface="Garamond" panose="02020404030301010803" pitchFamily="18" charset="0"/>
-                          </a:endParaRPr>
-                        </a:p>
-                      </a:txBody>
-                      <a:tcPr/>
-                    </a:tc>
-                    <a:tc>
-                      <a:txBody>
-                        <a:bodyPr/>
-                        <a:lstStyle/>
-                        <a:p>
-                          <a:endParaRPr lang="en-US" sz="2400" dirty="0">
-                            <a:latin typeface="Garamond" panose="02020404030301010803" pitchFamily="18" charset="0"/>
-                          </a:endParaRPr>
-                        </a:p>
-                      </a:txBody>
-                      <a:tcPr/>
-                    </a:tc>
-                    <a:tc>
-                      <a:txBody>
-                        <a:bodyPr/>
-                        <a:lstStyle/>
-                        <a:p>
-                          <a:endParaRPr lang="en-US" sz="2400" dirty="0">
-                            <a:latin typeface="Garamond" panose="02020404030301010803" pitchFamily="18" charset="0"/>
-                          </a:endParaRPr>
-                        </a:p>
-                      </a:txBody>
-                      <a:tcPr/>
-                    </a:tc>
-                    <a:tc>
-                      <a:txBody>
-                        <a:bodyPr/>
-                        <a:lstStyle/>
-                        <a:p>
-                          <a:endParaRPr lang="en-US" sz="2400" dirty="0">
-                            <a:latin typeface="Garamond" panose="02020404030301010803" pitchFamily="18" charset="0"/>
-                          </a:endParaRPr>
-                        </a:p>
-                      </a:txBody>
-                      <a:tcPr/>
-                    </a:tc>
-                    <a:extLst>
-                      <a:ext uri="{0D108BD9-81ED-4DB2-BD59-A6C34878D82A}">
-                        <a16:rowId xmlns:a16="http://schemas.microsoft.com/office/drawing/2014/main" val="2435110856"/>
-                      </a:ext>
-                    </a:extLst>
-                  </a:tr>
-                  <a:tr h="494132">
-                    <a:tc>
-                      <a:txBody>
-                        <a:bodyPr/>
-                        <a:lstStyle/>
-                        <a:p>
-                          <a:r>
-                            <a:rPr lang="en-US" sz="2400" dirty="0">
-                              <a:latin typeface="Garamond" panose="02020404030301010803" pitchFamily="18" charset="0"/>
-                            </a:rPr>
-                            <a:t>Orbital Period P</a:t>
-                          </a:r>
-                        </a:p>
-                      </a:txBody>
-                      <a:tcPr/>
-                    </a:tc>
-                    <a:tc>
-                      <a:txBody>
-                        <a:bodyPr/>
-                        <a:lstStyle/>
-                        <a:p>
-                          <a:endParaRPr lang="en-US" sz="2400" dirty="0">
-                            <a:latin typeface="Garamond" panose="02020404030301010803" pitchFamily="18" charset="0"/>
-                          </a:endParaRPr>
-                        </a:p>
-                      </a:txBody>
-                      <a:tcPr/>
-                    </a:tc>
-                    <a:tc>
-                      <a:txBody>
-                        <a:bodyPr/>
-                        <a:lstStyle/>
-                        <a:p>
-                          <a:endParaRPr lang="en-US" sz="2400" dirty="0">
-                            <a:latin typeface="Garamond" panose="02020404030301010803" pitchFamily="18" charset="0"/>
-                          </a:endParaRPr>
-                        </a:p>
-                      </a:txBody>
-                      <a:tcPr/>
-                    </a:tc>
-                    <a:tc>
-                      <a:txBody>
-                        <a:bodyPr/>
-                        <a:lstStyle/>
-                        <a:p>
-                          <a:endParaRPr lang="en-US" sz="2400" dirty="0">
-                            <a:latin typeface="Garamond" panose="02020404030301010803" pitchFamily="18" charset="0"/>
-                          </a:endParaRPr>
-                        </a:p>
-                      </a:txBody>
-                      <a:tcPr/>
-                    </a:tc>
-                    <a:tc>
-                      <a:txBody>
-                        <a:bodyPr/>
-                        <a:lstStyle/>
-                        <a:p>
-                          <a:endParaRPr lang="en-US" sz="2400" dirty="0">
-                            <a:latin typeface="Garamond" panose="02020404030301010803" pitchFamily="18" charset="0"/>
-                          </a:endParaRPr>
-                        </a:p>
-                      </a:txBody>
-                      <a:tcPr/>
-                    </a:tc>
-                    <a:tc>
-                      <a:txBody>
-                        <a:bodyPr/>
-                        <a:lstStyle/>
-                        <a:p>
-                          <a:endParaRPr lang="en-US" sz="2400" dirty="0">
-                            <a:latin typeface="Garamond" panose="02020404030301010803" pitchFamily="18" charset="0"/>
-                          </a:endParaRPr>
-                        </a:p>
-                      </a:txBody>
-                      <a:tcPr/>
-                    </a:tc>
-                    <a:extLst>
-                      <a:ext uri="{0D108BD9-81ED-4DB2-BD59-A6C34878D82A}">
-                        <a16:rowId xmlns:a16="http://schemas.microsoft.com/office/drawing/2014/main" val="2767985039"/>
-                      </a:ext>
-                    </a:extLst>
-                  </a:tr>
-                  <a:tr h="494132">
-                    <a:tc>
-                      <a:txBody>
-                        <a:bodyPr/>
-                        <a:lstStyle/>
-                        <a:p>
-                          <a:r>
-                            <a:rPr lang="en-US" sz="2400" dirty="0">
-                              <a:latin typeface="Garamond" panose="02020404030301010803" pitchFamily="18" charset="0"/>
-                            </a:rPr>
-                            <a:t>Semimajor axis a</a:t>
-                          </a:r>
-                        </a:p>
-                      </a:txBody>
-                      <a:tcPr/>
-                    </a:tc>
-                    <a:tc>
-                      <a:txBody>
-                        <a:bodyPr/>
-                        <a:lstStyle/>
-                        <a:p>
-                          <a:endParaRPr lang="en-US" sz="2400" dirty="0">
-                            <a:latin typeface="Garamond" panose="02020404030301010803" pitchFamily="18" charset="0"/>
-                          </a:endParaRPr>
-                        </a:p>
-                      </a:txBody>
-                      <a:tcPr/>
-                    </a:tc>
-                    <a:tc>
-                      <a:txBody>
-                        <a:bodyPr/>
-                        <a:lstStyle/>
-                        <a:p>
-                          <a:endParaRPr lang="en-US" sz="2400" dirty="0">
-                            <a:latin typeface="Garamond" panose="02020404030301010803" pitchFamily="18" charset="0"/>
-                          </a:endParaRPr>
-                        </a:p>
-                      </a:txBody>
-                      <a:tcPr/>
-                    </a:tc>
-                    <a:tc>
-                      <a:txBody>
-                        <a:bodyPr/>
-                        <a:lstStyle/>
-                        <a:p>
-                          <a:endParaRPr lang="en-US" sz="2400" dirty="0">
-                            <a:latin typeface="Garamond" panose="02020404030301010803" pitchFamily="18" charset="0"/>
-                          </a:endParaRPr>
-                        </a:p>
-                      </a:txBody>
-                      <a:tcPr/>
-                    </a:tc>
-                    <a:tc>
-                      <a:txBody>
-                        <a:bodyPr/>
-                        <a:lstStyle/>
-                        <a:p>
-                          <a:endParaRPr lang="en-US" sz="2400" dirty="0">
-                            <a:latin typeface="Garamond" panose="02020404030301010803" pitchFamily="18" charset="0"/>
-                          </a:endParaRPr>
-                        </a:p>
-                      </a:txBody>
-                      <a:tcPr/>
-                    </a:tc>
-                    <a:tc>
-                      <a:txBody>
-                        <a:bodyPr/>
-                        <a:lstStyle/>
-                        <a:p>
-                          <a:endParaRPr lang="en-US" sz="2400" dirty="0">
-                            <a:latin typeface="Garamond" panose="02020404030301010803" pitchFamily="18" charset="0"/>
-                          </a:endParaRPr>
-                        </a:p>
-                      </a:txBody>
-                      <a:tcPr/>
-                    </a:tc>
-                    <a:extLst>
-                      <a:ext uri="{0D108BD9-81ED-4DB2-BD59-A6C34878D82A}">
-                        <a16:rowId xmlns:a16="http://schemas.microsoft.com/office/drawing/2014/main" val="1942473870"/>
-                      </a:ext>
-                    </a:extLst>
-                  </a:tr>
-                  <a:tr h="494132">
-                    <a:tc>
-                      <a:txBody>
-                        <a:bodyPr/>
-                        <a:lstStyle/>
-                        <a:p>
-                          <a:r>
-                            <a:rPr lang="en-US" sz="2400" dirty="0">
-                              <a:latin typeface="Garamond" panose="02020404030301010803" pitchFamily="18" charset="0"/>
-                            </a:rPr>
-                            <a:t>Radius R </a:t>
-                          </a:r>
-                        </a:p>
-                      </a:txBody>
-                      <a:tcPr/>
-                    </a:tc>
-                    <a:tc>
-                      <a:txBody>
-                        <a:bodyPr/>
-                        <a:lstStyle/>
-                        <a:p>
-                          <a:endParaRPr lang="en-US" sz="2400" dirty="0">
-                            <a:latin typeface="Garamond" panose="02020404030301010803" pitchFamily="18" charset="0"/>
-                          </a:endParaRPr>
-                        </a:p>
-                      </a:txBody>
-                      <a:tcPr/>
-                    </a:tc>
-                    <a:tc>
-                      <a:txBody>
-                        <a:bodyPr/>
-                        <a:lstStyle/>
-                        <a:p>
-                          <a:endParaRPr lang="en-US" sz="2400" dirty="0">
-                            <a:latin typeface="Garamond" panose="02020404030301010803" pitchFamily="18" charset="0"/>
-                          </a:endParaRPr>
-                        </a:p>
-                      </a:txBody>
-                      <a:tcPr/>
-                    </a:tc>
-                    <a:tc>
-                      <a:txBody>
-                        <a:bodyPr/>
-                        <a:lstStyle/>
-                        <a:p>
-                          <a:endParaRPr lang="en-US" sz="2400" dirty="0">
-                            <a:latin typeface="Garamond" panose="02020404030301010803" pitchFamily="18" charset="0"/>
-                          </a:endParaRPr>
-                        </a:p>
-                      </a:txBody>
-                      <a:tcPr/>
-                    </a:tc>
-                    <a:tc>
-                      <a:txBody>
-                        <a:bodyPr/>
-                        <a:lstStyle/>
-                        <a:p>
-                          <a:endParaRPr lang="en-US" sz="2400" dirty="0">
-                            <a:latin typeface="Garamond" panose="02020404030301010803" pitchFamily="18" charset="0"/>
-                          </a:endParaRPr>
-                        </a:p>
-                      </a:txBody>
-                      <a:tcPr/>
-                    </a:tc>
-                    <a:tc>
-                      <a:txBody>
-                        <a:bodyPr/>
-                        <a:lstStyle/>
-                        <a:p>
-                          <a:endParaRPr lang="en-US" sz="2400" dirty="0">
-                            <a:latin typeface="Garamond" panose="02020404030301010803" pitchFamily="18" charset="0"/>
-                          </a:endParaRPr>
-                        </a:p>
-                      </a:txBody>
-                      <a:tcPr/>
-                    </a:tc>
-                    <a:extLst>
-                      <a:ext uri="{0D108BD9-81ED-4DB2-BD59-A6C34878D82A}">
-                        <a16:rowId xmlns:a16="http://schemas.microsoft.com/office/drawing/2014/main" val="3811881790"/>
-                      </a:ext>
-                    </a:extLst>
-                  </a:tr>
-                </a:tbl>
-              </a:graphicData>
-            </a:graphic>
-          </p:graphicFrame>
-        </mc:Choice>
-        <mc:Fallback>
-          <p:graphicFrame>
-            <p:nvGraphicFramePr>
-              <p:cNvPr id="2" name="Tabelle 1">
-                <a:extLst>
-                  <a:ext uri="{FF2B5EF4-FFF2-40B4-BE49-F238E27FC236}">
-                    <a16:creationId xmlns:a16="http://schemas.microsoft.com/office/drawing/2014/main" id="{676EC7A9-7BA9-3282-F812-BF1EB6A556C5}"/>
-                  </a:ext>
-                </a:extLst>
-              </p:cNvPr>
-              <p:cNvGraphicFramePr>
-                <a:graphicFrameLocks noGrp="1"/>
-              </p:cNvGraphicFramePr>
-              <p:nvPr>
-                <p:extLst>
-                  <p:ext uri="{D42A27DB-BD31-4B8C-83A1-F6EECF244321}">
-                    <p14:modId xmlns:p14="http://schemas.microsoft.com/office/powerpoint/2010/main" val="2319209304"/>
-                  </p:ext>
-                </p:extLst>
-              </p:nvPr>
-            </p:nvGraphicFramePr>
-            <p:xfrm>
-              <a:off x="312829" y="13598088"/>
-              <a:ext cx="11427239" cy="4280104"/>
-            </p:xfrm>
-            <a:graphic>
-              <a:graphicData uri="http://schemas.openxmlformats.org/drawingml/2006/table">
-                <a:tbl>
-                  <a:tblPr firstRow="1" bandRow="1">
-                    <a:tableStyleId>{5940675A-B579-460E-94D1-54222C63F5DA}</a:tableStyleId>
-                  </a:tblPr>
-                  <a:tblGrid>
-                    <a:gridCol w="1924950">
-                      <a:extLst>
-                        <a:ext uri="{9D8B030D-6E8A-4147-A177-3AD203B41FA5}">
-                          <a16:colId xmlns:a16="http://schemas.microsoft.com/office/drawing/2014/main" val="1204722445"/>
-                        </a:ext>
-                      </a:extLst>
-                    </a:gridCol>
-                    <a:gridCol w="1924950">
-                      <a:extLst>
-                        <a:ext uri="{9D8B030D-6E8A-4147-A177-3AD203B41FA5}">
-                          <a16:colId xmlns:a16="http://schemas.microsoft.com/office/drawing/2014/main" val="3703163242"/>
-                        </a:ext>
-                      </a:extLst>
-                    </a:gridCol>
-                    <a:gridCol w="1924950">
-                      <a:extLst>
-                        <a:ext uri="{9D8B030D-6E8A-4147-A177-3AD203B41FA5}">
-                          <a16:colId xmlns:a16="http://schemas.microsoft.com/office/drawing/2014/main" val="1561748901"/>
-                        </a:ext>
-                      </a:extLst>
-                    </a:gridCol>
-                    <a:gridCol w="1924950">
-                      <a:extLst>
-                        <a:ext uri="{9D8B030D-6E8A-4147-A177-3AD203B41FA5}">
-                          <a16:colId xmlns:a16="http://schemas.microsoft.com/office/drawing/2014/main" val="1538840913"/>
-                        </a:ext>
-                      </a:extLst>
-                    </a:gridCol>
-                    <a:gridCol w="1924950">
-                      <a:extLst>
-                        <a:ext uri="{9D8B030D-6E8A-4147-A177-3AD203B41FA5}">
-                          <a16:colId xmlns:a16="http://schemas.microsoft.com/office/drawing/2014/main" val="381055411"/>
-                        </a:ext>
-                      </a:extLst>
-                    </a:gridCol>
-                    <a:gridCol w="1802489">
-                      <a:extLst>
-                        <a:ext uri="{9D8B030D-6E8A-4147-A177-3AD203B41FA5}">
-                          <a16:colId xmlns:a16="http://schemas.microsoft.com/office/drawing/2014/main" val="1848283666"/>
-                        </a:ext>
-                      </a:extLst>
-                    </a:gridCol>
-                  </a:tblGrid>
-                  <a:tr h="822960">
-                    <a:tc>
-                      <a:txBody>
-                        <a:bodyPr/>
-                        <a:lstStyle/>
-                        <a:p>
-                          <a:endParaRPr lang="en-US" sz="2400" dirty="0">
-                            <a:latin typeface="Garamond" panose="02020404030301010803" pitchFamily="18" charset="0"/>
-                          </a:endParaRPr>
-                        </a:p>
-                      </a:txBody>
-                      <a:tcPr/>
-                    </a:tc>
-                    <a:tc>
-                      <a:txBody>
-                        <a:bodyPr/>
-                        <a:lstStyle/>
-                        <a:p>
-                          <a:r>
-                            <a:rPr lang="en-US" sz="2400" dirty="0">
-                              <a:latin typeface="Garamond" panose="02020404030301010803" pitchFamily="18" charset="0"/>
-                            </a:rPr>
-                            <a:t>Eccentricity e</a:t>
-                          </a:r>
-                        </a:p>
-                      </a:txBody>
-                      <a:tcPr/>
-                    </a:tc>
-                    <a:tc>
-                      <a:txBody>
-                        <a:bodyPr/>
-                        <a:lstStyle/>
-                        <a:p>
-                          <a:r>
-                            <a:rPr lang="en-US" sz="2400" dirty="0">
-                              <a:latin typeface="Garamond" panose="02020404030301010803" pitchFamily="18" charset="0"/>
-                            </a:rPr>
-                            <a:t>Mass ratio q</a:t>
-                          </a:r>
-                        </a:p>
-                      </a:txBody>
-                      <a:tcPr/>
-                    </a:tc>
-                    <a:tc>
-                      <a:txBody>
-                        <a:bodyPr/>
-                        <a:lstStyle/>
-                        <a:p>
-                          <a:r>
-                            <a:rPr lang="en-US" sz="2400" dirty="0">
-                              <a:latin typeface="Garamond" panose="02020404030301010803" pitchFamily="18" charset="0"/>
-                            </a:rPr>
-                            <a:t>Orbital Period P</a:t>
-                          </a:r>
-                        </a:p>
-                      </a:txBody>
-                      <a:tcPr/>
-                    </a:tc>
-                    <a:tc>
-                      <a:txBody>
-                        <a:bodyPr/>
-                        <a:lstStyle/>
-                        <a:p>
-                          <a:r>
-                            <a:rPr lang="en-US" sz="2400" dirty="0">
-                              <a:latin typeface="Garamond" panose="02020404030301010803" pitchFamily="18" charset="0"/>
-                            </a:rPr>
-                            <a:t>Semi-major axis a</a:t>
-                          </a:r>
-                        </a:p>
-                      </a:txBody>
-                      <a:tcPr/>
-                    </a:tc>
-                    <a:tc>
-                      <a:txBody>
-                        <a:bodyPr/>
-                        <a:lstStyle/>
-                        <a:p>
-                          <a:r>
-                            <a:rPr lang="en-US" sz="2400" dirty="0">
-                              <a:latin typeface="Garamond" panose="02020404030301010803" pitchFamily="18" charset="0"/>
-                            </a:rPr>
-                            <a:t>Radius ratio R</a:t>
-                          </a:r>
-                        </a:p>
-                      </a:txBody>
-                      <a:tcPr/>
-                    </a:tc>
-                    <a:extLst>
-                      <a:ext uri="{0D108BD9-81ED-4DB2-BD59-A6C34878D82A}">
-                        <a16:rowId xmlns:a16="http://schemas.microsoft.com/office/drawing/2014/main" val="1142826704"/>
-                      </a:ext>
-                    </a:extLst>
-                  </a:tr>
-                  <a:tr h="494132">
-                    <a:tc>
-                      <a:txBody>
-                        <a:bodyPr/>
-                        <a:lstStyle/>
-                        <a:p>
-                          <a:r>
-                            <a:rPr lang="en-US" sz="2400" dirty="0">
-                              <a:latin typeface="Garamond" panose="02020404030301010803" pitchFamily="18" charset="0"/>
-                            </a:rPr>
-                            <a:t>Eccentricity e</a:t>
-                          </a:r>
-                        </a:p>
-                      </a:txBody>
-                      <a:tcPr/>
-                    </a:tc>
-                    <a:tc>
-                      <a:txBody>
-                        <a:bodyPr/>
-                        <a:lstStyle/>
-                        <a:p>
-                          <a:endParaRPr lang="en-US" sz="2400" dirty="0">
-                            <a:latin typeface="Garamond" panose="02020404030301010803" pitchFamily="18" charset="0"/>
-                          </a:endParaRPr>
-                        </a:p>
-                      </a:txBody>
-                      <a:tcPr/>
-                    </a:tc>
-                    <a:tc>
-                      <a:txBody>
-                        <a:bodyPr/>
-                        <a:lstStyle/>
-                        <a:p>
-                          <a:endParaRPr lang="en-US" sz="2400" dirty="0">
-                            <a:latin typeface="Garamond" panose="02020404030301010803" pitchFamily="18" charset="0"/>
-                          </a:endParaRPr>
-                        </a:p>
-                      </a:txBody>
-                      <a:tcPr/>
-                    </a:tc>
-                    <a:tc>
-                      <a:txBody>
-                        <a:bodyPr/>
-                        <a:lstStyle/>
-                        <a:p>
-                          <a:endParaRPr lang="en-US"/>
-                        </a:p>
-                      </a:txBody>
-                      <a:tcPr>
-                        <a:blipFill>
-                          <a:blip r:embed="rId5"/>
-                          <a:stretch>
-                            <a:fillRect l="-301270" t="-175309" r="-194921" b="-622222"/>
-                          </a:stretch>
-                        </a:blipFill>
-                      </a:tcPr>
-                    </a:tc>
-                    <a:tc>
-                      <a:txBody>
-                        <a:bodyPr/>
-                        <a:lstStyle/>
-                        <a:p>
-                          <a:endParaRPr lang="en-US" sz="2400" dirty="0">
-                            <a:latin typeface="Garamond" panose="02020404030301010803" pitchFamily="18" charset="0"/>
-                          </a:endParaRPr>
-                        </a:p>
-                      </a:txBody>
-                      <a:tcPr/>
-                    </a:tc>
-                    <a:tc>
-                      <a:txBody>
-                        <a:bodyPr/>
-                        <a:lstStyle/>
-                        <a:p>
-                          <a:endParaRPr lang="en-US" sz="2400" dirty="0">
-                            <a:latin typeface="Garamond" panose="02020404030301010803" pitchFamily="18" charset="0"/>
-                          </a:endParaRPr>
-                        </a:p>
-                      </a:txBody>
-                      <a:tcPr/>
-                    </a:tc>
-                    <a:extLst>
-                      <a:ext uri="{0D108BD9-81ED-4DB2-BD59-A6C34878D82A}">
-                        <a16:rowId xmlns:a16="http://schemas.microsoft.com/office/drawing/2014/main" val="1417779945"/>
-                      </a:ext>
-                    </a:extLst>
-                  </a:tr>
-                  <a:tr h="822960">
-                    <a:tc>
-                      <a:txBody>
-                        <a:bodyPr/>
-                        <a:lstStyle/>
-                        <a:p>
-                          <a:r>
-                            <a:rPr lang="en-US" sz="2400" dirty="0">
-                              <a:latin typeface="Garamond" panose="02020404030301010803" pitchFamily="18" charset="0"/>
-                            </a:rPr>
-                            <a:t>Mass ratio q</a:t>
-                          </a:r>
-                        </a:p>
-                      </a:txBody>
-                      <a:tcPr/>
-                    </a:tc>
-                    <a:tc>
-                      <a:txBody>
-                        <a:bodyPr/>
-                        <a:lstStyle/>
-                        <a:p>
-                          <a:endParaRPr lang="en-US" sz="2400" dirty="0">
-                            <a:latin typeface="Garamond" panose="02020404030301010803" pitchFamily="18" charset="0"/>
-                          </a:endParaRPr>
-                        </a:p>
-                        <a:p>
-                          <a:endParaRPr lang="en-US" sz="2400" dirty="0">
-                            <a:latin typeface="Garamond" panose="02020404030301010803" pitchFamily="18" charset="0"/>
-                          </a:endParaRPr>
-                        </a:p>
-                      </a:txBody>
-                      <a:tcPr/>
-                    </a:tc>
-                    <a:tc>
-                      <a:txBody>
-                        <a:bodyPr/>
-                        <a:lstStyle/>
-                        <a:p>
-                          <a:endParaRPr lang="en-US" sz="2400" dirty="0">
-                            <a:latin typeface="Garamond" panose="02020404030301010803" pitchFamily="18" charset="0"/>
-                          </a:endParaRPr>
-                        </a:p>
-                      </a:txBody>
-                      <a:tcPr/>
-                    </a:tc>
-                    <a:tc>
-                      <a:txBody>
-                        <a:bodyPr/>
-                        <a:lstStyle/>
-                        <a:p>
-                          <a:endParaRPr lang="en-US" sz="2400" dirty="0">
-                            <a:latin typeface="Garamond" panose="02020404030301010803" pitchFamily="18" charset="0"/>
-                          </a:endParaRPr>
-                        </a:p>
-                      </a:txBody>
-                      <a:tcPr/>
-                    </a:tc>
-                    <a:tc>
-                      <a:txBody>
-                        <a:bodyPr/>
-                        <a:lstStyle/>
-                        <a:p>
-                          <a:endParaRPr lang="en-US" sz="2400" dirty="0">
-                            <a:latin typeface="Garamond" panose="02020404030301010803" pitchFamily="18" charset="0"/>
-                          </a:endParaRPr>
-                        </a:p>
-                      </a:txBody>
-                      <a:tcPr/>
-                    </a:tc>
-                    <a:tc>
-                      <a:txBody>
-                        <a:bodyPr/>
-                        <a:lstStyle/>
-                        <a:p>
-                          <a:endParaRPr lang="en-US" sz="2400" dirty="0">
-                            <a:latin typeface="Garamond" panose="02020404030301010803" pitchFamily="18" charset="0"/>
-                          </a:endParaRPr>
-                        </a:p>
-                      </a:txBody>
-                      <a:tcPr/>
-                    </a:tc>
-                    <a:extLst>
-                      <a:ext uri="{0D108BD9-81ED-4DB2-BD59-A6C34878D82A}">
-                        <a16:rowId xmlns:a16="http://schemas.microsoft.com/office/drawing/2014/main" val="2435110856"/>
-                      </a:ext>
-                    </a:extLst>
-                  </a:tr>
-                  <a:tr h="822960">
-                    <a:tc>
-                      <a:txBody>
-                        <a:bodyPr/>
-                        <a:lstStyle/>
-                        <a:p>
-                          <a:r>
-                            <a:rPr lang="en-US" sz="2400" dirty="0">
-                              <a:latin typeface="Garamond" panose="02020404030301010803" pitchFamily="18" charset="0"/>
-                            </a:rPr>
-                            <a:t>Orbital Period P</a:t>
-                          </a:r>
-                        </a:p>
-                      </a:txBody>
-                      <a:tcPr/>
-                    </a:tc>
-                    <a:tc>
-                      <a:txBody>
-                        <a:bodyPr/>
-                        <a:lstStyle/>
-                        <a:p>
-                          <a:endParaRPr lang="en-US" sz="2400" dirty="0">
-                            <a:latin typeface="Garamond" panose="02020404030301010803" pitchFamily="18" charset="0"/>
-                          </a:endParaRPr>
-                        </a:p>
-                      </a:txBody>
-                      <a:tcPr/>
-                    </a:tc>
-                    <a:tc>
-                      <a:txBody>
-                        <a:bodyPr/>
-                        <a:lstStyle/>
-                        <a:p>
-                          <a:endParaRPr lang="en-US" sz="2400" dirty="0">
-                            <a:latin typeface="Garamond" panose="02020404030301010803" pitchFamily="18" charset="0"/>
-                          </a:endParaRPr>
-                        </a:p>
-                      </a:txBody>
-                      <a:tcPr/>
-                    </a:tc>
-                    <a:tc>
-                      <a:txBody>
-                        <a:bodyPr/>
-                        <a:lstStyle/>
-                        <a:p>
-                          <a:endParaRPr lang="en-US" sz="2400" dirty="0">
-                            <a:latin typeface="Garamond" panose="02020404030301010803" pitchFamily="18" charset="0"/>
-                          </a:endParaRPr>
-                        </a:p>
-                      </a:txBody>
-                      <a:tcPr/>
-                    </a:tc>
-                    <a:tc>
-                      <a:txBody>
-                        <a:bodyPr/>
-                        <a:lstStyle/>
-                        <a:p>
-                          <a:endParaRPr lang="en-US" sz="2400" dirty="0">
-                            <a:latin typeface="Garamond" panose="02020404030301010803" pitchFamily="18" charset="0"/>
-                          </a:endParaRPr>
-                        </a:p>
-                      </a:txBody>
-                      <a:tcPr/>
-                    </a:tc>
-                    <a:tc>
-                      <a:txBody>
-                        <a:bodyPr/>
-                        <a:lstStyle/>
-                        <a:p>
-                          <a:endParaRPr lang="en-US" sz="2400" dirty="0">
-                            <a:latin typeface="Garamond" panose="02020404030301010803" pitchFamily="18" charset="0"/>
-                          </a:endParaRPr>
-                        </a:p>
-                      </a:txBody>
-                      <a:tcPr/>
-                    </a:tc>
-                    <a:extLst>
-                      <a:ext uri="{0D108BD9-81ED-4DB2-BD59-A6C34878D82A}">
-                        <a16:rowId xmlns:a16="http://schemas.microsoft.com/office/drawing/2014/main" val="2767985039"/>
-                      </a:ext>
-                    </a:extLst>
-                  </a:tr>
-                  <a:tr h="822960">
-                    <a:tc>
-                      <a:txBody>
-                        <a:bodyPr/>
-                        <a:lstStyle/>
-                        <a:p>
-                          <a:r>
-                            <a:rPr lang="en-US" sz="2400" dirty="0">
-                              <a:latin typeface="Garamond" panose="02020404030301010803" pitchFamily="18" charset="0"/>
-                            </a:rPr>
-                            <a:t>Semimajor axis a</a:t>
-                          </a:r>
-                        </a:p>
-                      </a:txBody>
-                      <a:tcPr/>
-                    </a:tc>
-                    <a:tc>
-                      <a:txBody>
-                        <a:bodyPr/>
-                        <a:lstStyle/>
-                        <a:p>
-                          <a:endParaRPr lang="en-US" sz="2400" dirty="0">
-                            <a:latin typeface="Garamond" panose="02020404030301010803" pitchFamily="18" charset="0"/>
-                          </a:endParaRPr>
-                        </a:p>
-                      </a:txBody>
-                      <a:tcPr/>
-                    </a:tc>
-                    <a:tc>
-                      <a:txBody>
-                        <a:bodyPr/>
-                        <a:lstStyle/>
-                        <a:p>
-                          <a:endParaRPr lang="en-US" sz="2400" dirty="0">
-                            <a:latin typeface="Garamond" panose="02020404030301010803" pitchFamily="18" charset="0"/>
-                          </a:endParaRPr>
-                        </a:p>
-                      </a:txBody>
-                      <a:tcPr/>
-                    </a:tc>
-                    <a:tc>
-                      <a:txBody>
-                        <a:bodyPr/>
-                        <a:lstStyle/>
-                        <a:p>
-                          <a:endParaRPr lang="en-US" sz="2400" dirty="0">
-                            <a:latin typeface="Garamond" panose="02020404030301010803" pitchFamily="18" charset="0"/>
-                          </a:endParaRPr>
-                        </a:p>
-                      </a:txBody>
-                      <a:tcPr/>
-                    </a:tc>
-                    <a:tc>
-                      <a:txBody>
-                        <a:bodyPr/>
-                        <a:lstStyle/>
-                        <a:p>
-                          <a:endParaRPr lang="en-US" sz="2400" dirty="0">
-                            <a:latin typeface="Garamond" panose="02020404030301010803" pitchFamily="18" charset="0"/>
-                          </a:endParaRPr>
-                        </a:p>
-                      </a:txBody>
-                      <a:tcPr/>
-                    </a:tc>
-                    <a:tc>
-                      <a:txBody>
-                        <a:bodyPr/>
-                        <a:lstStyle/>
-                        <a:p>
-                          <a:endParaRPr lang="en-US" sz="2400" dirty="0">
-                            <a:latin typeface="Garamond" panose="02020404030301010803" pitchFamily="18" charset="0"/>
-                          </a:endParaRPr>
-                        </a:p>
-                      </a:txBody>
-                      <a:tcPr/>
-                    </a:tc>
-                    <a:extLst>
-                      <a:ext uri="{0D108BD9-81ED-4DB2-BD59-A6C34878D82A}">
-                        <a16:rowId xmlns:a16="http://schemas.microsoft.com/office/drawing/2014/main" val="1942473870"/>
-                      </a:ext>
-                    </a:extLst>
-                  </a:tr>
-                  <a:tr h="494132">
-                    <a:tc>
-                      <a:txBody>
-                        <a:bodyPr/>
-                        <a:lstStyle/>
-                        <a:p>
-                          <a:r>
-                            <a:rPr lang="en-US" sz="2400" dirty="0">
-                              <a:latin typeface="Garamond" panose="02020404030301010803" pitchFamily="18" charset="0"/>
-                            </a:rPr>
-                            <a:t>Radius R </a:t>
-                          </a:r>
-                        </a:p>
-                      </a:txBody>
-                      <a:tcPr/>
-                    </a:tc>
-                    <a:tc>
-                      <a:txBody>
-                        <a:bodyPr/>
-                        <a:lstStyle/>
-                        <a:p>
-                          <a:endParaRPr lang="en-US" sz="2400" dirty="0">
-                            <a:latin typeface="Garamond" panose="02020404030301010803" pitchFamily="18" charset="0"/>
-                          </a:endParaRPr>
-                        </a:p>
-                      </a:txBody>
-                      <a:tcPr/>
-                    </a:tc>
-                    <a:tc>
-                      <a:txBody>
-                        <a:bodyPr/>
-                        <a:lstStyle/>
-                        <a:p>
-                          <a:endParaRPr lang="en-US" sz="2400" dirty="0">
-                            <a:latin typeface="Garamond" panose="02020404030301010803" pitchFamily="18" charset="0"/>
-                          </a:endParaRPr>
-                        </a:p>
-                      </a:txBody>
-                      <a:tcPr/>
-                    </a:tc>
-                    <a:tc>
-                      <a:txBody>
-                        <a:bodyPr/>
-                        <a:lstStyle/>
-                        <a:p>
-                          <a:endParaRPr lang="en-US" sz="2400" dirty="0">
-                            <a:latin typeface="Garamond" panose="02020404030301010803" pitchFamily="18" charset="0"/>
-                          </a:endParaRPr>
-                        </a:p>
-                      </a:txBody>
-                      <a:tcPr/>
-                    </a:tc>
-                    <a:tc>
-                      <a:txBody>
-                        <a:bodyPr/>
-                        <a:lstStyle/>
-                        <a:p>
-                          <a:endParaRPr lang="en-US" sz="2400" dirty="0">
-                            <a:latin typeface="Garamond" panose="02020404030301010803" pitchFamily="18" charset="0"/>
-                          </a:endParaRPr>
-                        </a:p>
-                      </a:txBody>
-                      <a:tcPr/>
-                    </a:tc>
-                    <a:tc>
-                      <a:txBody>
-                        <a:bodyPr/>
-                        <a:lstStyle/>
-                        <a:p>
-                          <a:endParaRPr lang="en-US" sz="2400" dirty="0">
-                            <a:latin typeface="Garamond" panose="02020404030301010803" pitchFamily="18" charset="0"/>
-                          </a:endParaRPr>
-                        </a:p>
-                      </a:txBody>
-                      <a:tcPr/>
-                    </a:tc>
-                    <a:extLst>
-                      <a:ext uri="{0D108BD9-81ED-4DB2-BD59-A6C34878D82A}">
-                        <a16:rowId xmlns:a16="http://schemas.microsoft.com/office/drawing/2014/main" val="3811881790"/>
-                      </a:ext>
-                    </a:extLst>
-                  </a:tr>
-                </a:tbl>
-              </a:graphicData>
-            </a:graphic>
-          </p:graphicFrame>
-        </mc:Fallback>
-      </mc:AlternateContent>
       <p:sp>
         <p:nvSpPr>
           <p:cNvPr id="6" name="Rechteck: abgerundete Ecken 5">
@@ -5589,7 +4382,7 @@
           <a:blip>
             <a:extLst>
               <a:ext uri="{96DAC541-7B7A-43D3-8B79-37D633B846F1}">
-                <asvg:svgBlip xmlns:asvg="http://schemas.microsoft.com/office/drawing/2016/SVG/main" r:embed="rId6"/>
+                <asvg:svgBlip xmlns:asvg="http://schemas.microsoft.com/office/drawing/2016/SVG/main" r:embed="rId5"/>
               </a:ext>
             </a:extLst>
           </a:blip>
@@ -5673,8 +4466,8 @@
         </p:nvSpPr>
         <p:spPr>
           <a:xfrm>
-            <a:off x="312829" y="13101877"/>
-            <a:ext cx="9818502" cy="461665"/>
+            <a:off x="295891" y="10783095"/>
+            <a:ext cx="7742600" cy="830997"/>
           </a:xfrm>
           <a:prstGeom prst="rect">
             <a:avLst/>
@@ -5778,7 +4571,7 @@
           <a:blip>
             <a:extLst>
               <a:ext uri="{96DAC541-7B7A-43D3-8B79-37D633B846F1}">
-                <asvg:svgBlip xmlns:asvg="http://schemas.microsoft.com/office/drawing/2016/SVG/main" r:embed="rId7"/>
+                <asvg:svgBlip xmlns:asvg="http://schemas.microsoft.com/office/drawing/2016/SVG/main" r:embed="rId6"/>
               </a:ext>
             </a:extLst>
           </a:blip>
@@ -5796,198 +4589,411 @@
           </a:prstGeom>
         </p:spPr>
       </p:pic>
-      <p:graphicFrame>
-        <p:nvGraphicFramePr>
-          <p:cNvPr id="16" name="Tabelle 15">
-            <a:extLst>
-              <a:ext uri="{FF2B5EF4-FFF2-40B4-BE49-F238E27FC236}">
-                <a16:creationId xmlns:a16="http://schemas.microsoft.com/office/drawing/2014/main" id="{94399FEF-B43E-87CD-14AE-705E86E62D60}"/>
-              </a:ext>
-            </a:extLst>
-          </p:cNvPr>
-          <p:cNvGraphicFramePr>
-            <a:graphicFrameLocks noGrp="1"/>
-          </p:cNvGraphicFramePr>
-          <p:nvPr>
-            <p:extLst>
-              <p:ext uri="{D42A27DB-BD31-4B8C-83A1-F6EECF244321}">
-                <p14:modId xmlns:p14="http://schemas.microsoft.com/office/powerpoint/2010/main" val="3148053890"/>
-              </p:ext>
-            </p:extLst>
-          </p:nvPr>
-        </p:nvGraphicFramePr>
-        <p:xfrm>
-          <a:off x="13547981" y="16326172"/>
-          <a:ext cx="7683486" cy="4592079"/>
-        </p:xfrm>
-        <a:graphic>
-          <a:graphicData uri="http://schemas.openxmlformats.org/drawingml/2006/table">
-            <a:tbl>
-              <a:tblPr firstRow="1" bandRow="1">
-                <a:tableStyleId>{5940675A-B579-460E-94D1-54222C63F5DA}</a:tableStyleId>
-              </a:tblPr>
-              <a:tblGrid>
-                <a:gridCol w="3841743">
-                  <a:extLst>
-                    <a:ext uri="{9D8B030D-6E8A-4147-A177-3AD203B41FA5}">
-                      <a16:colId xmlns:a16="http://schemas.microsoft.com/office/drawing/2014/main" val="1884549708"/>
-                    </a:ext>
-                  </a:extLst>
-                </a:gridCol>
-                <a:gridCol w="3841743">
-                  <a:extLst>
-                    <a:ext uri="{9D8B030D-6E8A-4147-A177-3AD203B41FA5}">
-                      <a16:colId xmlns:a16="http://schemas.microsoft.com/office/drawing/2014/main" val="3529507465"/>
-                    </a:ext>
-                  </a:extLst>
-                </a:gridCol>
-              </a:tblGrid>
-              <a:tr h="4592079">
-                <a:tc>
-                  <a:txBody>
-                    <a:bodyPr/>
-                    <a:lstStyle/>
-                    <a:p>
-                      <a:pPr algn="ctr"/>
-                      <a:r>
-                        <a:rPr lang="en-US" sz="2400" b="1" i="0" dirty="0">
-                          <a:latin typeface="Garamond" panose="02020404030301010803" pitchFamily="18" charset="0"/>
-                        </a:rPr>
-                        <a:t>SB9</a:t>
-                      </a:r>
-                    </a:p>
-                    <a:p>
-                      <a:pPr algn="just">
-                        <a:spcAft>
-                          <a:spcPts val="1125"/>
-                        </a:spcAft>
-                        <a:buNone/>
-                      </a:pPr>
-                      <a:r>
-                        <a:rPr lang="en-US" sz="2400" dirty="0">
-                          <a:latin typeface="Garamond" panose="02020404030301010803" pitchFamily="18" charset="0"/>
-                        </a:rPr>
-                        <a:t>We find …. Biased towards inclination of 90° </a:t>
-                      </a:r>
-                      <a:r>
-                        <a:rPr lang="en-US" sz="2400" dirty="0" err="1">
-                          <a:latin typeface="Garamond" panose="02020404030301010803" pitchFamily="18" charset="0"/>
-                        </a:rPr>
-                        <a:t>balbalbal</a:t>
-                      </a:r>
-                      <a:endParaRPr lang="en-US" sz="2400" dirty="0">
-                        <a:latin typeface="Garamond" panose="02020404030301010803" pitchFamily="18" charset="0"/>
-                      </a:endParaRPr>
-                    </a:p>
-                  </a:txBody>
-                  <a:tcPr>
-                    <a:lnL w="12700" cmpd="sng">
-                      <a:noFill/>
-                    </a:lnL>
-                    <a:lnR w="12700" cap="flat" cmpd="sng" algn="ctr">
-                      <a:solidFill>
-                        <a:schemeClr val="tx1"/>
-                      </a:solidFill>
-                      <a:prstDash val="solid"/>
-                      <a:round/>
-                      <a:headEnd type="none" w="med" len="med"/>
-                      <a:tailEnd type="none" w="med" len="med"/>
-                    </a:lnR>
-                    <a:lnT w="12700" cmpd="sng">
-                      <a:noFill/>
-                    </a:lnT>
-                    <a:lnB w="12700" cap="flat" cmpd="sng" algn="ctr">
-                      <a:noFill/>
-                      <a:prstDash val="solid"/>
-                      <a:round/>
-                      <a:headEnd type="none" w="med" len="med"/>
-                      <a:tailEnd type="none" w="med" len="med"/>
-                    </a:lnB>
-                  </a:tcPr>
-                </a:tc>
-                <a:tc>
-                  <a:txBody>
-                    <a:bodyPr/>
-                    <a:lstStyle/>
-                    <a:p>
-                      <a:pPr algn="ctr"/>
-                      <a:r>
-                        <a:rPr lang="en-US" sz="2400" b="1" dirty="0">
-                          <a:latin typeface="Garamond" panose="02020404030301010803" pitchFamily="18" charset="0"/>
-                        </a:rPr>
-                        <a:t>ORB6</a:t>
-                      </a:r>
-                    </a:p>
-                    <a:p>
-                      <a:pPr algn="l"/>
-                      <a:r>
-                        <a:rPr lang="en-US" sz="2400" b="0" dirty="0">
-                          <a:latin typeface="Garamond" panose="02020404030301010803" pitchFamily="18" charset="0"/>
-                        </a:rPr>
-                        <a:t>Biased towards shorter periods </a:t>
-                      </a:r>
-                      <a:r>
-                        <a:rPr lang="en-US" sz="2400" b="0" dirty="0" err="1">
-                          <a:latin typeface="Garamond" panose="02020404030301010803" pitchFamily="18" charset="0"/>
-                        </a:rPr>
-                        <a:t>blabalbla</a:t>
-                      </a:r>
-                      <a:endParaRPr lang="en-US" sz="2400" b="0" dirty="0">
-                        <a:latin typeface="Garamond" panose="02020404030301010803" pitchFamily="18" charset="0"/>
-                      </a:endParaRPr>
-                    </a:p>
-                    <a:p>
-                      <a:pPr algn="l"/>
-                      <a:r>
-                        <a:rPr lang="en-US" sz="2400" b="0" i="0" dirty="0">
-                          <a:solidFill>
-                            <a:srgbClr val="2A2A2A"/>
-                          </a:solidFill>
-                          <a:effectLst/>
-                          <a:latin typeface="Merriweather" panose="00000500000000000000" pitchFamily="2" charset="0"/>
-                        </a:rPr>
-                        <a:t>f visual orbits is strongly biased against large eccentricities.</a:t>
-                      </a:r>
-                      <a:endParaRPr lang="en-US" sz="2400" b="0" dirty="0">
-                        <a:latin typeface="Garamond" panose="02020404030301010803" pitchFamily="18" charset="0"/>
-                      </a:endParaRPr>
-                    </a:p>
-                  </a:txBody>
-                  <a:tcPr>
-                    <a:lnL w="12700" cap="flat" cmpd="sng" algn="ctr">
-                      <a:solidFill>
-                        <a:schemeClr val="tx1"/>
-                      </a:solidFill>
-                      <a:prstDash val="solid"/>
-                      <a:round/>
-                      <a:headEnd type="none" w="med" len="med"/>
-                      <a:tailEnd type="none" w="med" len="med"/>
-                    </a:lnL>
-                    <a:lnR w="12700" cmpd="sng">
-                      <a:noFill/>
-                    </a:lnR>
-                    <a:lnT w="12700" cmpd="sng">
-                      <a:noFill/>
-                    </a:lnT>
-                    <a:lnB w="12700" cap="flat" cmpd="sng" algn="ctr">
-                      <a:noFill/>
-                      <a:prstDash val="solid"/>
-                      <a:round/>
-                      <a:headEnd type="none" w="med" len="med"/>
-                      <a:tailEnd type="none" w="med" len="med"/>
-                    </a:lnB>
-                  </a:tcPr>
-                </a:tc>
+      <mc:AlternateContent xmlns:mc="http://schemas.openxmlformats.org/markup-compatibility/2006">
+        <mc:Choice xmlns:a14="http://schemas.microsoft.com/office/drawing/2010/main" Requires="a14">
+          <p:graphicFrame>
+            <p:nvGraphicFramePr>
+              <p:cNvPr id="16" name="Tabelle 15">
                 <a:extLst>
-                  <a:ext uri="{0D108BD9-81ED-4DB2-BD59-A6C34878D82A}">
-                    <a16:rowId xmlns:a16="http://schemas.microsoft.com/office/drawing/2014/main" val="3166390322"/>
+                  <a:ext uri="{FF2B5EF4-FFF2-40B4-BE49-F238E27FC236}">
+                    <a16:creationId xmlns:a16="http://schemas.microsoft.com/office/drawing/2014/main" id="{94399FEF-B43E-87CD-14AE-705E86E62D60}"/>
                   </a:ext>
                 </a:extLst>
-              </a:tr>
-            </a:tbl>
-          </a:graphicData>
-        </a:graphic>
-      </p:graphicFrame>
+              </p:cNvPr>
+              <p:cNvGraphicFramePr>
+                <a:graphicFrameLocks noGrp="1"/>
+              </p:cNvGraphicFramePr>
+              <p:nvPr>
+                <p:extLst>
+                  <p:ext uri="{D42A27DB-BD31-4B8C-83A1-F6EECF244321}">
+                    <p14:modId xmlns:p14="http://schemas.microsoft.com/office/powerpoint/2010/main" val="2611105247"/>
+                  </p:ext>
+                </p:extLst>
+              </p:nvPr>
+            </p:nvGraphicFramePr>
+            <p:xfrm>
+              <a:off x="13547981" y="16326172"/>
+              <a:ext cx="7683486" cy="8540603"/>
+            </p:xfrm>
+            <a:graphic>
+              <a:graphicData uri="http://schemas.openxmlformats.org/drawingml/2006/table">
+                <a:tbl>
+                  <a:tblPr firstRow="1" bandRow="1">
+                    <a:tableStyleId>{5940675A-B579-460E-94D1-54222C63F5DA}</a:tableStyleId>
+                  </a:tblPr>
+                  <a:tblGrid>
+                    <a:gridCol w="3841743">
+                      <a:extLst>
+                        <a:ext uri="{9D8B030D-6E8A-4147-A177-3AD203B41FA5}">
+                          <a16:colId xmlns:a16="http://schemas.microsoft.com/office/drawing/2014/main" val="1884549708"/>
+                        </a:ext>
+                      </a:extLst>
+                    </a:gridCol>
+                    <a:gridCol w="3841743">
+                      <a:extLst>
+                        <a:ext uri="{9D8B030D-6E8A-4147-A177-3AD203B41FA5}">
+                          <a16:colId xmlns:a16="http://schemas.microsoft.com/office/drawing/2014/main" val="3529507465"/>
+                        </a:ext>
+                      </a:extLst>
+                    </a:gridCol>
+                  </a:tblGrid>
+                  <a:tr h="8540603">
+                    <a:tc>
+                      <a:txBody>
+                        <a:bodyPr/>
+                        <a:lstStyle/>
+                        <a:p>
+                          <a:pPr algn="ctr"/>
+                          <a:r>
+                            <a:rPr lang="en-US" sz="2400" b="1" i="0" dirty="0">
+                              <a:latin typeface="Garamond" panose="02020404030301010803" pitchFamily="18" charset="0"/>
+                            </a:rPr>
+                            <a:t>SB9</a:t>
+                          </a:r>
+                        </a:p>
+                        <a:p>
+                          <a:pPr algn="just">
+                            <a:spcAft>
+                              <a:spcPts val="1125"/>
+                            </a:spcAft>
+                            <a:buNone/>
+                          </a:pPr>
+                          <a:r>
+                            <a:rPr lang="en-US" sz="2400" dirty="0">
+                              <a:latin typeface="Garamond" panose="02020404030301010803" pitchFamily="18" charset="0"/>
+                            </a:rPr>
+                            <a:t>We find that SB9 is biased…</a:t>
+                          </a:r>
+                        </a:p>
+                        <a:p>
+                          <a:pPr algn="just">
+                            <a:spcAft>
+                              <a:spcPts val="1125"/>
+                            </a:spcAft>
+                            <a:buNone/>
+                          </a:pPr>
+                          <a:r>
+                            <a:rPr lang="en-US" sz="2400" dirty="0">
+                              <a:latin typeface="Garamond" panose="02020404030301010803" pitchFamily="18" charset="0"/>
+                            </a:rPr>
+                            <a:t>…towards lower eccentricities, with a very strong preference for </a:t>
+                          </a:r>
+                          <a14:m>
+                            <m:oMath xmlns:m="http://schemas.openxmlformats.org/officeDocument/2006/math">
+                              <m:r>
+                                <a:rPr lang="en-US" sz="2400" b="0" i="1" smtClean="0">
+                                  <a:latin typeface="Cambria Math" panose="02040503050406030204" pitchFamily="18" charset="0"/>
+                                </a:rPr>
+                                <m:t>𝑒</m:t>
+                              </m:r>
+                              <m:r>
+                                <a:rPr lang="en-US" sz="2400" b="0" i="1" smtClean="0">
+                                  <a:latin typeface="Cambria Math" panose="02040503050406030204" pitchFamily="18" charset="0"/>
+                                </a:rPr>
+                                <m:t>=0</m:t>
+                              </m:r>
+                            </m:oMath>
+                          </a14:m>
+                          <a:r>
+                            <a:rPr lang="en-US" sz="2400" dirty="0">
+                              <a:latin typeface="Garamond" panose="02020404030301010803" pitchFamily="18" charset="0"/>
+                            </a:rPr>
+                            <a:t>. </a:t>
+                          </a:r>
+                        </a:p>
+                        <a:p>
+                          <a:pPr algn="just">
+                            <a:spcAft>
+                              <a:spcPts val="1125"/>
+                            </a:spcAft>
+                            <a:buNone/>
+                          </a:pPr>
+                          <a:endParaRPr lang="en-US" sz="2400" dirty="0">
+                            <a:latin typeface="Garamond" panose="02020404030301010803" pitchFamily="18" charset="0"/>
+                          </a:endParaRPr>
+                        </a:p>
+                        <a:p>
+                          <a:pPr algn="just">
+                            <a:spcAft>
+                              <a:spcPts val="1125"/>
+                            </a:spcAft>
+                            <a:buNone/>
+                          </a:pPr>
+                          <a:r>
+                            <a:rPr lang="en-US" sz="2400" dirty="0">
+                              <a:latin typeface="Garamond" panose="02020404030301010803" pitchFamily="18" charset="0"/>
+                            </a:rPr>
+                            <a:t> Biased towards inclination of 90°</a:t>
+                          </a:r>
+                        </a:p>
+                      </a:txBody>
+                      <a:tcPr>
+                        <a:lnL w="12700" cmpd="sng">
+                          <a:noFill/>
+                        </a:lnL>
+                        <a:lnR w="12700" cap="flat" cmpd="sng" algn="ctr">
+                          <a:solidFill>
+                            <a:schemeClr val="tx1"/>
+                          </a:solidFill>
+                          <a:prstDash val="solid"/>
+                          <a:round/>
+                          <a:headEnd type="none" w="med" len="med"/>
+                          <a:tailEnd type="none" w="med" len="med"/>
+                        </a:lnR>
+                        <a:lnT w="12700" cmpd="sng">
+                          <a:noFill/>
+                        </a:lnT>
+                        <a:lnB w="12700" cap="flat" cmpd="sng" algn="ctr">
+                          <a:noFill/>
+                          <a:prstDash val="solid"/>
+                          <a:round/>
+                          <a:headEnd type="none" w="med" len="med"/>
+                          <a:tailEnd type="none" w="med" len="med"/>
+                        </a:lnB>
+                      </a:tcPr>
+                    </a:tc>
+                    <a:tc>
+                      <a:txBody>
+                        <a:bodyPr/>
+                        <a:lstStyle/>
+                        <a:p>
+                          <a:pPr algn="ctr"/>
+                          <a:r>
+                            <a:rPr lang="en-US" sz="2400" b="1" dirty="0">
+                              <a:latin typeface="Garamond" panose="02020404030301010803" pitchFamily="18" charset="0"/>
+                            </a:rPr>
+                            <a:t>ORB6</a:t>
+                          </a:r>
+                        </a:p>
+                        <a:p>
+                          <a:pPr algn="l"/>
+                          <a:r>
+                            <a:rPr lang="en-US" sz="2400" b="0" dirty="0">
+                              <a:latin typeface="Garamond" panose="02020404030301010803" pitchFamily="18" charset="0"/>
+                            </a:rPr>
+                            <a:t>We find that ORB6 is biased…</a:t>
+                          </a:r>
+                        </a:p>
+                        <a:p>
+                          <a:pPr algn="l"/>
+                          <a:r>
+                            <a:rPr lang="en-US" sz="2400" b="0" dirty="0">
+                              <a:latin typeface="Garamond" panose="02020404030301010803" pitchFamily="18" charset="0"/>
+                            </a:rPr>
+                            <a:t>…towards lower eccentricities, between 0 and 0.5.. There is only a slight preference for circular orbits. </a:t>
+                          </a:r>
+                        </a:p>
+                        <a:p>
+                          <a:pPr algn="l"/>
+                          <a:r>
+                            <a:rPr lang="en-US" sz="2400" b="0" dirty="0">
+                              <a:latin typeface="Garamond" panose="02020404030301010803" pitchFamily="18" charset="0"/>
+                            </a:rPr>
+                            <a:t>Biased towards shorter periods</a:t>
+                          </a:r>
+                        </a:p>
+                      </a:txBody>
+                      <a:tcPr>
+                        <a:lnL w="12700" cap="flat" cmpd="sng" algn="ctr">
+                          <a:solidFill>
+                            <a:schemeClr val="tx1"/>
+                          </a:solidFill>
+                          <a:prstDash val="solid"/>
+                          <a:round/>
+                          <a:headEnd type="none" w="med" len="med"/>
+                          <a:tailEnd type="none" w="med" len="med"/>
+                        </a:lnL>
+                        <a:lnR w="12700" cmpd="sng">
+                          <a:noFill/>
+                        </a:lnR>
+                        <a:lnT w="12700" cmpd="sng">
+                          <a:noFill/>
+                        </a:lnT>
+                        <a:lnB w="12700" cap="flat" cmpd="sng" algn="ctr">
+                          <a:noFill/>
+                          <a:prstDash val="solid"/>
+                          <a:round/>
+                          <a:headEnd type="none" w="med" len="med"/>
+                          <a:tailEnd type="none" w="med" len="med"/>
+                        </a:lnB>
+                      </a:tcPr>
+                    </a:tc>
+                    <a:extLst>
+                      <a:ext uri="{0D108BD9-81ED-4DB2-BD59-A6C34878D82A}">
+                        <a16:rowId xmlns:a16="http://schemas.microsoft.com/office/drawing/2014/main" val="3166390322"/>
+                      </a:ext>
+                    </a:extLst>
+                  </a:tr>
+                </a:tbl>
+              </a:graphicData>
+            </a:graphic>
+          </p:graphicFrame>
+        </mc:Choice>
+        <mc:Fallback>
+          <p:graphicFrame>
+            <p:nvGraphicFramePr>
+              <p:cNvPr id="16" name="Tabelle 15">
+                <a:extLst>
+                  <a:ext uri="{FF2B5EF4-FFF2-40B4-BE49-F238E27FC236}">
+                    <a16:creationId xmlns:a16="http://schemas.microsoft.com/office/drawing/2014/main" id="{94399FEF-B43E-87CD-14AE-705E86E62D60}"/>
+                  </a:ext>
+                </a:extLst>
+              </p:cNvPr>
+              <p:cNvGraphicFramePr>
+                <a:graphicFrameLocks noGrp="1"/>
+              </p:cNvGraphicFramePr>
+              <p:nvPr>
+                <p:extLst>
+                  <p:ext uri="{D42A27DB-BD31-4B8C-83A1-F6EECF244321}">
+                    <p14:modId xmlns:p14="http://schemas.microsoft.com/office/powerpoint/2010/main" val="2611105247"/>
+                  </p:ext>
+                </p:extLst>
+              </p:nvPr>
+            </p:nvGraphicFramePr>
+            <p:xfrm>
+              <a:off x="13547981" y="16326172"/>
+              <a:ext cx="7683486" cy="8540603"/>
+            </p:xfrm>
+            <a:graphic>
+              <a:graphicData uri="http://schemas.openxmlformats.org/drawingml/2006/table">
+                <a:tbl>
+                  <a:tblPr firstRow="1" bandRow="1">
+                    <a:tableStyleId>{5940675A-B579-460E-94D1-54222C63F5DA}</a:tableStyleId>
+                  </a:tblPr>
+                  <a:tblGrid>
+                    <a:gridCol w="3841743">
+                      <a:extLst>
+                        <a:ext uri="{9D8B030D-6E8A-4147-A177-3AD203B41FA5}">
+                          <a16:colId xmlns:a16="http://schemas.microsoft.com/office/drawing/2014/main" val="1884549708"/>
+                        </a:ext>
+                      </a:extLst>
+                    </a:gridCol>
+                    <a:gridCol w="3841743">
+                      <a:extLst>
+                        <a:ext uri="{9D8B030D-6E8A-4147-A177-3AD203B41FA5}">
+                          <a16:colId xmlns:a16="http://schemas.microsoft.com/office/drawing/2014/main" val="3529507465"/>
+                        </a:ext>
+                      </a:extLst>
+                    </a:gridCol>
+                  </a:tblGrid>
+                  <a:tr h="8540603">
+                    <a:tc>
+                      <a:txBody>
+                        <a:bodyPr/>
+                        <a:lstStyle/>
+                        <a:p>
+                          <a:endParaRPr lang="en-US"/>
+                        </a:p>
+                      </a:txBody>
+                      <a:tcPr>
+                        <a:lnL w="12700" cmpd="sng">
+                          <a:noFill/>
+                        </a:lnL>
+                        <a:lnR w="12700" cap="flat" cmpd="sng" algn="ctr">
+                          <a:solidFill>
+                            <a:schemeClr val="tx1"/>
+                          </a:solidFill>
+                          <a:prstDash val="solid"/>
+                          <a:round/>
+                          <a:headEnd type="none" w="med" len="med"/>
+                          <a:tailEnd type="none" w="med" len="med"/>
+                        </a:lnR>
+                        <a:lnT w="12700" cmpd="sng">
+                          <a:noFill/>
+                        </a:lnT>
+                        <a:lnB w="12700" cap="flat" cmpd="sng" algn="ctr">
+                          <a:noFill/>
+                          <a:prstDash val="solid"/>
+                          <a:round/>
+                          <a:headEnd type="none" w="med" len="med"/>
+                          <a:tailEnd type="none" w="med" len="med"/>
+                        </a:lnB>
+                        <a:blipFill>
+                          <a:blip r:embed="rId7"/>
+                          <a:stretch>
+                            <a:fillRect t="-571" r="-99842" b="-71"/>
+                          </a:stretch>
+                        </a:blipFill>
+                      </a:tcPr>
+                    </a:tc>
+                    <a:tc>
+                      <a:txBody>
+                        <a:bodyPr/>
+                        <a:lstStyle/>
+                        <a:p>
+                          <a:pPr algn="ctr"/>
+                          <a:r>
+                            <a:rPr lang="en-US" sz="2400" b="1" dirty="0">
+                              <a:latin typeface="Garamond" panose="02020404030301010803" pitchFamily="18" charset="0"/>
+                            </a:rPr>
+                            <a:t>ORB6</a:t>
+                          </a:r>
+                        </a:p>
+                        <a:p>
+                          <a:pPr algn="l"/>
+                          <a:r>
+                            <a:rPr lang="en-US" sz="2400" b="0" dirty="0">
+                              <a:latin typeface="Garamond" panose="02020404030301010803" pitchFamily="18" charset="0"/>
+                            </a:rPr>
+                            <a:t>We find that ORB6 is biased…</a:t>
+                          </a:r>
+                        </a:p>
+                        <a:p>
+                          <a:pPr algn="l"/>
+                          <a:r>
+                            <a:rPr lang="en-US" sz="2400" b="0" dirty="0">
+                              <a:latin typeface="Garamond" panose="02020404030301010803" pitchFamily="18" charset="0"/>
+                            </a:rPr>
+                            <a:t>…towards lower eccentricities, between 0 and 0.5.. There is only a slight preference for circular orbits. </a:t>
+                          </a:r>
+                        </a:p>
+                        <a:p>
+                          <a:pPr algn="l"/>
+                          <a:r>
+                            <a:rPr lang="en-US" sz="2400" b="0" dirty="0">
+                              <a:latin typeface="Garamond" panose="02020404030301010803" pitchFamily="18" charset="0"/>
+                            </a:rPr>
+                            <a:t>Biased towards shorter periods</a:t>
+                          </a:r>
+                        </a:p>
+                      </a:txBody>
+                      <a:tcPr>
+                        <a:lnL w="12700" cap="flat" cmpd="sng" algn="ctr">
+                          <a:solidFill>
+                            <a:schemeClr val="tx1"/>
+                          </a:solidFill>
+                          <a:prstDash val="solid"/>
+                          <a:round/>
+                          <a:headEnd type="none" w="med" len="med"/>
+                          <a:tailEnd type="none" w="med" len="med"/>
+                        </a:lnL>
+                        <a:lnR w="12700" cmpd="sng">
+                          <a:noFill/>
+                        </a:lnR>
+                        <a:lnT w="12700" cmpd="sng">
+                          <a:noFill/>
+                        </a:lnT>
+                        <a:lnB w="12700" cap="flat" cmpd="sng" algn="ctr">
+                          <a:noFill/>
+                          <a:prstDash val="solid"/>
+                          <a:round/>
+                          <a:headEnd type="none" w="med" len="med"/>
+                          <a:tailEnd type="none" w="med" len="med"/>
+                        </a:lnB>
+                      </a:tcPr>
+                    </a:tc>
+                    <a:extLst>
+                      <a:ext uri="{0D108BD9-81ED-4DB2-BD59-A6C34878D82A}">
+                        <a16:rowId xmlns:a16="http://schemas.microsoft.com/office/drawing/2014/main" val="3166390322"/>
+                      </a:ext>
+                    </a:extLst>
+                  </a:tr>
+                </a:tbl>
+              </a:graphicData>
+            </a:graphic>
+          </p:graphicFrame>
+        </mc:Fallback>
+      </mc:AlternateContent>
       <p:pic>
         <p:nvPicPr>
           <p:cNvPr id="20" name="Grafik 19">
@@ -6040,8 +5046,8 @@
         </p:nvSpPr>
         <p:spPr>
           <a:xfrm>
-            <a:off x="218459" y="18139506"/>
-            <a:ext cx="9746459" cy="461665"/>
+            <a:off x="8373978" y="10931499"/>
+            <a:ext cx="4061707" cy="830997"/>
           </a:xfrm>
           <a:prstGeom prst="rect">
             <a:avLst/>
@@ -6117,6 +5123,1068 @@
               </a:rPr>
               <a:t>Note that from the detection method alone we can already infer some biases.</a:t>
             </a:r>
+          </a:p>
+        </p:txBody>
+      </p:sp>
+      <mc:AlternateContent xmlns:mc="http://schemas.openxmlformats.org/markup-compatibility/2006">
+        <mc:Choice xmlns:a14="http://schemas.microsoft.com/office/drawing/2010/main" Requires="a14">
+          <p:graphicFrame>
+            <p:nvGraphicFramePr>
+              <p:cNvPr id="3" name="Tabelle 2">
+                <a:extLst>
+                  <a:ext uri="{FF2B5EF4-FFF2-40B4-BE49-F238E27FC236}">
+                    <a16:creationId xmlns:a16="http://schemas.microsoft.com/office/drawing/2014/main" id="{94A2B041-0A3D-4469-7F39-F62F5BC2501A}"/>
+                  </a:ext>
+                </a:extLst>
+              </p:cNvPr>
+              <p:cNvGraphicFramePr>
+                <a:graphicFrameLocks noGrp="1"/>
+              </p:cNvGraphicFramePr>
+              <p:nvPr>
+                <p:extLst>
+                  <p:ext uri="{D42A27DB-BD31-4B8C-83A1-F6EECF244321}">
+                    <p14:modId xmlns:p14="http://schemas.microsoft.com/office/powerpoint/2010/main" val="3485859075"/>
+                  </p:ext>
+                </p:extLst>
+              </p:nvPr>
+            </p:nvGraphicFramePr>
+            <p:xfrm>
+              <a:off x="274119" y="11791702"/>
+              <a:ext cx="7845519" cy="3559048"/>
+            </p:xfrm>
+            <a:graphic>
+              <a:graphicData uri="http://schemas.openxmlformats.org/drawingml/2006/table">
+                <a:tbl>
+                  <a:tblPr firstRow="1" bandRow="1">
+                    <a:tableStyleId>{2D5ABB26-0587-4C30-8999-92F81FD0307C}</a:tableStyleId>
+                  </a:tblPr>
+                  <a:tblGrid>
+                    <a:gridCol w="2444885">
+                      <a:extLst>
+                        <a:ext uri="{9D8B030D-6E8A-4147-A177-3AD203B41FA5}">
+                          <a16:colId xmlns:a16="http://schemas.microsoft.com/office/drawing/2014/main" val="1884549708"/>
+                        </a:ext>
+                      </a:extLst>
+                    </a:gridCol>
+                    <a:gridCol w="5400634">
+                      <a:extLst>
+                        <a:ext uri="{9D8B030D-6E8A-4147-A177-3AD203B41FA5}">
+                          <a16:colId xmlns:a16="http://schemas.microsoft.com/office/drawing/2014/main" val="3529507465"/>
+                        </a:ext>
+                      </a:extLst>
+                    </a:gridCol>
+                  </a:tblGrid>
+                  <a:tr h="443536">
+                    <a:tc>
+                      <a:txBody>
+                        <a:bodyPr/>
+                        <a:lstStyle/>
+                        <a:p>
+                          <a:pPr algn="ctr"/>
+                          <a:r>
+                            <a:rPr lang="en-US" sz="2400" b="1" dirty="0"/>
+                            <a:t>Parameter</a:t>
+                          </a:r>
+                          <a:endParaRPr lang="en-US" sz="2400" b="1" dirty="0">
+                            <a:latin typeface="Garamond" panose="02020404030301010803" pitchFamily="18" charset="0"/>
+                          </a:endParaRPr>
+                        </a:p>
+                      </a:txBody>
+                      <a:tcPr>
+                        <a:lnR w="12700" cap="flat" cmpd="sng" algn="ctr">
+                          <a:solidFill>
+                            <a:schemeClr val="tx1"/>
+                          </a:solidFill>
+                          <a:prstDash val="solid"/>
+                          <a:round/>
+                          <a:headEnd type="none" w="med" len="med"/>
+                          <a:tailEnd type="none" w="med" len="med"/>
+                        </a:lnR>
+                      </a:tcPr>
+                    </a:tc>
+                    <a:tc>
+                      <a:txBody>
+                        <a:bodyPr/>
+                        <a:lstStyle/>
+                        <a:p>
+                          <a:pPr algn="ctr"/>
+                          <a:r>
+                            <a:rPr lang="en-US" sz="2400" b="1" dirty="0"/>
+                            <a:t>PDF</a:t>
+                          </a:r>
+                          <a:endParaRPr lang="en-US" sz="2400" b="0" i="0" dirty="0">
+                            <a:solidFill>
+                              <a:srgbClr val="2A2A2A"/>
+                            </a:solidFill>
+                            <a:effectLst/>
+                            <a:latin typeface="Garamond" panose="02020404030301010803" pitchFamily="18" charset="0"/>
+                          </a:endParaRPr>
+                        </a:p>
+                      </a:txBody>
+                      <a:tcPr>
+                        <a:lnL w="12700" cap="flat" cmpd="sng" algn="ctr">
+                          <a:solidFill>
+                            <a:schemeClr val="tx1"/>
+                          </a:solidFill>
+                          <a:prstDash val="solid"/>
+                          <a:round/>
+                          <a:headEnd type="none" w="med" len="med"/>
+                          <a:tailEnd type="none" w="med" len="med"/>
+                        </a:lnL>
+                      </a:tcPr>
+                    </a:tc>
+                    <a:extLst>
+                      <a:ext uri="{0D108BD9-81ED-4DB2-BD59-A6C34878D82A}">
+                        <a16:rowId xmlns:a16="http://schemas.microsoft.com/office/drawing/2014/main" val="3166390322"/>
+                      </a:ext>
+                    </a:extLst>
+                  </a:tr>
+                  <a:tr h="732478">
+                    <a:tc>
+                      <a:txBody>
+                        <a:bodyPr/>
+                        <a:lstStyle/>
+                        <a:p>
+                          <a:pPr marL="0" marR="0" lvl="0" indent="0" algn="ctr" defTabSz="2138324" rtl="0" eaLnBrk="1" fontAlgn="auto" latinLnBrk="0" hangingPunct="1">
+                            <a:lnSpc>
+                              <a:spcPct val="100000"/>
+                            </a:lnSpc>
+                            <a:spcBef>
+                              <a:spcPts val="0"/>
+                            </a:spcBef>
+                            <a:spcAft>
+                              <a:spcPts val="0"/>
+                            </a:spcAft>
+                            <a:buClrTx/>
+                            <a:buSzTx/>
+                            <a:buFontTx/>
+                            <a:buNone/>
+                            <a:tabLst/>
+                            <a:defRPr/>
+                          </a:pPr>
+                          <a:r>
+                            <a:rPr lang="en-US" sz="2400" b="0" dirty="0"/>
+                            <a:t>Eccentricity e</a:t>
+                          </a:r>
+                          <a:endParaRPr lang="en-US" sz="2400" b="0" dirty="0">
+                            <a:latin typeface="Garamond" panose="02020404030301010803" pitchFamily="18" charset="0"/>
+                          </a:endParaRPr>
+                        </a:p>
+                      </a:txBody>
+                      <a:tcPr>
+                        <a:lnR w="12700" cap="flat" cmpd="sng" algn="ctr">
+                          <a:solidFill>
+                            <a:schemeClr val="tx1"/>
+                          </a:solidFill>
+                          <a:prstDash val="solid"/>
+                          <a:round/>
+                          <a:headEnd type="none" w="med" len="med"/>
+                          <a:tailEnd type="none" w="med" len="med"/>
+                        </a:lnR>
+                      </a:tcPr>
+                    </a:tc>
+                    <a:tc>
+                      <a:txBody>
+                        <a:bodyPr/>
+                        <a:lstStyle/>
+                        <a:p>
+                          <a:pPr marL="0" marR="0" lvl="0" indent="0" algn="l" defTabSz="2138324" rtl="0" eaLnBrk="1" fontAlgn="auto" latinLnBrk="0" hangingPunct="1">
+                            <a:lnSpc>
+                              <a:spcPct val="100000"/>
+                            </a:lnSpc>
+                            <a:spcBef>
+                              <a:spcPts val="0"/>
+                            </a:spcBef>
+                            <a:spcAft>
+                              <a:spcPts val="0"/>
+                            </a:spcAft>
+                            <a:buClrTx/>
+                            <a:buSzTx/>
+                            <a:buFontTx/>
+                            <a:buNone/>
+                            <a:tabLst/>
+                            <a:defRPr/>
+                          </a:pPr>
+                          <a14:m>
+                            <m:oMathPara xmlns:m="http://schemas.openxmlformats.org/officeDocument/2006/math">
+                              <m:oMathParaPr>
+                                <m:jc m:val="centerGroup"/>
+                              </m:oMathParaPr>
+                              <m:oMath xmlns:m="http://schemas.openxmlformats.org/officeDocument/2006/math">
+                                <m:r>
+                                  <a:rPr lang="en-US" sz="2400" b="0" smtClean="0"/>
+                                  <m:t>𝑓</m:t>
+                                </m:r>
+                                <m:d>
+                                  <m:dPr>
+                                    <m:ctrlPr>
+                                      <a:rPr lang="en-US" sz="2400" b="0" smtClean="0"/>
+                                    </m:ctrlPr>
+                                  </m:dPr>
+                                  <m:e>
+                                    <m:r>
+                                      <a:rPr lang="en-US" sz="2400" b="0" smtClean="0"/>
+                                      <m:t>𝑒</m:t>
+                                    </m:r>
+                                    <m:r>
+                                      <a:rPr lang="en-US" sz="2400" b="0" smtClean="0"/>
+                                      <m:t>|</m:t>
+                                    </m:r>
+                                    <m:r>
+                                      <a:rPr lang="en-US" sz="2400" b="0" smtClean="0"/>
+                                      <m:t>𝑎</m:t>
+                                    </m:r>
+                                  </m:e>
+                                </m:d>
+                                <m:r>
+                                  <a:rPr lang="en-US" sz="2400" b="0" smtClean="0"/>
+                                  <m:t>=</m:t>
+                                </m:r>
+                                <m:d>
+                                  <m:dPr>
+                                    <m:begChr m:val="{"/>
+                                    <m:endChr m:val=""/>
+                                    <m:ctrlPr>
+                                      <a:rPr lang="en-US" sz="2400" b="0" smtClean="0"/>
+                                    </m:ctrlPr>
+                                  </m:dPr>
+                                  <m:e>
+                                    <m:eqArr>
+                                      <m:eqArrPr>
+                                        <m:ctrlPr>
+                                          <a:rPr lang="en-US" sz="2400" b="0" smtClean="0"/>
+                                        </m:ctrlPr>
+                                      </m:eqArrPr>
+                                      <m:e>
+                                        <m:r>
+                                          <a:rPr lang="en-US" sz="2400" b="0" smtClean="0"/>
+                                          <m:t>1        </m:t>
+                                        </m:r>
+                                        <m:r>
+                                          <a:rPr lang="en-US" sz="2400" b="0" smtClean="0"/>
+                                          <m:t>𝑎</m:t>
+                                        </m:r>
+                                        <m:r>
+                                          <a:rPr lang="en-US" sz="2400" b="0" smtClean="0"/>
+                                          <m:t>&lt;100</m:t>
+                                        </m:r>
+                                        <m:r>
+                                          <a:rPr lang="en-US" sz="2400" b="0" smtClean="0"/>
+                                          <m:t>𝐴𝑈</m:t>
+                                        </m:r>
+                                      </m:e>
+                                      <m:e>
+                                        <m:r>
+                                          <a:rPr lang="en-US" sz="2400" b="0" smtClean="0"/>
+                                          <m:t>2</m:t>
+                                        </m:r>
+                                        <m:r>
+                                          <a:rPr lang="en-US" sz="2400" b="0" smtClean="0"/>
+                                          <m:t>𝑒</m:t>
+                                        </m:r>
+                                        <m:r>
+                                          <a:rPr lang="en-US" sz="2400" b="0" smtClean="0"/>
+                                          <m:t>       </m:t>
+                                        </m:r>
+                                        <m:r>
+                                          <a:rPr lang="en-US" sz="2400" b="0" smtClean="0"/>
+                                          <m:t>𝑎</m:t>
+                                        </m:r>
+                                        <m:r>
+                                          <a:rPr lang="en-US" sz="2400" b="0" smtClean="0"/>
+                                          <m:t>&gt;100 </m:t>
+                                        </m:r>
+                                        <m:r>
+                                          <a:rPr lang="en-US" sz="2400" b="0" smtClean="0"/>
+                                          <m:t>𝐴𝑈</m:t>
+                                        </m:r>
+                                      </m:e>
+                                    </m:eqArr>
+                                  </m:e>
+                                </m:d>
+                              </m:oMath>
+                            </m:oMathPara>
+                          </a14:m>
+                          <a:endParaRPr lang="en-US" sz="2400" dirty="0">
+                            <a:latin typeface="Garamond" panose="02020404030301010803" pitchFamily="18" charset="0"/>
+                          </a:endParaRPr>
+                        </a:p>
+                      </a:txBody>
+                      <a:tcPr>
+                        <a:lnL w="12700" cap="flat" cmpd="sng" algn="ctr">
+                          <a:solidFill>
+                            <a:schemeClr val="tx1"/>
+                          </a:solidFill>
+                          <a:prstDash val="solid"/>
+                          <a:round/>
+                          <a:headEnd type="none" w="med" len="med"/>
+                          <a:tailEnd type="none" w="med" len="med"/>
+                        </a:lnL>
+                      </a:tcPr>
+                    </a:tc>
+                    <a:extLst>
+                      <a:ext uri="{0D108BD9-81ED-4DB2-BD59-A6C34878D82A}">
+                        <a16:rowId xmlns:a16="http://schemas.microsoft.com/office/drawing/2014/main" val="3842043408"/>
+                      </a:ext>
+                    </a:extLst>
+                  </a:tr>
+                  <a:tr h="0">
+                    <a:tc>
+                      <a:txBody>
+                        <a:bodyPr/>
+                        <a:lstStyle/>
+                        <a:p>
+                          <a:pPr algn="ctr"/>
+                          <a:r>
+                            <a:rPr lang="en-US" sz="2400" b="0" dirty="0"/>
+                            <a:t>Mass ratio q</a:t>
+                          </a:r>
+                          <a:endParaRPr lang="en-US" sz="2400" b="0" i="0" dirty="0">
+                            <a:latin typeface="Garamond" panose="02020404030301010803" pitchFamily="18" charset="0"/>
+                          </a:endParaRPr>
+                        </a:p>
+                      </a:txBody>
+                      <a:tcPr>
+                        <a:lnR w="12700" cap="flat" cmpd="sng" algn="ctr">
+                          <a:solidFill>
+                            <a:schemeClr val="tx1"/>
+                          </a:solidFill>
+                          <a:prstDash val="solid"/>
+                          <a:round/>
+                          <a:headEnd type="none" w="med" len="med"/>
+                          <a:tailEnd type="none" w="med" len="med"/>
+                        </a:lnR>
+                      </a:tcPr>
+                    </a:tc>
+                    <a:tc>
+                      <a:txBody>
+                        <a:bodyPr/>
+                        <a:lstStyle/>
+                        <a:p>
+                          <a:pPr algn="l"/>
+                          <a:endParaRPr lang="en-US" sz="2400" b="0" i="0" dirty="0">
+                            <a:solidFill>
+                              <a:srgbClr val="2A2A2A"/>
+                            </a:solidFill>
+                            <a:effectLst/>
+                            <a:latin typeface="Garamond" panose="02020404030301010803" pitchFamily="18" charset="0"/>
+                          </a:endParaRPr>
+                        </a:p>
+                      </a:txBody>
+                      <a:tcPr>
+                        <a:lnL w="12700" cap="flat" cmpd="sng" algn="ctr">
+                          <a:solidFill>
+                            <a:schemeClr val="tx1"/>
+                          </a:solidFill>
+                          <a:prstDash val="solid"/>
+                          <a:round/>
+                          <a:headEnd type="none" w="med" len="med"/>
+                          <a:tailEnd type="none" w="med" len="med"/>
+                        </a:lnL>
+                      </a:tcPr>
+                    </a:tc>
+                    <a:extLst>
+                      <a:ext uri="{0D108BD9-81ED-4DB2-BD59-A6C34878D82A}">
+                        <a16:rowId xmlns:a16="http://schemas.microsoft.com/office/drawing/2014/main" val="2570003111"/>
+                      </a:ext>
+                    </a:extLst>
+                  </a:tr>
+                  <a:tr h="0">
+                    <a:tc>
+                      <a:txBody>
+                        <a:bodyPr/>
+                        <a:lstStyle/>
+                        <a:p>
+                          <a:pPr algn="ctr"/>
+                          <a:r>
+                            <a:rPr lang="en-US" sz="2400" b="0" dirty="0"/>
+                            <a:t>Orbital Period P</a:t>
+                          </a:r>
+                          <a:endParaRPr lang="en-US" sz="2400" b="0" i="0" dirty="0">
+                            <a:latin typeface="Garamond" panose="02020404030301010803" pitchFamily="18" charset="0"/>
+                          </a:endParaRPr>
+                        </a:p>
+                      </a:txBody>
+                      <a:tcPr>
+                        <a:lnR w="12700" cap="flat" cmpd="sng" algn="ctr">
+                          <a:solidFill>
+                            <a:schemeClr val="tx1"/>
+                          </a:solidFill>
+                          <a:prstDash val="solid"/>
+                          <a:round/>
+                          <a:headEnd type="none" w="med" len="med"/>
+                          <a:tailEnd type="none" w="med" len="med"/>
+                        </a:lnR>
+                      </a:tcPr>
+                    </a:tc>
+                    <a:tc>
+                      <a:txBody>
+                        <a:bodyPr/>
+                        <a:lstStyle/>
+                        <a:p>
+                          <a:pPr algn="l"/>
+                          <a:endParaRPr lang="en-US" sz="2400" b="0" i="0" dirty="0">
+                            <a:solidFill>
+                              <a:srgbClr val="2A2A2A"/>
+                            </a:solidFill>
+                            <a:effectLst/>
+                            <a:latin typeface="Garamond" panose="02020404030301010803" pitchFamily="18" charset="0"/>
+                          </a:endParaRPr>
+                        </a:p>
+                      </a:txBody>
+                      <a:tcPr>
+                        <a:lnL w="12700" cap="flat" cmpd="sng" algn="ctr">
+                          <a:solidFill>
+                            <a:schemeClr val="tx1"/>
+                          </a:solidFill>
+                          <a:prstDash val="solid"/>
+                          <a:round/>
+                          <a:headEnd type="none" w="med" len="med"/>
+                          <a:tailEnd type="none" w="med" len="med"/>
+                        </a:lnL>
+                      </a:tcPr>
+                    </a:tc>
+                    <a:extLst>
+                      <a:ext uri="{0D108BD9-81ED-4DB2-BD59-A6C34878D82A}">
+                        <a16:rowId xmlns:a16="http://schemas.microsoft.com/office/drawing/2014/main" val="594018447"/>
+                      </a:ext>
+                    </a:extLst>
+                  </a:tr>
+                  <a:tr h="0">
+                    <a:tc>
+                      <a:txBody>
+                        <a:bodyPr/>
+                        <a:lstStyle/>
+                        <a:p>
+                          <a:pPr algn="ctr"/>
+                          <a:r>
+                            <a:rPr lang="en-US" sz="2400" b="0" dirty="0"/>
+                            <a:t>Semi major axis a</a:t>
+                          </a:r>
+                          <a:endParaRPr lang="en-US" sz="2400" b="0" i="0" dirty="0">
+                            <a:latin typeface="Garamond" panose="02020404030301010803" pitchFamily="18" charset="0"/>
+                          </a:endParaRPr>
+                        </a:p>
+                      </a:txBody>
+                      <a:tcPr>
+                        <a:lnR w="12700" cap="flat" cmpd="sng" algn="ctr">
+                          <a:solidFill>
+                            <a:schemeClr val="tx1"/>
+                          </a:solidFill>
+                          <a:prstDash val="solid"/>
+                          <a:round/>
+                          <a:headEnd type="none" w="med" len="med"/>
+                          <a:tailEnd type="none" w="med" len="med"/>
+                        </a:lnR>
+                      </a:tcPr>
+                    </a:tc>
+                    <a:tc>
+                      <a:txBody>
+                        <a:bodyPr/>
+                        <a:lstStyle/>
+                        <a:p>
+                          <a:pPr algn="l"/>
+                          <a:endParaRPr lang="en-US" sz="2400" b="0" i="0" dirty="0">
+                            <a:solidFill>
+                              <a:srgbClr val="2A2A2A"/>
+                            </a:solidFill>
+                            <a:effectLst/>
+                            <a:latin typeface="Garamond" panose="02020404030301010803" pitchFamily="18" charset="0"/>
+                          </a:endParaRPr>
+                        </a:p>
+                      </a:txBody>
+                      <a:tcPr>
+                        <a:lnL w="12700" cap="flat" cmpd="sng" algn="ctr">
+                          <a:solidFill>
+                            <a:schemeClr val="tx1"/>
+                          </a:solidFill>
+                          <a:prstDash val="solid"/>
+                          <a:round/>
+                          <a:headEnd type="none" w="med" len="med"/>
+                          <a:tailEnd type="none" w="med" len="med"/>
+                        </a:lnL>
+                      </a:tcPr>
+                    </a:tc>
+                    <a:extLst>
+                      <a:ext uri="{0D108BD9-81ED-4DB2-BD59-A6C34878D82A}">
+                        <a16:rowId xmlns:a16="http://schemas.microsoft.com/office/drawing/2014/main" val="1531686875"/>
+                      </a:ext>
+                    </a:extLst>
+                  </a:tr>
+                  <a:tr h="433291">
+                    <a:tc>
+                      <a:txBody>
+                        <a:bodyPr/>
+                        <a:lstStyle/>
+                        <a:p>
+                          <a:pPr algn="ctr"/>
+                          <a:r>
+                            <a:rPr lang="en-US" sz="2400" b="0" dirty="0"/>
+                            <a:t>Radius ratio R</a:t>
+                          </a:r>
+                          <a:endParaRPr lang="en-US" sz="2400" b="0" i="0" dirty="0">
+                            <a:latin typeface="Garamond" panose="02020404030301010803" pitchFamily="18" charset="0"/>
+                          </a:endParaRPr>
+                        </a:p>
+                      </a:txBody>
+                      <a:tcPr>
+                        <a:lnR w="12700" cap="flat" cmpd="sng" algn="ctr">
+                          <a:solidFill>
+                            <a:schemeClr val="tx1"/>
+                          </a:solidFill>
+                          <a:prstDash val="solid"/>
+                          <a:round/>
+                          <a:headEnd type="none" w="med" len="med"/>
+                          <a:tailEnd type="none" w="med" len="med"/>
+                        </a:lnR>
+                      </a:tcPr>
+                    </a:tc>
+                    <a:tc>
+                      <a:txBody>
+                        <a:bodyPr/>
+                        <a:lstStyle/>
+                        <a:p>
+                          <a:pPr algn="l"/>
+                          <a:endParaRPr lang="en-US" sz="2400" b="0" i="0" dirty="0">
+                            <a:solidFill>
+                              <a:srgbClr val="2A2A2A"/>
+                            </a:solidFill>
+                            <a:effectLst/>
+                            <a:latin typeface="Garamond" panose="02020404030301010803" pitchFamily="18" charset="0"/>
+                          </a:endParaRPr>
+                        </a:p>
+                      </a:txBody>
+                      <a:tcPr>
+                        <a:lnL w="12700" cap="flat" cmpd="sng" algn="ctr">
+                          <a:solidFill>
+                            <a:schemeClr val="tx1"/>
+                          </a:solidFill>
+                          <a:prstDash val="solid"/>
+                          <a:round/>
+                          <a:headEnd type="none" w="med" len="med"/>
+                          <a:tailEnd type="none" w="med" len="med"/>
+                        </a:lnL>
+                      </a:tcPr>
+                    </a:tc>
+                    <a:extLst>
+                      <a:ext uri="{0D108BD9-81ED-4DB2-BD59-A6C34878D82A}">
+                        <a16:rowId xmlns:a16="http://schemas.microsoft.com/office/drawing/2014/main" val="3406429993"/>
+                      </a:ext>
+                    </a:extLst>
+                  </a:tr>
+                </a:tbl>
+              </a:graphicData>
+            </a:graphic>
+          </p:graphicFrame>
+        </mc:Choice>
+        <mc:Fallback>
+          <p:graphicFrame>
+            <p:nvGraphicFramePr>
+              <p:cNvPr id="3" name="Tabelle 2">
+                <a:extLst>
+                  <a:ext uri="{FF2B5EF4-FFF2-40B4-BE49-F238E27FC236}">
+                    <a16:creationId xmlns:a16="http://schemas.microsoft.com/office/drawing/2014/main" id="{94A2B041-0A3D-4469-7F39-F62F5BC2501A}"/>
+                  </a:ext>
+                </a:extLst>
+              </p:cNvPr>
+              <p:cNvGraphicFramePr>
+                <a:graphicFrameLocks noGrp="1"/>
+              </p:cNvGraphicFramePr>
+              <p:nvPr>
+                <p:extLst>
+                  <p:ext uri="{D42A27DB-BD31-4B8C-83A1-F6EECF244321}">
+                    <p14:modId xmlns:p14="http://schemas.microsoft.com/office/powerpoint/2010/main" val="3485859075"/>
+                  </p:ext>
+                </p:extLst>
+              </p:nvPr>
+            </p:nvGraphicFramePr>
+            <p:xfrm>
+              <a:off x="274119" y="11791702"/>
+              <a:ext cx="7845519" cy="3559048"/>
+            </p:xfrm>
+            <a:graphic>
+              <a:graphicData uri="http://schemas.openxmlformats.org/drawingml/2006/table">
+                <a:tbl>
+                  <a:tblPr firstRow="1" bandRow="1">
+                    <a:tableStyleId>{2D5ABB26-0587-4C30-8999-92F81FD0307C}</a:tableStyleId>
+                  </a:tblPr>
+                  <a:tblGrid>
+                    <a:gridCol w="2444885">
+                      <a:extLst>
+                        <a:ext uri="{9D8B030D-6E8A-4147-A177-3AD203B41FA5}">
+                          <a16:colId xmlns:a16="http://schemas.microsoft.com/office/drawing/2014/main" val="1884549708"/>
+                        </a:ext>
+                      </a:extLst>
+                    </a:gridCol>
+                    <a:gridCol w="5400634">
+                      <a:extLst>
+                        <a:ext uri="{9D8B030D-6E8A-4147-A177-3AD203B41FA5}">
+                          <a16:colId xmlns:a16="http://schemas.microsoft.com/office/drawing/2014/main" val="3529507465"/>
+                        </a:ext>
+                      </a:extLst>
+                    </a:gridCol>
+                  </a:tblGrid>
+                  <a:tr h="457200">
+                    <a:tc>
+                      <a:txBody>
+                        <a:bodyPr/>
+                        <a:lstStyle/>
+                        <a:p>
+                          <a:pPr algn="ctr"/>
+                          <a:r>
+                            <a:rPr lang="en-US" sz="2400" b="1" dirty="0"/>
+                            <a:t>Parameter</a:t>
+                          </a:r>
+                          <a:endParaRPr lang="en-US" sz="2400" b="1" dirty="0">
+                            <a:latin typeface="Garamond" panose="02020404030301010803" pitchFamily="18" charset="0"/>
+                          </a:endParaRPr>
+                        </a:p>
+                      </a:txBody>
+                      <a:tcPr>
+                        <a:lnR w="12700" cap="flat" cmpd="sng" algn="ctr">
+                          <a:solidFill>
+                            <a:schemeClr val="tx1"/>
+                          </a:solidFill>
+                          <a:prstDash val="solid"/>
+                          <a:round/>
+                          <a:headEnd type="none" w="med" len="med"/>
+                          <a:tailEnd type="none" w="med" len="med"/>
+                        </a:lnR>
+                      </a:tcPr>
+                    </a:tc>
+                    <a:tc>
+                      <a:txBody>
+                        <a:bodyPr/>
+                        <a:lstStyle/>
+                        <a:p>
+                          <a:pPr algn="ctr"/>
+                          <a:r>
+                            <a:rPr lang="en-US" sz="2400" b="1" dirty="0"/>
+                            <a:t>PDF</a:t>
+                          </a:r>
+                          <a:endParaRPr lang="en-US" sz="2400" b="0" i="0" dirty="0">
+                            <a:solidFill>
+                              <a:srgbClr val="2A2A2A"/>
+                            </a:solidFill>
+                            <a:effectLst/>
+                            <a:latin typeface="Garamond" panose="02020404030301010803" pitchFamily="18" charset="0"/>
+                          </a:endParaRPr>
+                        </a:p>
+                      </a:txBody>
+                      <a:tcPr>
+                        <a:lnL w="12700" cap="flat" cmpd="sng" algn="ctr">
+                          <a:solidFill>
+                            <a:schemeClr val="tx1"/>
+                          </a:solidFill>
+                          <a:prstDash val="solid"/>
+                          <a:round/>
+                          <a:headEnd type="none" w="med" len="med"/>
+                          <a:tailEnd type="none" w="med" len="med"/>
+                        </a:lnL>
+                      </a:tcPr>
+                    </a:tc>
+                    <a:extLst>
+                      <a:ext uri="{0D108BD9-81ED-4DB2-BD59-A6C34878D82A}">
+                        <a16:rowId xmlns:a16="http://schemas.microsoft.com/office/drawing/2014/main" val="3166390322"/>
+                      </a:ext>
+                    </a:extLst>
+                  </a:tr>
+                  <a:tr h="907288">
+                    <a:tc>
+                      <a:txBody>
+                        <a:bodyPr/>
+                        <a:lstStyle/>
+                        <a:p>
+                          <a:pPr marL="0" marR="0" lvl="0" indent="0" algn="ctr" defTabSz="2138324" rtl="0" eaLnBrk="1" fontAlgn="auto" latinLnBrk="0" hangingPunct="1">
+                            <a:lnSpc>
+                              <a:spcPct val="100000"/>
+                            </a:lnSpc>
+                            <a:spcBef>
+                              <a:spcPts val="0"/>
+                            </a:spcBef>
+                            <a:spcAft>
+                              <a:spcPts val="0"/>
+                            </a:spcAft>
+                            <a:buClrTx/>
+                            <a:buSzTx/>
+                            <a:buFontTx/>
+                            <a:buNone/>
+                            <a:tabLst/>
+                            <a:defRPr/>
+                          </a:pPr>
+                          <a:r>
+                            <a:rPr lang="en-US" sz="2400" b="0" dirty="0"/>
+                            <a:t>Eccentricity e</a:t>
+                          </a:r>
+                          <a:endParaRPr lang="en-US" sz="2400" b="0" dirty="0">
+                            <a:latin typeface="Garamond" panose="02020404030301010803" pitchFamily="18" charset="0"/>
+                          </a:endParaRPr>
+                        </a:p>
+                      </a:txBody>
+                      <a:tcPr>
+                        <a:lnR w="12700" cap="flat" cmpd="sng" algn="ctr">
+                          <a:solidFill>
+                            <a:schemeClr val="tx1"/>
+                          </a:solidFill>
+                          <a:prstDash val="solid"/>
+                          <a:round/>
+                          <a:headEnd type="none" w="med" len="med"/>
+                          <a:tailEnd type="none" w="med" len="med"/>
+                        </a:lnR>
+                      </a:tcPr>
+                    </a:tc>
+                    <a:tc>
+                      <a:txBody>
+                        <a:bodyPr/>
+                        <a:lstStyle/>
+                        <a:p>
+                          <a:endParaRPr lang="en-US"/>
+                        </a:p>
+                      </a:txBody>
+                      <a:tcPr>
+                        <a:lnL w="12700" cap="flat" cmpd="sng" algn="ctr">
+                          <a:solidFill>
+                            <a:schemeClr val="tx1"/>
+                          </a:solidFill>
+                          <a:prstDash val="solid"/>
+                          <a:round/>
+                          <a:headEnd type="none" w="med" len="med"/>
+                          <a:tailEnd type="none" w="med" len="med"/>
+                        </a:lnL>
+                        <a:blipFill>
+                          <a:blip r:embed="rId9"/>
+                          <a:stretch>
+                            <a:fillRect l="-45209" t="-55705" b="-257047"/>
+                          </a:stretch>
+                        </a:blipFill>
+                      </a:tcPr>
+                    </a:tc>
+                    <a:extLst>
+                      <a:ext uri="{0D108BD9-81ED-4DB2-BD59-A6C34878D82A}">
+                        <a16:rowId xmlns:a16="http://schemas.microsoft.com/office/drawing/2014/main" val="3842043408"/>
+                      </a:ext>
+                    </a:extLst>
+                  </a:tr>
+                  <a:tr h="457200">
+                    <a:tc>
+                      <a:txBody>
+                        <a:bodyPr/>
+                        <a:lstStyle/>
+                        <a:p>
+                          <a:pPr algn="ctr"/>
+                          <a:r>
+                            <a:rPr lang="en-US" sz="2400" b="0" dirty="0"/>
+                            <a:t>Mass ratio q</a:t>
+                          </a:r>
+                          <a:endParaRPr lang="en-US" sz="2400" b="0" i="0" dirty="0">
+                            <a:latin typeface="Garamond" panose="02020404030301010803" pitchFamily="18" charset="0"/>
+                          </a:endParaRPr>
+                        </a:p>
+                      </a:txBody>
+                      <a:tcPr>
+                        <a:lnR w="12700" cap="flat" cmpd="sng" algn="ctr">
+                          <a:solidFill>
+                            <a:schemeClr val="tx1"/>
+                          </a:solidFill>
+                          <a:prstDash val="solid"/>
+                          <a:round/>
+                          <a:headEnd type="none" w="med" len="med"/>
+                          <a:tailEnd type="none" w="med" len="med"/>
+                        </a:lnR>
+                      </a:tcPr>
+                    </a:tc>
+                    <a:tc>
+                      <a:txBody>
+                        <a:bodyPr/>
+                        <a:lstStyle/>
+                        <a:p>
+                          <a:pPr algn="l"/>
+                          <a:endParaRPr lang="en-US" sz="2400" b="0" i="0" dirty="0">
+                            <a:solidFill>
+                              <a:srgbClr val="2A2A2A"/>
+                            </a:solidFill>
+                            <a:effectLst/>
+                            <a:latin typeface="Garamond" panose="02020404030301010803" pitchFamily="18" charset="0"/>
+                          </a:endParaRPr>
+                        </a:p>
+                      </a:txBody>
+                      <a:tcPr>
+                        <a:lnL w="12700" cap="flat" cmpd="sng" algn="ctr">
+                          <a:solidFill>
+                            <a:schemeClr val="tx1"/>
+                          </a:solidFill>
+                          <a:prstDash val="solid"/>
+                          <a:round/>
+                          <a:headEnd type="none" w="med" len="med"/>
+                          <a:tailEnd type="none" w="med" len="med"/>
+                        </a:lnL>
+                      </a:tcPr>
+                    </a:tc>
+                    <a:extLst>
+                      <a:ext uri="{0D108BD9-81ED-4DB2-BD59-A6C34878D82A}">
+                        <a16:rowId xmlns:a16="http://schemas.microsoft.com/office/drawing/2014/main" val="2570003111"/>
+                      </a:ext>
+                    </a:extLst>
+                  </a:tr>
+                  <a:tr h="457200">
+                    <a:tc>
+                      <a:txBody>
+                        <a:bodyPr/>
+                        <a:lstStyle/>
+                        <a:p>
+                          <a:pPr algn="ctr"/>
+                          <a:r>
+                            <a:rPr lang="en-US" sz="2400" b="0" dirty="0"/>
+                            <a:t>Orbital Period P</a:t>
+                          </a:r>
+                          <a:endParaRPr lang="en-US" sz="2400" b="0" i="0" dirty="0">
+                            <a:latin typeface="Garamond" panose="02020404030301010803" pitchFamily="18" charset="0"/>
+                          </a:endParaRPr>
+                        </a:p>
+                      </a:txBody>
+                      <a:tcPr>
+                        <a:lnR w="12700" cap="flat" cmpd="sng" algn="ctr">
+                          <a:solidFill>
+                            <a:schemeClr val="tx1"/>
+                          </a:solidFill>
+                          <a:prstDash val="solid"/>
+                          <a:round/>
+                          <a:headEnd type="none" w="med" len="med"/>
+                          <a:tailEnd type="none" w="med" len="med"/>
+                        </a:lnR>
+                      </a:tcPr>
+                    </a:tc>
+                    <a:tc>
+                      <a:txBody>
+                        <a:bodyPr/>
+                        <a:lstStyle/>
+                        <a:p>
+                          <a:pPr algn="l"/>
+                          <a:endParaRPr lang="en-US" sz="2400" b="0" i="0" dirty="0">
+                            <a:solidFill>
+                              <a:srgbClr val="2A2A2A"/>
+                            </a:solidFill>
+                            <a:effectLst/>
+                            <a:latin typeface="Garamond" panose="02020404030301010803" pitchFamily="18" charset="0"/>
+                          </a:endParaRPr>
+                        </a:p>
+                      </a:txBody>
+                      <a:tcPr>
+                        <a:lnL w="12700" cap="flat" cmpd="sng" algn="ctr">
+                          <a:solidFill>
+                            <a:schemeClr val="tx1"/>
+                          </a:solidFill>
+                          <a:prstDash val="solid"/>
+                          <a:round/>
+                          <a:headEnd type="none" w="med" len="med"/>
+                          <a:tailEnd type="none" w="med" len="med"/>
+                        </a:lnL>
+                      </a:tcPr>
+                    </a:tc>
+                    <a:extLst>
+                      <a:ext uri="{0D108BD9-81ED-4DB2-BD59-A6C34878D82A}">
+                        <a16:rowId xmlns:a16="http://schemas.microsoft.com/office/drawing/2014/main" val="594018447"/>
+                      </a:ext>
+                    </a:extLst>
+                  </a:tr>
+                  <a:tr h="822960">
+                    <a:tc>
+                      <a:txBody>
+                        <a:bodyPr/>
+                        <a:lstStyle/>
+                        <a:p>
+                          <a:pPr algn="ctr"/>
+                          <a:r>
+                            <a:rPr lang="en-US" sz="2400" b="0" dirty="0"/>
+                            <a:t>Semi major axis a</a:t>
+                          </a:r>
+                          <a:endParaRPr lang="en-US" sz="2400" b="0" i="0" dirty="0">
+                            <a:latin typeface="Garamond" panose="02020404030301010803" pitchFamily="18" charset="0"/>
+                          </a:endParaRPr>
+                        </a:p>
+                      </a:txBody>
+                      <a:tcPr>
+                        <a:lnR w="12700" cap="flat" cmpd="sng" algn="ctr">
+                          <a:solidFill>
+                            <a:schemeClr val="tx1"/>
+                          </a:solidFill>
+                          <a:prstDash val="solid"/>
+                          <a:round/>
+                          <a:headEnd type="none" w="med" len="med"/>
+                          <a:tailEnd type="none" w="med" len="med"/>
+                        </a:lnR>
+                      </a:tcPr>
+                    </a:tc>
+                    <a:tc>
+                      <a:txBody>
+                        <a:bodyPr/>
+                        <a:lstStyle/>
+                        <a:p>
+                          <a:pPr algn="l"/>
+                          <a:endParaRPr lang="en-US" sz="2400" b="0" i="0" dirty="0">
+                            <a:solidFill>
+                              <a:srgbClr val="2A2A2A"/>
+                            </a:solidFill>
+                            <a:effectLst/>
+                            <a:latin typeface="Garamond" panose="02020404030301010803" pitchFamily="18" charset="0"/>
+                          </a:endParaRPr>
+                        </a:p>
+                      </a:txBody>
+                      <a:tcPr>
+                        <a:lnL w="12700" cap="flat" cmpd="sng" algn="ctr">
+                          <a:solidFill>
+                            <a:schemeClr val="tx1"/>
+                          </a:solidFill>
+                          <a:prstDash val="solid"/>
+                          <a:round/>
+                          <a:headEnd type="none" w="med" len="med"/>
+                          <a:tailEnd type="none" w="med" len="med"/>
+                        </a:lnL>
+                      </a:tcPr>
+                    </a:tc>
+                    <a:extLst>
+                      <a:ext uri="{0D108BD9-81ED-4DB2-BD59-A6C34878D82A}">
+                        <a16:rowId xmlns:a16="http://schemas.microsoft.com/office/drawing/2014/main" val="1531686875"/>
+                      </a:ext>
+                    </a:extLst>
+                  </a:tr>
+                  <a:tr h="457200">
+                    <a:tc>
+                      <a:txBody>
+                        <a:bodyPr/>
+                        <a:lstStyle/>
+                        <a:p>
+                          <a:pPr algn="ctr"/>
+                          <a:r>
+                            <a:rPr lang="en-US" sz="2400" b="0" dirty="0"/>
+                            <a:t>Radius ratio R</a:t>
+                          </a:r>
+                          <a:endParaRPr lang="en-US" sz="2400" b="0" i="0" dirty="0">
+                            <a:latin typeface="Garamond" panose="02020404030301010803" pitchFamily="18" charset="0"/>
+                          </a:endParaRPr>
+                        </a:p>
+                      </a:txBody>
+                      <a:tcPr>
+                        <a:lnR w="12700" cap="flat" cmpd="sng" algn="ctr">
+                          <a:solidFill>
+                            <a:schemeClr val="tx1"/>
+                          </a:solidFill>
+                          <a:prstDash val="solid"/>
+                          <a:round/>
+                          <a:headEnd type="none" w="med" len="med"/>
+                          <a:tailEnd type="none" w="med" len="med"/>
+                        </a:lnR>
+                      </a:tcPr>
+                    </a:tc>
+                    <a:tc>
+                      <a:txBody>
+                        <a:bodyPr/>
+                        <a:lstStyle/>
+                        <a:p>
+                          <a:pPr algn="l"/>
+                          <a:endParaRPr lang="en-US" sz="2400" b="0" i="0" dirty="0">
+                            <a:solidFill>
+                              <a:srgbClr val="2A2A2A"/>
+                            </a:solidFill>
+                            <a:effectLst/>
+                            <a:latin typeface="Garamond" panose="02020404030301010803" pitchFamily="18" charset="0"/>
+                          </a:endParaRPr>
+                        </a:p>
+                      </a:txBody>
+                      <a:tcPr>
+                        <a:lnL w="12700" cap="flat" cmpd="sng" algn="ctr">
+                          <a:solidFill>
+                            <a:schemeClr val="tx1"/>
+                          </a:solidFill>
+                          <a:prstDash val="solid"/>
+                          <a:round/>
+                          <a:headEnd type="none" w="med" len="med"/>
+                          <a:tailEnd type="none" w="med" len="med"/>
+                        </a:lnL>
+                      </a:tcPr>
+                    </a:tc>
+                    <a:extLst>
+                      <a:ext uri="{0D108BD9-81ED-4DB2-BD59-A6C34878D82A}">
+                        <a16:rowId xmlns:a16="http://schemas.microsoft.com/office/drawing/2014/main" val="3406429993"/>
+                      </a:ext>
+                    </a:extLst>
+                  </a:tr>
+                </a:tbl>
+              </a:graphicData>
+            </a:graphic>
+          </p:graphicFrame>
+        </mc:Fallback>
+      </mc:AlternateContent>
+      <p:sp>
+        <p:nvSpPr>
+          <p:cNvPr id="4" name="Textfeld 3">
+            <a:extLst>
+              <a:ext uri="{FF2B5EF4-FFF2-40B4-BE49-F238E27FC236}">
+                <a16:creationId xmlns:a16="http://schemas.microsoft.com/office/drawing/2014/main" id="{3526855B-9F99-BDFF-14A5-A48A03F5DA01}"/>
+              </a:ext>
+            </a:extLst>
+          </p:cNvPr>
+          <p:cNvSpPr txBox="1"/>
+          <p:nvPr/>
+        </p:nvSpPr>
+        <p:spPr>
+          <a:xfrm>
+            <a:off x="365760" y="25467153"/>
+            <a:ext cx="12070080" cy="2080057"/>
+          </a:xfrm>
+          <a:prstGeom prst="rect">
+            <a:avLst/>
+          </a:prstGeom>
+          <a:noFill/>
+        </p:spPr>
+        <p:txBody>
+          <a:bodyPr wrap="square" rtlCol="0">
+            <a:spAutoFit/>
+          </a:bodyPr>
+          <a:lstStyle/>
+          <a:p>
+            <a:r>
+              <a:rPr lang="en-US" sz="2400" dirty="0">
+                <a:latin typeface="Garamond" panose="02020404030301010803" pitchFamily="18" charset="0"/>
+              </a:rPr>
+              <a:t>lower eccentricity orbits are easier to fully characterize. ORB6 only includes fully characterized orbits, which is dine more completely for lower eccentricities.</a:t>
+            </a:r>
+          </a:p>
+          <a:p>
+            <a:endParaRPr lang="en-US" sz="2400" dirty="0">
+              <a:latin typeface="Garamond" panose="02020404030301010803" pitchFamily="18" charset="0"/>
+            </a:endParaRPr>
+          </a:p>
+          <a:p>
+            <a:pPr algn="just">
+              <a:spcAft>
+                <a:spcPts val="1125"/>
+              </a:spcAft>
+              <a:buNone/>
+            </a:pPr>
+            <a:r>
+              <a:rPr lang="en-US" sz="2400" dirty="0">
+                <a:highlight>
+                  <a:srgbClr val="FFFF00"/>
+                </a:highlight>
+                <a:latin typeface="Garamond" panose="02020404030301010803" pitchFamily="18" charset="0"/>
+              </a:rPr>
+              <a:t>Put conclusion here </a:t>
+            </a:r>
+            <a:endParaRPr lang="en-US" sz="2400" dirty="0">
+              <a:solidFill>
+                <a:srgbClr val="000000"/>
+              </a:solidFill>
+              <a:highlight>
+                <a:srgbClr val="FFFF00"/>
+              </a:highlight>
+              <a:latin typeface="Garamond" panose="02020404030301010803" pitchFamily="18" charset="0"/>
+            </a:endParaRPr>
+          </a:p>
+          <a:p>
+            <a:endParaRPr lang="en-US" sz="2400" dirty="0">
+              <a:latin typeface="Garamond" panose="02020404030301010803" pitchFamily="18" charset="0"/>
+            </a:endParaRPr>
           </a:p>
         </p:txBody>
       </p:sp>
@@ -8241,8 +8309,8 @@
           </a:graphicData>
         </a:graphic>
       </p:graphicFrame>
-      <mc:AlternateContent xmlns:mc="http://schemas.openxmlformats.org/markup-compatibility/2006">
-        <mc:Choice xmlns:a14="http://schemas.microsoft.com/office/drawing/2010/main" Requires="a14">
+      <mc:AlternateContent xmlns:mc="http://schemas.openxmlformats.org/markup-compatibility/2006" xmlns:a14="http://schemas.microsoft.com/office/drawing/2010/main">
+        <mc:Choice Requires="a14">
           <p:graphicFrame>
             <p:nvGraphicFramePr>
               <p:cNvPr id="2" name="Tabelle 1">
@@ -8872,7 +8940,7 @@
             </a:graphic>
           </p:graphicFrame>
         </mc:Choice>
-        <mc:Fallback>
+        <mc:Fallback xmlns="">
           <p:graphicFrame>
             <p:nvGraphicFramePr>
               <p:cNvPr id="2" name="Tabelle 1">

</xml_diff>

<commit_message>
poster font size update after feedback
</commit_message>
<xml_diff>
--- a/Poster.pptx
+++ b/Poster.pptx
@@ -117,7 +117,7 @@
 <file path=ppt/revisionInfo.xml><?xml version="1.0" encoding="utf-8"?>
 <p1510:revInfo xmlns:a="http://schemas.openxmlformats.org/drawingml/2006/main" xmlns:r="http://schemas.openxmlformats.org/officeDocument/2006/relationships" xmlns:p1510="http://schemas.microsoft.com/office/powerpoint/2015/10/main">
   <p1510:revLst>
-    <p1510:client id="{7885A197-381A-465D-A948-96F1A941B31A}" v="287" dt="2026-05-13T10:45:54.931"/>
+    <p1510:client id="{7885A197-381A-465D-A948-96F1A941B31A}" v="288" dt="2026-05-14T18:34:15.740"/>
   </p1510:revLst>
 </p1510:revInfo>
 </file>
@@ -127,18 +127,18 @@
   <pc:docChgLst>
     <pc:chgData name="Elja Meuter" userId="b1e1bb923a19bf75" providerId="LiveId" clId="{D71E6ABD-519B-41F0-9374-E926C1080144}"/>
     <pc:docChg chg="undo redo custSel addSld modSld">
-      <pc:chgData name="Elja Meuter" userId="b1e1bb923a19bf75" providerId="LiveId" clId="{D71E6ABD-519B-41F0-9374-E926C1080144}" dt="2026-05-13T10:47:02.362" v="8408" actId="14100"/>
+      <pc:chgData name="Elja Meuter" userId="b1e1bb923a19bf75" providerId="LiveId" clId="{D71E6ABD-519B-41F0-9374-E926C1080144}" dt="2026-05-14T18:36:57.692" v="8560" actId="5793"/>
       <pc:docMkLst>
         <pc:docMk/>
       </pc:docMkLst>
       <pc:sldChg chg="addSp delSp modSp mod setBg">
-        <pc:chgData name="Elja Meuter" userId="b1e1bb923a19bf75" providerId="LiveId" clId="{D71E6ABD-519B-41F0-9374-E926C1080144}" dt="2026-05-13T10:47:02.362" v="8408" actId="14100"/>
+        <pc:chgData name="Elja Meuter" userId="b1e1bb923a19bf75" providerId="LiveId" clId="{D71E6ABD-519B-41F0-9374-E926C1080144}" dt="2026-05-14T18:36:57.692" v="8560" actId="5793"/>
         <pc:sldMkLst>
           <pc:docMk/>
           <pc:sldMk cId="1631260291" sldId="256"/>
         </pc:sldMkLst>
         <pc:spChg chg="add mod">
-          <ac:chgData name="Elja Meuter" userId="b1e1bb923a19bf75" providerId="LiveId" clId="{D71E6ABD-519B-41F0-9374-E926C1080144}" dt="2026-05-13T10:46:07.828" v="8400" actId="2711"/>
+          <ac:chgData name="Elja Meuter" userId="b1e1bb923a19bf75" providerId="LiveId" clId="{D71E6ABD-519B-41F0-9374-E926C1080144}" dt="2026-05-14T18:34:35.344" v="8512" actId="1076"/>
           <ac:spMkLst>
             <pc:docMk/>
             <pc:sldMk cId="1631260291" sldId="256"/>
@@ -146,7 +146,7 @@
           </ac:spMkLst>
         </pc:spChg>
         <pc:spChg chg="add mod">
-          <ac:chgData name="Elja Meuter" userId="b1e1bb923a19bf75" providerId="LiveId" clId="{D71E6ABD-519B-41F0-9374-E926C1080144}" dt="2026-05-08T10:52:22.921" v="4790" actId="14100"/>
+          <ac:chgData name="Elja Meuter" userId="b1e1bb923a19bf75" providerId="LiveId" clId="{D71E6ABD-519B-41F0-9374-E926C1080144}" dt="2026-05-14T18:31:50.712" v="8489" actId="14100"/>
           <ac:spMkLst>
             <pc:docMk/>
             <pc:sldMk cId="1631260291" sldId="256"/>
@@ -154,7 +154,7 @@
           </ac:spMkLst>
         </pc:spChg>
         <pc:spChg chg="add mod">
-          <ac:chgData name="Elja Meuter" userId="b1e1bb923a19bf75" providerId="LiveId" clId="{D71E6ABD-519B-41F0-9374-E926C1080144}" dt="2026-05-08T11:36:20.255" v="6634" actId="14100"/>
+          <ac:chgData name="Elja Meuter" userId="b1e1bb923a19bf75" providerId="LiveId" clId="{D71E6ABD-519B-41F0-9374-E926C1080144}" dt="2026-05-14T18:31:34.271" v="8456" actId="1036"/>
           <ac:spMkLst>
             <pc:docMk/>
             <pc:sldMk cId="1631260291" sldId="256"/>
@@ -162,7 +162,7 @@
           </ac:spMkLst>
         </pc:spChg>
         <pc:spChg chg="add mod">
-          <ac:chgData name="Elja Meuter" userId="b1e1bb923a19bf75" providerId="LiveId" clId="{D71E6ABD-519B-41F0-9374-E926C1080144}" dt="2026-05-13T10:46:40.569" v="8403" actId="1076"/>
+          <ac:chgData name="Elja Meuter" userId="b1e1bb923a19bf75" providerId="LiveId" clId="{D71E6ABD-519B-41F0-9374-E926C1080144}" dt="2026-05-14T18:32:53.497" v="8494" actId="255"/>
           <ac:spMkLst>
             <pc:docMk/>
             <pc:sldMk cId="1631260291" sldId="256"/>
@@ -170,7 +170,7 @@
           </ac:spMkLst>
         </pc:spChg>
         <pc:spChg chg="add mod">
-          <ac:chgData name="Elja Meuter" userId="b1e1bb923a19bf75" providerId="LiveId" clId="{D71E6ABD-519B-41F0-9374-E926C1080144}" dt="2026-05-08T11:04:40.694" v="5334" actId="1037"/>
+          <ac:chgData name="Elja Meuter" userId="b1e1bb923a19bf75" providerId="LiveId" clId="{D71E6ABD-519B-41F0-9374-E926C1080144}" dt="2026-05-14T18:32:22.477" v="8493" actId="255"/>
           <ac:spMkLst>
             <pc:docMk/>
             <pc:sldMk cId="1631260291" sldId="256"/>
@@ -178,15 +178,15 @@
           </ac:spMkLst>
         </pc:spChg>
         <pc:spChg chg="add mod">
-          <ac:chgData name="Elja Meuter" userId="b1e1bb923a19bf75" providerId="LiveId" clId="{D71E6ABD-519B-41F0-9374-E926C1080144}" dt="2026-05-13T10:46:40.569" v="8403" actId="1076"/>
+          <ac:chgData name="Elja Meuter" userId="b1e1bb923a19bf75" providerId="LiveId" clId="{D71E6ABD-519B-41F0-9374-E926C1080144}" dt="2026-05-14T18:33:08.611" v="8497" actId="1076"/>
           <ac:spMkLst>
             <pc:docMk/>
             <pc:sldMk cId="1631260291" sldId="256"/>
             <ac:spMk id="21" creationId="{3B83DCEF-94AB-AC46-83D6-D9A1370B6283}"/>
           </ac:spMkLst>
         </pc:spChg>
-        <pc:spChg chg="add mod">
-          <ac:chgData name="Elja Meuter" userId="b1e1bb923a19bf75" providerId="LiveId" clId="{D71E6ABD-519B-41F0-9374-E926C1080144}" dt="2026-05-10T09:45:34.617" v="6643" actId="20577"/>
+        <pc:spChg chg="add del mod">
+          <ac:chgData name="Elja Meuter" userId="b1e1bb923a19bf75" providerId="LiveId" clId="{D71E6ABD-519B-41F0-9374-E926C1080144}" dt="2026-05-14T18:30:06.105" v="8410" actId="478"/>
           <ac:spMkLst>
             <pc:docMk/>
             <pc:sldMk cId="1631260291" sldId="256"/>
@@ -242,7 +242,7 @@
           </ac:spMkLst>
         </pc:spChg>
         <pc:spChg chg="add mod">
-          <ac:chgData name="Elja Meuter" userId="b1e1bb923a19bf75" providerId="LiveId" clId="{D71E6ABD-519B-41F0-9374-E926C1080144}" dt="2026-05-13T10:44:44.351" v="8383" actId="20577"/>
+          <ac:chgData name="Elja Meuter" userId="b1e1bb923a19bf75" providerId="LiveId" clId="{D71E6ABD-519B-41F0-9374-E926C1080144}" dt="2026-05-14T18:30:25.308" v="8412" actId="255"/>
           <ac:spMkLst>
             <pc:docMk/>
             <pc:sldMk cId="1631260291" sldId="256"/>
@@ -250,7 +250,7 @@
           </ac:spMkLst>
         </pc:spChg>
         <pc:spChg chg="add mod">
-          <ac:chgData name="Elja Meuter" userId="b1e1bb923a19bf75" providerId="LiveId" clId="{D71E6ABD-519B-41F0-9374-E926C1080144}" dt="2026-05-08T10:54:18.419" v="4819" actId="113"/>
+          <ac:chgData name="Elja Meuter" userId="b1e1bb923a19bf75" providerId="LiveId" clId="{D71E6ABD-519B-41F0-9374-E926C1080144}" dt="2026-05-14T18:31:44.412" v="8487" actId="14100"/>
           <ac:spMkLst>
             <pc:docMk/>
             <pc:sldMk cId="1631260291" sldId="256"/>
@@ -258,7 +258,7 @@
           </ac:spMkLst>
         </pc:spChg>
         <pc:spChg chg="add mod">
-          <ac:chgData name="Elja Meuter" userId="b1e1bb923a19bf75" providerId="LiveId" clId="{D71E6ABD-519B-41F0-9374-E926C1080144}" dt="2026-05-13T10:46:40.569" v="8403" actId="1076"/>
+          <ac:chgData name="Elja Meuter" userId="b1e1bb923a19bf75" providerId="LiveId" clId="{D71E6ABD-519B-41F0-9374-E926C1080144}" dt="2026-05-14T18:32:10.634" v="8492" actId="255"/>
           <ac:spMkLst>
             <pc:docMk/>
             <pc:sldMk cId="1631260291" sldId="256"/>
@@ -266,7 +266,7 @@
           </ac:spMkLst>
         </pc:spChg>
         <pc:spChg chg="add mod">
-          <ac:chgData name="Elja Meuter" userId="b1e1bb923a19bf75" providerId="LiveId" clId="{D71E6ABD-519B-41F0-9374-E926C1080144}" dt="2026-05-08T11:14:48.548" v="5844" actId="14100"/>
+          <ac:chgData name="Elja Meuter" userId="b1e1bb923a19bf75" providerId="LiveId" clId="{D71E6ABD-519B-41F0-9374-E926C1080144}" dt="2026-05-14T18:33:35.678" v="8499" actId="255"/>
           <ac:spMkLst>
             <pc:docMk/>
             <pc:sldMk cId="1631260291" sldId="256"/>
@@ -274,7 +274,7 @@
           </ac:spMkLst>
         </pc:spChg>
         <pc:spChg chg="add del mod">
-          <ac:chgData name="Elja Meuter" userId="b1e1bb923a19bf75" providerId="LiveId" clId="{D71E6ABD-519B-41F0-9374-E926C1080144}" dt="2026-05-13T10:45:49.558" v="8395" actId="21"/>
+          <ac:chgData name="Elja Meuter" userId="b1e1bb923a19bf75" providerId="LiveId" clId="{D71E6ABD-519B-41F0-9374-E926C1080144}" dt="2026-05-14T18:34:31.695" v="8511" actId="1076"/>
           <ac:spMkLst>
             <pc:docMk/>
             <pc:sldMk cId="1631260291" sldId="256"/>
@@ -282,7 +282,7 @@
           </ac:spMkLst>
         </pc:spChg>
         <pc:spChg chg="add mod">
-          <ac:chgData name="Elja Meuter" userId="b1e1bb923a19bf75" providerId="LiveId" clId="{D71E6ABD-519B-41F0-9374-E926C1080144}" dt="2026-05-08T11:26:40.850" v="6255" actId="14100"/>
+          <ac:chgData name="Elja Meuter" userId="b1e1bb923a19bf75" providerId="LiveId" clId="{D71E6ABD-519B-41F0-9374-E926C1080144}" dt="2026-05-14T18:35:56.506" v="8553" actId="20577"/>
           <ac:spMkLst>
             <pc:docMk/>
             <pc:sldMk cId="1631260291" sldId="256"/>
@@ -298,7 +298,7 @@
           </ac:graphicFrameMkLst>
         </pc:graphicFrameChg>
         <pc:graphicFrameChg chg="add mod modGraphic">
-          <ac:chgData name="Elja Meuter" userId="b1e1bb923a19bf75" providerId="LiveId" clId="{D71E6ABD-519B-41F0-9374-E926C1080144}" dt="2026-05-13T10:46:40.569" v="8403" actId="1076"/>
+          <ac:chgData name="Elja Meuter" userId="b1e1bb923a19bf75" providerId="LiveId" clId="{D71E6ABD-519B-41F0-9374-E926C1080144}" dt="2026-05-14T18:33:05.468" v="8496" actId="255"/>
           <ac:graphicFrameMkLst>
             <pc:docMk/>
             <pc:sldMk cId="1631260291" sldId="256"/>
@@ -306,15 +306,15 @@
           </ac:graphicFrameMkLst>
         </pc:graphicFrameChg>
         <pc:graphicFrameChg chg="add mod modGraphic">
-          <ac:chgData name="Elja Meuter" userId="b1e1bb923a19bf75" providerId="LiveId" clId="{D71E6ABD-519B-41F0-9374-E926C1080144}" dt="2026-05-13T10:46:14.498" v="8401" actId="14100"/>
+          <ac:chgData name="Elja Meuter" userId="b1e1bb923a19bf75" providerId="LiveId" clId="{D71E6ABD-519B-41F0-9374-E926C1080144}" dt="2026-05-14T18:36:57.692" v="8560" actId="5793"/>
           <ac:graphicFrameMkLst>
             <pc:docMk/>
             <pc:sldMk cId="1631260291" sldId="256"/>
             <ac:graphicFrameMk id="16" creationId="{94399FEF-B43E-87CD-14AE-705E86E62D60}"/>
           </ac:graphicFrameMkLst>
         </pc:graphicFrameChg>
-        <pc:picChg chg="add mod">
-          <ac:chgData name="Elja Meuter" userId="b1e1bb923a19bf75" providerId="LiveId" clId="{D71E6ABD-519B-41F0-9374-E926C1080144}" dt="2026-05-08T10:50:59.647" v="4785" actId="1076"/>
+        <pc:picChg chg="add del mod">
+          <ac:chgData name="Elja Meuter" userId="b1e1bb923a19bf75" providerId="LiveId" clId="{D71E6ABD-519B-41F0-9374-E926C1080144}" dt="2026-05-14T18:30:03.906" v="8409" actId="478"/>
           <ac:picMkLst>
             <pc:docMk/>
             <pc:sldMk cId="1631260291" sldId="256"/>
@@ -338,7 +338,7 @@
           </ac:picMkLst>
         </pc:picChg>
         <pc:picChg chg="add mod">
-          <ac:chgData name="Elja Meuter" userId="b1e1bb923a19bf75" providerId="LiveId" clId="{D71E6ABD-519B-41F0-9374-E926C1080144}" dt="2026-05-13T10:45:16.999" v="8387" actId="1076"/>
+          <ac:chgData name="Elja Meuter" userId="b1e1bb923a19bf75" providerId="LiveId" clId="{D71E6ABD-519B-41F0-9374-E926C1080144}" dt="2026-05-14T18:35:02.541" v="8529" actId="1035"/>
           <ac:picMkLst>
             <pc:docMk/>
             <pc:sldMk cId="1631260291" sldId="256"/>
@@ -346,7 +346,7 @@
           </ac:picMkLst>
         </pc:picChg>
         <pc:picChg chg="add mod">
-          <ac:chgData name="Elja Meuter" userId="b1e1bb923a19bf75" providerId="LiveId" clId="{D71E6ABD-519B-41F0-9374-E926C1080144}" dt="2026-05-13T10:46:20.477" v="8402" actId="1076"/>
+          <ac:chgData name="Elja Meuter" userId="b1e1bb923a19bf75" providerId="LiveId" clId="{D71E6ABD-519B-41F0-9374-E926C1080144}" dt="2026-05-14T18:35:00.922" v="8525" actId="1035"/>
           <ac:picMkLst>
             <pc:docMk/>
             <pc:sldMk cId="1631260291" sldId="256"/>
@@ -768,7 +768,7 @@
           <a:p>
             <a:fld id="{A1915611-89FC-422F-9E33-70C527C3BC07}" type="datetimeFigureOut">
               <a:rPr lang="en-US" smtClean="0"/>
-              <a:t>5/13/2026</a:t>
+              <a:t>5/14/2026</a:t>
             </a:fld>
             <a:endParaRPr lang="en-US"/>
           </a:p>
@@ -938,7 +938,7 @@
           <a:p>
             <a:fld id="{A1915611-89FC-422F-9E33-70C527C3BC07}" type="datetimeFigureOut">
               <a:rPr lang="en-US" smtClean="0"/>
-              <a:t>5/13/2026</a:t>
+              <a:t>5/14/2026</a:t>
             </a:fld>
             <a:endParaRPr lang="en-US"/>
           </a:p>
@@ -1118,7 +1118,7 @@
           <a:p>
             <a:fld id="{A1915611-89FC-422F-9E33-70C527C3BC07}" type="datetimeFigureOut">
               <a:rPr lang="en-US" smtClean="0"/>
-              <a:t>5/13/2026</a:t>
+              <a:t>5/14/2026</a:t>
             </a:fld>
             <a:endParaRPr lang="en-US"/>
           </a:p>
@@ -1288,7 +1288,7 @@
           <a:p>
             <a:fld id="{A1915611-89FC-422F-9E33-70C527C3BC07}" type="datetimeFigureOut">
               <a:rPr lang="en-US" smtClean="0"/>
-              <a:t>5/13/2026</a:t>
+              <a:t>5/14/2026</a:t>
             </a:fld>
             <a:endParaRPr lang="en-US"/>
           </a:p>
@@ -1534,7 +1534,7 @@
           <a:p>
             <a:fld id="{A1915611-89FC-422F-9E33-70C527C3BC07}" type="datetimeFigureOut">
               <a:rPr lang="en-US" smtClean="0"/>
-              <a:t>5/13/2026</a:t>
+              <a:t>5/14/2026</a:t>
             </a:fld>
             <a:endParaRPr lang="en-US"/>
           </a:p>
@@ -1766,7 +1766,7 @@
           <a:p>
             <a:fld id="{A1915611-89FC-422F-9E33-70C527C3BC07}" type="datetimeFigureOut">
               <a:rPr lang="en-US" smtClean="0"/>
-              <a:t>5/13/2026</a:t>
+              <a:t>5/14/2026</a:t>
             </a:fld>
             <a:endParaRPr lang="en-US"/>
           </a:p>
@@ -2133,7 +2133,7 @@
           <a:p>
             <a:fld id="{A1915611-89FC-422F-9E33-70C527C3BC07}" type="datetimeFigureOut">
               <a:rPr lang="en-US" smtClean="0"/>
-              <a:t>5/13/2026</a:t>
+              <a:t>5/14/2026</a:t>
             </a:fld>
             <a:endParaRPr lang="en-US"/>
           </a:p>
@@ -2251,7 +2251,7 @@
           <a:p>
             <a:fld id="{A1915611-89FC-422F-9E33-70C527C3BC07}" type="datetimeFigureOut">
               <a:rPr lang="en-US" smtClean="0"/>
-              <a:t>5/13/2026</a:t>
+              <a:t>5/14/2026</a:t>
             </a:fld>
             <a:endParaRPr lang="en-US"/>
           </a:p>
@@ -2346,7 +2346,7 @@
           <a:p>
             <a:fld id="{A1915611-89FC-422F-9E33-70C527C3BC07}" type="datetimeFigureOut">
               <a:rPr lang="en-US" smtClean="0"/>
-              <a:t>5/13/2026</a:t>
+              <a:t>5/14/2026</a:t>
             </a:fld>
             <a:endParaRPr lang="en-US"/>
           </a:p>
@@ -2623,7 +2623,7 @@
           <a:p>
             <a:fld id="{A1915611-89FC-422F-9E33-70C527C3BC07}" type="datetimeFigureOut">
               <a:rPr lang="en-US" smtClean="0"/>
-              <a:t>5/13/2026</a:t>
+              <a:t>5/14/2026</a:t>
             </a:fld>
             <a:endParaRPr lang="en-US"/>
           </a:p>
@@ -2880,7 +2880,7 @@
           <a:p>
             <a:fld id="{A1915611-89FC-422F-9E33-70C527C3BC07}" type="datetimeFigureOut">
               <a:rPr lang="en-US" smtClean="0"/>
-              <a:t>5/13/2026</a:t>
+              <a:t>5/14/2026</a:t>
             </a:fld>
             <a:endParaRPr lang="en-US"/>
           </a:p>
@@ -3093,7 +3093,7 @@
           <a:p>
             <a:fld id="{A1915611-89FC-422F-9E33-70C527C3BC07}" type="datetimeFigureOut">
               <a:rPr lang="en-US" smtClean="0"/>
-              <a:t>5/13/2026</a:t>
+              <a:t>5/14/2026</a:t>
             </a:fld>
             <a:endParaRPr lang="en-US"/>
           </a:p>
@@ -3771,7 +3771,7 @@
         <p:spPr>
           <a:xfrm>
             <a:off x="603885" y="4220811"/>
-            <a:ext cx="11136183" cy="1815882"/>
+            <a:ext cx="11136183" cy="2185214"/>
           </a:xfrm>
           <a:prstGeom prst="rect">
             <a:avLst/>
@@ -3788,7 +3788,7 @@
           <a:lstStyle/>
           <a:p>
             <a:r>
-              <a:rPr lang="en-US" sz="4400" b="1" dirty="0">
+              <a:rPr lang="en-US" sz="6000" b="1" dirty="0">
                 <a:latin typeface="Garamond" panose="02020404030301010803" pitchFamily="18" charset="0"/>
               </a:rPr>
               <a:t>Introduction</a:t>
@@ -3813,7 +3813,7 @@
               <a:defRPr/>
             </a:pPr>
             <a:r>
-              <a:rPr kumimoji="0" lang="en-US" sz="2400" b="0" i="0" u="none" strike="noStrike" kern="1200" cap="none" spc="0" normalizeH="0" baseline="0" noProof="0" dirty="0">
+              <a:rPr kumimoji="0" lang="en-US" sz="3200" b="0" i="0" u="none" strike="noStrike" kern="1200" cap="none" spc="0" normalizeH="0" baseline="0" noProof="0" dirty="0">
                 <a:ln>
                   <a:noFill/>
                 </a:ln>
@@ -3854,8 +3854,8 @@
         </p:nvSpPr>
         <p:spPr>
           <a:xfrm>
-            <a:off x="14033881" y="3794719"/>
-            <a:ext cx="6745859" cy="1138773"/>
+            <a:off x="14489982" y="3794719"/>
+            <a:ext cx="6289758" cy="2000548"/>
           </a:xfrm>
           <a:prstGeom prst="rect">
             <a:avLst/>
@@ -3870,7 +3870,7 @@
           <a:p>
             <a:pPr algn="r"/>
             <a:r>
-              <a:rPr lang="en-US" sz="4400" b="1" dirty="0">
+              <a:rPr lang="en-US" sz="6000" b="1" dirty="0">
                 <a:latin typeface="Garamond" panose="02020404030301010803" pitchFamily="18" charset="0"/>
               </a:rPr>
               <a:t>Aim</a:t>
@@ -3884,7 +3884,7 @@
               <a:buNone/>
             </a:pPr>
             <a:r>
-              <a:rPr lang="en-US" sz="2400" b="0" i="0" dirty="0">
+              <a:rPr lang="en-US" sz="3200" b="0" i="0" dirty="0">
                 <a:solidFill>
                   <a:srgbClr val="000000"/>
                 </a:solidFill>
@@ -3910,8 +3910,8 @@
         </p:nvSpPr>
         <p:spPr>
           <a:xfrm>
-            <a:off x="4572255" y="7604524"/>
-            <a:ext cx="7277051" cy="2246769"/>
+            <a:off x="4003789" y="7604524"/>
+            <a:ext cx="7845518" cy="2985433"/>
           </a:xfrm>
           <a:prstGeom prst="rect">
             <a:avLst/>
@@ -3926,7 +3926,7 @@
           <a:p>
             <a:pPr algn="r"/>
             <a:r>
-              <a:rPr lang="en-US" sz="4400" b="1" dirty="0">
+              <a:rPr lang="en-US" sz="6000" b="1" dirty="0">
                 <a:latin typeface="Garamond" panose="02020404030301010803" pitchFamily="18" charset="0"/>
               </a:rPr>
               <a:t>Method</a:t>
@@ -3935,7 +3935,7 @@
           <a:p>
             <a:pPr algn="r"/>
             <a:r>
-              <a:rPr lang="en-US" sz="2400" b="0" i="0" dirty="0">
+              <a:rPr lang="en-US" sz="3200" b="0" i="0" dirty="0">
                 <a:solidFill>
                   <a:srgbClr val="000000"/>
                 </a:solidFill>
@@ -3944,7 +3944,7 @@
               </a:rPr>
               <a:t>We generate synthetic binary star populations based on theory. Then we subtract our generated binary star population from the SB9 and ORB6 catalogues and plot the difference.  </a:t>
             </a:r>
-            <a:endParaRPr lang="en-US" sz="2400" dirty="0">
+            <a:endParaRPr lang="en-US" sz="3200" dirty="0">
               <a:latin typeface="Garamond" panose="02020404030301010803" pitchFamily="18" charset="0"/>
             </a:endParaRPr>
           </a:p>
@@ -3965,7 +3965,7 @@
         <p:spPr>
           <a:xfrm>
             <a:off x="16469427" y="15612540"/>
-            <a:ext cx="4279281" cy="1446550"/>
+            <a:ext cx="4279281" cy="1938992"/>
           </a:xfrm>
           <a:prstGeom prst="rect">
             <a:avLst/>
@@ -3983,7 +3983,7 @@
           <a:p>
             <a:pPr algn="r"/>
             <a:r>
-              <a:rPr lang="en-US" sz="4400" b="1" dirty="0">
+              <a:rPr lang="en-US" sz="6000" b="1" dirty="0">
                 <a:latin typeface="Garamond" panose="02020404030301010803" pitchFamily="18" charset="0"/>
               </a:rPr>
               <a:t>Results</a:t>
@@ -3991,7 +3991,7 @@
           </a:p>
           <a:p>
             <a:pPr algn="r"/>
-            <a:endParaRPr lang="en-US" sz="4400" b="1" dirty="0">
+            <a:endParaRPr lang="en-US" sz="6000" b="1" dirty="0">
               <a:latin typeface="Garamond" panose="02020404030301010803" pitchFamily="18" charset="0"/>
             </a:endParaRPr>
           </a:p>
@@ -4035,8 +4035,8 @@
         </p:blipFill>
         <p:spPr>
           <a:xfrm>
-            <a:off x="8046720" y="17740215"/>
-            <a:ext cx="4944344" cy="2849072"/>
+            <a:off x="7032014" y="20053502"/>
+            <a:ext cx="6553681" cy="3776418"/>
           </a:xfrm>
           <a:prstGeom prst="rect">
             <a:avLst/>
@@ -4081,8 +4081,8 @@
         </p:blipFill>
         <p:spPr>
           <a:xfrm>
-            <a:off x="8181679" y="21060228"/>
-            <a:ext cx="4674426" cy="2691277"/>
+            <a:off x="234931" y="20023752"/>
+            <a:ext cx="6559186" cy="3776418"/>
           </a:xfrm>
           <a:prstGeom prst="rect">
             <a:avLst/>
@@ -4103,8 +4103,8 @@
         </p:nvSpPr>
         <p:spPr>
           <a:xfrm>
-            <a:off x="152158" y="20628764"/>
-            <a:ext cx="7567553" cy="3724096"/>
+            <a:off x="552331" y="23915651"/>
+            <a:ext cx="12184575" cy="5940088"/>
           </a:xfrm>
           <a:prstGeom prst="rect">
             <a:avLst/>
@@ -4121,7 +4121,7 @@
           <a:lstStyle/>
           <a:p>
             <a:r>
-              <a:rPr lang="en-US" sz="4400" b="1" dirty="0">
+              <a:rPr lang="en-US" sz="6000" b="1" dirty="0">
                 <a:latin typeface="Garamond" panose="02020404030301010803" pitchFamily="18" charset="0"/>
               </a:rPr>
               <a:t>Conclusion &amp; Discussion</a:t>
@@ -4129,24 +4129,26 @@
           </a:p>
           <a:p>
             <a:r>
-              <a:rPr lang="en-US" sz="2400" dirty="0">
+              <a:rPr lang="en-US" sz="3200" dirty="0">
                 <a:latin typeface="Garamond" panose="02020404030301010803" pitchFamily="18" charset="0"/>
               </a:rPr>
               <a:t>A preference for circular orbits in SB9, makes sense since these have the easiest RV curve to detect. Spectroscopic binaries are often close binaries, so circular orbits are much more likely. </a:t>
             </a:r>
           </a:p>
           <a:p>
-            <a:endParaRPr lang="en-US" sz="2400" dirty="0">
+            <a:endParaRPr lang="en-US" sz="3200" dirty="0">
               <a:latin typeface="Garamond" panose="02020404030301010803" pitchFamily="18" charset="0"/>
             </a:endParaRPr>
           </a:p>
           <a:p>
             <a:r>
-              <a:rPr lang="en-US" sz="2400" dirty="0">
+              <a:rPr lang="en-US" sz="3200" dirty="0">
                 <a:latin typeface="Garamond" panose="02020404030301010803" pitchFamily="18" charset="0"/>
               </a:rPr>
-              <a:t>For ORB6 the bias towards lower eccentricities is much flatter, indicating that a larger period range is covered. The bias is most likely of computational origin since</a:t>
-            </a:r>
+              <a:t>For ORB6 the bias towards lower eccentricities is much flatter, indicating that a larger period range is covered. The bias is most likely of computational origin since lower eccentricity orbits are easier to fully characterize. ORB6 only includes fully characterized orbits, which is dine more completely for lower eccentricities.</a:t>
+            </a:r>
+          </a:p>
+          <a:p>
             <a:endParaRPr lang="en-US" sz="3200" dirty="0">
               <a:latin typeface="Garamond" panose="02020404030301010803" pitchFamily="18" charset="0"/>
             </a:endParaRPr>
@@ -4167,8 +4169,8 @@
         </p:nvSpPr>
         <p:spPr>
           <a:xfrm>
-            <a:off x="12787087" y="25467153"/>
-            <a:ext cx="8283710" cy="3970318"/>
+            <a:off x="12837268" y="24253006"/>
+            <a:ext cx="8283710" cy="7725192"/>
           </a:xfrm>
           <a:prstGeom prst="rect">
             <a:avLst/>
@@ -4185,7 +4187,7 @@
           <a:lstStyle/>
           <a:p>
             <a:r>
-              <a:rPr lang="en-US" sz="4400" b="1" dirty="0">
+              <a:rPr lang="en-US" sz="6000" b="1" dirty="0">
                 <a:latin typeface="Garamond" panose="02020404030301010803" pitchFamily="18" charset="0"/>
               </a:rPr>
               <a:t>Acknowledgements &amp; References</a:t>
@@ -4193,13 +4195,13 @@
           </a:p>
           <a:p>
             <a:r>
-              <a:rPr lang="en-US" sz="2400" dirty="0">
+              <a:rPr lang="en-US" sz="3200" dirty="0">
                 <a:latin typeface="Garamond" panose="02020404030301010803" pitchFamily="18" charset="0"/>
               </a:rPr>
               <a:t>We thank Oleg Malkov for his continued support to provide us with all the data from the </a:t>
             </a:r>
             <a:r>
-              <a:rPr lang="en-US" sz="2400" dirty="0">
+              <a:rPr lang="en-US" sz="3200" dirty="0">
                 <a:solidFill>
                   <a:srgbClr val="000000"/>
                 </a:solidFill>
@@ -4208,11 +4210,32 @@
               <a:t>Binary Star Database BDB (Kovaleva et al, 2015), available from Institute of Astronomy (Russian Academy of Sciences),</a:t>
             </a:r>
             <a:r>
-              <a:rPr lang="en-US" sz="2400" dirty="0">
+              <a:rPr lang="en-US" sz="3200" dirty="0">
                 <a:latin typeface="Garamond" panose="02020404030301010803" pitchFamily="18" charset="0"/>
               </a:rPr>
-              <a:t> used in this project and Susana Monteiro Carneiro for her support and feedback throughout the entire lifetime of the project.</a:t>
-            </a:r>
+              <a:t> used in this project and</a:t>
+            </a:r>
+          </a:p>
+          <a:p>
+            <a:r>
+              <a:rPr lang="en-US" sz="3200" dirty="0">
+                <a:latin typeface="Garamond" panose="02020404030301010803" pitchFamily="18" charset="0"/>
+              </a:rPr>
+              <a:t> Susana Monteiro Carneiro for her </a:t>
+            </a:r>
+          </a:p>
+          <a:p>
+            <a:r>
+              <a:rPr lang="en-US" sz="3200" dirty="0">
+                <a:latin typeface="Garamond" panose="02020404030301010803" pitchFamily="18" charset="0"/>
+              </a:rPr>
+              <a:t>support and feedback throughout the entire duration of the project.</a:t>
+            </a:r>
+          </a:p>
+          <a:p>
+            <a:endParaRPr lang="en-US" sz="3200" dirty="0">
+              <a:latin typeface="Garamond" panose="02020404030301010803" pitchFamily="18" charset="0"/>
+            </a:endParaRPr>
           </a:p>
           <a:p>
             <a:r>
@@ -4265,8 +4288,8 @@
         </p:nvSpPr>
         <p:spPr>
           <a:xfrm>
-            <a:off x="14458951" y="5167760"/>
-            <a:ext cx="6289758" cy="1506720"/>
+            <a:off x="13703578" y="5815459"/>
+            <a:ext cx="7045131" cy="2485403"/>
           </a:xfrm>
           <a:prstGeom prst="roundRect">
             <a:avLst>
@@ -4299,7 +4322,7 @@
           <a:p>
             <a:pPr algn="ctr"/>
             <a:r>
-              <a:rPr lang="en-US" sz="2400" b="0" i="0" dirty="0">
+              <a:rPr lang="en-US" sz="3200" b="0" i="0" dirty="0">
                 <a:solidFill>
                   <a:srgbClr val="F0F6FC"/>
                 </a:solidFill>
@@ -4308,7 +4331,7 @@
               </a:rPr>
               <a:t>What observational biases are present in the SB9 and ORB6 binary star catalogues when compared to theoretically expected binary star populations? </a:t>
             </a:r>
-            <a:endParaRPr lang="en-US" dirty="0">
+            <a:endParaRPr lang="en-US" sz="3200" dirty="0">
               <a:latin typeface="Garamond" panose="02020404030301010803" pitchFamily="18" charset="0"/>
             </a:endParaRPr>
           </a:p>
@@ -4328,8 +4351,8 @@
         </p:nvSpPr>
         <p:spPr>
           <a:xfrm>
-            <a:off x="13065221" y="6790592"/>
-            <a:ext cx="7683487" cy="1938992"/>
+            <a:off x="14002849" y="8428892"/>
+            <a:ext cx="6745859" cy="4031873"/>
           </a:xfrm>
           <a:prstGeom prst="rect">
             <a:avLst/>
@@ -4344,7 +4367,7 @@
           <a:p>
             <a:pPr algn="r"/>
             <a:r>
-              <a:rPr kumimoji="0" lang="en-US" sz="2400" b="0" i="0" u="none" strike="noStrike" kern="1200" cap="none" spc="0" normalizeH="0" baseline="0" noProof="0" dirty="0">
+              <a:rPr kumimoji="0" lang="en-US" sz="3200" b="0" i="0" u="none" strike="noStrike" kern="1200" cap="none" spc="0" normalizeH="0" baseline="0" noProof="0" dirty="0">
                 <a:ln>
                   <a:noFill/>
                 </a:ln>
@@ -4360,46 +4383,10 @@
               </a:rPr>
               <a:t>Specifically, we will analyze the differences between observed and theoretical distributions of eccentricity, mass ratio, radius ratio, orbital period, and semi-major axis and the observational biases expected from the detection methods used in these catalogues.</a:t>
             </a:r>
-            <a:endParaRPr lang="en-US" dirty="0"/>
+            <a:endParaRPr lang="en-US" sz="3200" dirty="0"/>
           </a:p>
         </p:txBody>
       </p:sp>
-      <p:pic>
-        <p:nvPicPr>
-          <p:cNvPr id="11" name="Grafik 10">
-            <a:extLst>
-              <a:ext uri="{FF2B5EF4-FFF2-40B4-BE49-F238E27FC236}">
-                <a16:creationId xmlns:a16="http://schemas.microsoft.com/office/drawing/2014/main" id="{13091CF6-D939-61E3-B772-F2B2A691074B}"/>
-              </a:ext>
-            </a:extLst>
-          </p:cNvPr>
-          <p:cNvPicPr>
-            <a:picLocks noChangeAspect="1"/>
-          </p:cNvPicPr>
-          <p:nvPr/>
-        </p:nvPicPr>
-        <p:blipFill>
-          <a:blip>
-            <a:extLst>
-              <a:ext uri="{96DAC541-7B7A-43D3-8B79-37D633B846F1}">
-                <asvg:svgBlip xmlns:asvg="http://schemas.microsoft.com/office/drawing/2016/SVG/main" r:embed="rId5"/>
-              </a:ext>
-            </a:extLst>
-          </a:blip>
-          <a:stretch>
-            <a:fillRect/>
-          </a:stretch>
-        </p:blipFill>
-        <p:spPr>
-          <a:xfrm>
-            <a:off x="14856740" y="8458667"/>
-            <a:ext cx="5520753" cy="4051522"/>
-          </a:xfrm>
-          <a:prstGeom prst="rect">
-            <a:avLst/>
-          </a:prstGeom>
-        </p:spPr>
-      </p:pic>
       <p:sp>
         <p:nvSpPr>
           <p:cNvPr id="38" name="Ellipse 37">
@@ -4467,7 +4454,7 @@
         <p:spPr>
           <a:xfrm>
             <a:off x="295891" y="10783095"/>
-            <a:ext cx="7742600" cy="830997"/>
+            <a:ext cx="7742600" cy="1077218"/>
           </a:xfrm>
           <a:prstGeom prst="rect">
             <a:avLst/>
@@ -4481,7 +4468,7 @@
           <a:lstStyle/>
           <a:p>
             <a:r>
-              <a:rPr lang="en-US" sz="2400" b="1" i="1" dirty="0">
+              <a:rPr lang="en-US" sz="3200" b="1" i="1" dirty="0">
                 <a:solidFill>
                   <a:srgbClr val="000000"/>
                 </a:solidFill>
@@ -4490,7 +4477,7 @@
               <a:t>Table 1</a:t>
             </a:r>
             <a:r>
-              <a:rPr lang="en-US" sz="2400" dirty="0">
+              <a:rPr lang="en-US" sz="3200" dirty="0">
                 <a:solidFill>
                   <a:srgbClr val="000000"/>
                 </a:solidFill>
@@ -4498,7 +4485,7 @@
               </a:rPr>
               <a:t>. Theoretical distributions of binary star systems based on theory. </a:t>
             </a:r>
-            <a:endParaRPr lang="en-US" sz="2400" dirty="0">
+            <a:endParaRPr lang="en-US" sz="3200" dirty="0">
               <a:latin typeface="Garamond" panose="02020404030301010803" pitchFamily="18" charset="0"/>
             </a:endParaRPr>
           </a:p>
@@ -4519,7 +4506,7 @@
         <p:spPr>
           <a:xfrm>
             <a:off x="651691" y="3483050"/>
-            <a:ext cx="9087296" cy="369332"/>
+            <a:ext cx="14001846" cy="523220"/>
           </a:xfrm>
           <a:prstGeom prst="rect">
             <a:avLst/>
@@ -4533,19 +4520,19 @@
           <a:lstStyle/>
           <a:p>
             <a:r>
-              <a:rPr lang="en-US" dirty="0">
+              <a:rPr lang="en-US" sz="2800" dirty="0">
                 <a:latin typeface="Garamond" panose="02020404030301010803" pitchFamily="18" charset="0"/>
               </a:rPr>
               <a:t>Authors: Elja Meuter (s4500229), Wouter de Wit (s----), Damian </a:t>
             </a:r>
             <a:r>
-              <a:rPr lang="en-US" dirty="0" err="1">
+              <a:rPr lang="en-US" sz="2800" dirty="0" err="1">
                 <a:latin typeface="Garamond" panose="02020404030301010803" pitchFamily="18" charset="0"/>
               </a:rPr>
               <a:t>Sloos</a:t>
             </a:r>
             <a:r>
-              <a:rPr lang="en-US" dirty="0">
+              <a:rPr lang="en-US" sz="2800" dirty="0">
                 <a:latin typeface="Garamond" panose="02020404030301010803" pitchFamily="18" charset="0"/>
               </a:rPr>
               <a:t> (s----), Tobias de Cock (s----)</a:t>
@@ -4571,7 +4558,7 @@
           <a:blip>
             <a:extLst>
               <a:ext uri="{96DAC541-7B7A-43D3-8B79-37D633B846F1}">
-                <asvg:svgBlip xmlns:asvg="http://schemas.microsoft.com/office/drawing/2016/SVG/main" r:embed="rId6"/>
+                <asvg:svgBlip xmlns:asvg="http://schemas.microsoft.com/office/drawing/2016/SVG/main" r:embed="rId5"/>
               </a:ext>
             </a:extLst>
           </a:blip>
@@ -4606,14 +4593,14 @@
               <p:nvPr>
                 <p:extLst>
                   <p:ext uri="{D42A27DB-BD31-4B8C-83A1-F6EECF244321}">
-                    <p14:modId xmlns:p14="http://schemas.microsoft.com/office/powerpoint/2010/main" val="2611105247"/>
+                    <p14:modId xmlns:p14="http://schemas.microsoft.com/office/powerpoint/2010/main" val="444441714"/>
                   </p:ext>
                 </p:extLst>
               </p:nvPr>
             </p:nvGraphicFramePr>
             <p:xfrm>
-              <a:off x="13547981" y="16326172"/>
-              <a:ext cx="7683486" cy="8540603"/>
+              <a:off x="13547981" y="16326173"/>
+              <a:ext cx="7683486" cy="8133582"/>
             </p:xfrm>
             <a:graphic>
               <a:graphicData uri="http://schemas.openxmlformats.org/drawingml/2006/table">
@@ -4637,7 +4624,7 @@
                       </a:extLst>
                     </a:gridCol>
                   </a:tblGrid>
-                  <a:tr h="8540603">
+                  <a:tr h="8133582">
                     <a:tc>
                       <a:txBody>
                         <a:bodyPr/>
@@ -4645,35 +4632,35 @@
                         <a:p>
                           <a:pPr algn="ctr"/>
                           <a:r>
-                            <a:rPr lang="en-US" sz="2400" b="1" i="0" dirty="0">
+                            <a:rPr lang="en-US" sz="3200" b="1" i="0" dirty="0">
                               <a:latin typeface="Garamond" panose="02020404030301010803" pitchFamily="18" charset="0"/>
                             </a:rPr>
                             <a:t>SB9</a:t>
                           </a:r>
                         </a:p>
                         <a:p>
-                          <a:pPr algn="just">
+                          <a:pPr algn="l">
                             <a:spcAft>
                               <a:spcPts val="1125"/>
                             </a:spcAft>
                             <a:buNone/>
                           </a:pPr>
                           <a:r>
-                            <a:rPr lang="en-US" sz="2400" dirty="0">
+                            <a:rPr lang="en-US" sz="3200" dirty="0">
                               <a:latin typeface="Garamond" panose="02020404030301010803" pitchFamily="18" charset="0"/>
                             </a:rPr>
                             <a:t>We find that SB9 is biased…</a:t>
                           </a:r>
                         </a:p>
                         <a:p>
-                          <a:pPr algn="just">
+                          <a:pPr algn="l">
                             <a:spcAft>
                               <a:spcPts val="1125"/>
                             </a:spcAft>
                             <a:buNone/>
                           </a:pPr>
                           <a:r>
-                            <a:rPr lang="en-US" sz="2400" dirty="0">
+                            <a:rPr lang="en-US" sz="3200" dirty="0">
                               <a:latin typeface="Garamond" panose="02020404030301010803" pitchFamily="18" charset="0"/>
                             </a:rPr>
                             <a:t>…towards lower eccentricities, with a very strong preference for </a:t>
@@ -4681,13 +4668,13 @@
                           <a14:m>
                             <m:oMath xmlns:m="http://schemas.openxmlformats.org/officeDocument/2006/math">
                               <m:r>
-                                <a:rPr lang="en-US" sz="2400" b="0" i="1" smtClean="0">
+                                <a:rPr lang="en-US" sz="3200" b="0" i="1" smtClean="0">
                                   <a:latin typeface="Cambria Math" panose="02040503050406030204" pitchFamily="18" charset="0"/>
                                 </a:rPr>
                                 <m:t>𝑒</m:t>
                               </m:r>
                               <m:r>
-                                <a:rPr lang="en-US" sz="2400" b="0" i="1" smtClean="0">
+                                <a:rPr lang="en-US" sz="3200" b="0" i="1" smtClean="0">
                                   <a:latin typeface="Cambria Math" panose="02040503050406030204" pitchFamily="18" charset="0"/>
                                 </a:rPr>
                                 <m:t>=0</m:t>
@@ -4695,32 +4682,32 @@
                             </m:oMath>
                           </a14:m>
                           <a:r>
-                            <a:rPr lang="en-US" sz="2400" dirty="0">
+                            <a:rPr lang="en-US" sz="3200" dirty="0">
                               <a:latin typeface="Garamond" panose="02020404030301010803" pitchFamily="18" charset="0"/>
                             </a:rPr>
                             <a:t>. </a:t>
                           </a:r>
                         </a:p>
                         <a:p>
-                          <a:pPr algn="just">
+                          <a:pPr algn="l">
                             <a:spcAft>
                               <a:spcPts val="1125"/>
                             </a:spcAft>
                             <a:buNone/>
                           </a:pPr>
-                          <a:endParaRPr lang="en-US" sz="2400" dirty="0">
+                          <a:endParaRPr lang="en-US" sz="3200" dirty="0">
                             <a:latin typeface="Garamond" panose="02020404030301010803" pitchFamily="18" charset="0"/>
                           </a:endParaRPr>
                         </a:p>
                         <a:p>
-                          <a:pPr algn="just">
+                          <a:pPr algn="l">
                             <a:spcAft>
                               <a:spcPts val="1125"/>
                             </a:spcAft>
                             <a:buNone/>
                           </a:pPr>
                           <a:r>
-                            <a:rPr lang="en-US" sz="2400" dirty="0">
+                            <a:rPr lang="en-US" sz="3200" dirty="0">
                               <a:latin typeface="Garamond" panose="02020404030301010803" pitchFamily="18" charset="0"/>
                             </a:rPr>
                             <a:t> Biased towards inclination of 90°</a:t>
@@ -4759,7 +4746,7 @@
                         <a:p>
                           <a:pPr algn="ctr"/>
                           <a:r>
-                            <a:rPr lang="en-US" sz="2400" b="1" dirty="0">
+                            <a:rPr lang="en-US" sz="3200" b="1" dirty="0">
                               <a:latin typeface="Garamond" panose="02020404030301010803" pitchFamily="18" charset="0"/>
                             </a:rPr>
                             <a:t>ORB6</a:t>
@@ -4768,7 +4755,7 @@
                         <a:p>
                           <a:pPr algn="l"/>
                           <a:r>
-                            <a:rPr lang="en-US" sz="2400" b="0" dirty="0">
+                            <a:rPr lang="en-US" sz="3200" b="0" dirty="0">
                               <a:latin typeface="Garamond" panose="02020404030301010803" pitchFamily="18" charset="0"/>
                             </a:rPr>
                             <a:t>We find that ORB6 is biased…</a:t>
@@ -4777,7 +4764,7 @@
                         <a:p>
                           <a:pPr algn="l"/>
                           <a:r>
-                            <a:rPr lang="en-US" sz="2400" b="0" dirty="0">
+                            <a:rPr lang="en-US" sz="3200" b="0" dirty="0">
                               <a:latin typeface="Garamond" panose="02020404030301010803" pitchFamily="18" charset="0"/>
                             </a:rPr>
                             <a:t>…towards lower eccentricities, between 0 and 0.5.. There is only a slight preference for circular orbits. </a:t>
@@ -4786,10 +4773,10 @@
                         <a:p>
                           <a:pPr algn="l"/>
                           <a:r>
-                            <a:rPr lang="en-US" sz="2400" b="0" dirty="0">
+                            <a:rPr lang="en-US" sz="3200" b="0" dirty="0">
                               <a:latin typeface="Garamond" panose="02020404030301010803" pitchFamily="18" charset="0"/>
                             </a:rPr>
-                            <a:t>Biased towards shorter periods</a:t>
+                            <a:t>… towards shorter periods</a:t>
                           </a:r>
                         </a:p>
                       </a:txBody>
@@ -4845,14 +4832,14 @@
               <p:nvPr>
                 <p:extLst>
                   <p:ext uri="{D42A27DB-BD31-4B8C-83A1-F6EECF244321}">
-                    <p14:modId xmlns:p14="http://schemas.microsoft.com/office/powerpoint/2010/main" val="2611105247"/>
+                    <p14:modId xmlns:p14="http://schemas.microsoft.com/office/powerpoint/2010/main" val="444441714"/>
                   </p:ext>
                 </p:extLst>
               </p:nvPr>
             </p:nvGraphicFramePr>
             <p:xfrm>
-              <a:off x="13547981" y="16326172"/>
-              <a:ext cx="7683486" cy="8540603"/>
+              <a:off x="13547981" y="16326173"/>
+              <a:ext cx="7683486" cy="8133582"/>
             </p:xfrm>
             <a:graphic>
               <a:graphicData uri="http://schemas.openxmlformats.org/drawingml/2006/table">
@@ -4876,7 +4863,7 @@
                       </a:extLst>
                     </a:gridCol>
                   </a:tblGrid>
-                  <a:tr h="8540603">
+                  <a:tr h="8133582">
                     <a:tc>
                       <a:txBody>
                         <a:bodyPr/>
@@ -4909,9 +4896,9 @@
                           <a:tailEnd type="none" w="med" len="med"/>
                         </a:lnB>
                         <a:blipFill>
-                          <a:blip r:embed="rId7"/>
+                          <a:blip r:embed="rId6"/>
                           <a:stretch>
-                            <a:fillRect t="-571" r="-99842" b="-71"/>
+                            <a:fillRect t="-974" r="-99842" b="-75"/>
                           </a:stretch>
                         </a:blipFill>
                       </a:tcPr>
@@ -4923,7 +4910,7 @@
                         <a:p>
                           <a:pPr algn="ctr"/>
                           <a:r>
-                            <a:rPr lang="en-US" sz="2400" b="1" dirty="0">
+                            <a:rPr lang="en-US" sz="3200" b="1" dirty="0">
                               <a:latin typeface="Garamond" panose="02020404030301010803" pitchFamily="18" charset="0"/>
                             </a:rPr>
                             <a:t>ORB6</a:t>
@@ -4932,7 +4919,7 @@
                         <a:p>
                           <a:pPr algn="l"/>
                           <a:r>
-                            <a:rPr lang="en-US" sz="2400" b="0" dirty="0">
+                            <a:rPr lang="en-US" sz="3200" b="0" dirty="0">
                               <a:latin typeface="Garamond" panose="02020404030301010803" pitchFamily="18" charset="0"/>
                             </a:rPr>
                             <a:t>We find that ORB6 is biased…</a:t>
@@ -4941,7 +4928,7 @@
                         <a:p>
                           <a:pPr algn="l"/>
                           <a:r>
-                            <a:rPr lang="en-US" sz="2400" b="0" dirty="0">
+                            <a:rPr lang="en-US" sz="3200" b="0" dirty="0">
                               <a:latin typeface="Garamond" panose="02020404030301010803" pitchFamily="18" charset="0"/>
                             </a:rPr>
                             <a:t>…towards lower eccentricities, between 0 and 0.5.. There is only a slight preference for circular orbits. </a:t>
@@ -4950,10 +4937,10 @@
                         <a:p>
                           <a:pPr algn="l"/>
                           <a:r>
-                            <a:rPr lang="en-US" sz="2400" b="0" dirty="0">
+                            <a:rPr lang="en-US" sz="3200" b="0" dirty="0">
                               <a:latin typeface="Garamond" panose="02020404030301010803" pitchFamily="18" charset="0"/>
                             </a:rPr>
-                            <a:t>Biased towards shorter periods</a:t>
+                            <a:t>… towards shorter periods</a:t>
                           </a:r>
                         </a:p>
                       </a:txBody>
@@ -5009,7 +4996,7 @@
           <p:nvPr/>
         </p:nvPicPr>
         <p:blipFill>
-          <a:blip r:embed="rId8">
+          <a:blip r:embed="rId7">
             <a:duotone>
               <a:prstClr val="black"/>
               <a:srgbClr val="F2EBE2">
@@ -5046,7 +5033,7 @@
         </p:nvSpPr>
         <p:spPr>
           <a:xfrm>
-            <a:off x="8373978" y="10931499"/>
+            <a:off x="0" y="17815727"/>
             <a:ext cx="4061707" cy="830997"/>
           </a:xfrm>
           <a:prstGeom prst="rect">
@@ -5071,57 +5058,6 @@
                 <a:latin typeface="Garamond" panose="02020404030301010803" pitchFamily="18" charset="0"/>
               </a:rPr>
               <a:t>Short description of theoretical distributions found</a:t>
-            </a:r>
-          </a:p>
-        </p:txBody>
-      </p:sp>
-      <p:sp>
-        <p:nvSpPr>
-          <p:cNvPr id="22" name="Textfeld 21">
-            <a:extLst>
-              <a:ext uri="{FF2B5EF4-FFF2-40B4-BE49-F238E27FC236}">
-                <a16:creationId xmlns:a16="http://schemas.microsoft.com/office/drawing/2014/main" id="{FF95607A-AB6C-1371-F2E6-5043AE7262D1}"/>
-              </a:ext>
-            </a:extLst>
-          </p:cNvPr>
-          <p:cNvSpPr txBox="1"/>
-          <p:nvPr/>
-        </p:nvSpPr>
-        <p:spPr>
-          <a:xfrm>
-            <a:off x="14856740" y="12270316"/>
-            <a:ext cx="4755157" cy="1938992"/>
-          </a:xfrm>
-          <a:prstGeom prst="rect">
-            <a:avLst/>
-          </a:prstGeom>
-          <a:noFill/>
-        </p:spPr>
-        <p:txBody>
-          <a:bodyPr wrap="square" rtlCol="0">
-            <a:spAutoFit/>
-          </a:bodyPr>
-          <a:lstStyle/>
-          <a:p>
-            <a:r>
-              <a:rPr lang="en-US" sz="2400" b="1" i="1" dirty="0">
-                <a:latin typeface="Garamond" panose="02020404030301010803" pitchFamily="18" charset="0"/>
-              </a:rPr>
-              <a:t>Figure 1</a:t>
-            </a:r>
-            <a:r>
-              <a:rPr lang="en-US" sz="2400" dirty="0">
-                <a:latin typeface="Garamond" panose="02020404030301010803" pitchFamily="18" charset="0"/>
-              </a:rPr>
-              <a:t>. Spectroscopic binary stars detection explained. </a:t>
-            </a:r>
-          </a:p>
-          <a:p>
-            <a:r>
-              <a:rPr lang="en-US" sz="2400" dirty="0">
-                <a:latin typeface="Garamond" panose="02020404030301010803" pitchFamily="18" charset="0"/>
-              </a:rPr>
-              <a:t>Note that from the detection method alone we can already infer some biases.</a:t>
             </a:r>
           </a:p>
         </p:txBody>
@@ -5143,14 +5079,14 @@
               <p:nvPr>
                 <p:extLst>
                   <p:ext uri="{D42A27DB-BD31-4B8C-83A1-F6EECF244321}">
-                    <p14:modId xmlns:p14="http://schemas.microsoft.com/office/powerpoint/2010/main" val="3485859075"/>
+                    <p14:modId xmlns:p14="http://schemas.microsoft.com/office/powerpoint/2010/main" val="2033232533"/>
                   </p:ext>
                 </p:extLst>
               </p:nvPr>
             </p:nvGraphicFramePr>
             <p:xfrm>
               <a:off x="274119" y="11791702"/>
-              <a:ext cx="7845519" cy="3559048"/>
+              <a:ext cx="7845519" cy="5537962"/>
             </p:xfrm>
             <a:graphic>
               <a:graphicData uri="http://schemas.openxmlformats.org/drawingml/2006/table">
@@ -5182,10 +5118,10 @@
                         <a:p>
                           <a:pPr algn="ctr"/>
                           <a:r>
-                            <a:rPr lang="en-US" sz="2400" b="1" dirty="0"/>
+                            <a:rPr lang="en-US" sz="3200" b="1" dirty="0"/>
                             <a:t>Parameter</a:t>
                           </a:r>
-                          <a:endParaRPr lang="en-US" sz="2400" b="1" dirty="0">
+                          <a:endParaRPr lang="en-US" sz="3200" b="1" dirty="0">
                             <a:latin typeface="Garamond" panose="02020404030301010803" pitchFamily="18" charset="0"/>
                           </a:endParaRPr>
                         </a:p>
@@ -5209,10 +5145,10 @@
                         <a:p>
                           <a:pPr algn="ctr"/>
                           <a:r>
-                            <a:rPr lang="en-US" sz="2400" b="1" dirty="0"/>
+                            <a:rPr lang="en-US" sz="3200" b="1" dirty="0"/>
                             <a:t>PDF</a:t>
                           </a:r>
-                          <a:endParaRPr lang="en-US" sz="2400" b="0" i="0" dirty="0">
+                          <a:endParaRPr lang="en-US" sz="3200" b="0" i="0" dirty="0">
                             <a:solidFill>
                               <a:srgbClr val="2A2A2A"/>
                             </a:solidFill>
@@ -5263,10 +5199,10 @@
                             <a:defRPr/>
                           </a:pPr>
                           <a:r>
-                            <a:rPr lang="en-US" sz="2400" b="0" dirty="0"/>
+                            <a:rPr lang="en-US" sz="3200" b="0" dirty="0"/>
                             <a:t>Eccentricity e</a:t>
                           </a:r>
-                          <a:endParaRPr lang="en-US" sz="2400" b="0" dirty="0">
+                          <a:endParaRPr lang="en-US" sz="3200" b="0" dirty="0">
                             <a:latin typeface="Garamond" panose="02020404030301010803" pitchFamily="18" charset="0"/>
                           </a:endParaRPr>
                         </a:p>
@@ -5312,32 +5248,44 @@
                               </m:oMathParaPr>
                               <m:oMath xmlns:m="http://schemas.openxmlformats.org/officeDocument/2006/math">
                                 <m:r>
-                                  <a:rPr lang="en-US" sz="2400" b="0" smtClean="0"/>
+                                  <a:rPr lang="en-US" sz="3200" b="0" smtClean="0">
+                                    <a:latin typeface="Cambria Math" panose="02040503050406030204" pitchFamily="18" charset="0"/>
+                                  </a:rPr>
                                   <m:t>𝑓</m:t>
                                 </m:r>
                                 <m:d>
                                   <m:dPr>
                                     <m:ctrlPr>
-                                      <a:rPr lang="en-US" sz="2400" b="0" smtClean="0"/>
+                                      <a:rPr lang="en-US" sz="3200" b="0" i="1" smtClean="0">
+                                        <a:latin typeface="Cambria Math" panose="02040503050406030204" pitchFamily="18" charset="0"/>
+                                      </a:rPr>
                                     </m:ctrlPr>
                                   </m:dPr>
                                   <m:e>
                                     <m:r>
-                                      <a:rPr lang="en-US" sz="2400" b="0" smtClean="0"/>
+                                      <a:rPr lang="en-US" sz="3200" b="0" smtClean="0">
+                                        <a:latin typeface="Cambria Math" panose="02040503050406030204" pitchFamily="18" charset="0"/>
+                                      </a:rPr>
                                       <m:t>𝑒</m:t>
                                     </m:r>
                                     <m:r>
-                                      <a:rPr lang="en-US" sz="2400" b="0" smtClean="0"/>
+                                      <a:rPr lang="en-US" sz="3200" b="0" smtClean="0">
+                                        <a:latin typeface="Cambria Math" panose="02040503050406030204" pitchFamily="18" charset="0"/>
+                                      </a:rPr>
                                       <m:t>|</m:t>
                                     </m:r>
                                     <m:r>
-                                      <a:rPr lang="en-US" sz="2400" b="0" smtClean="0"/>
+                                      <a:rPr lang="en-US" sz="3200" b="0" smtClean="0">
+                                        <a:latin typeface="Cambria Math" panose="02040503050406030204" pitchFamily="18" charset="0"/>
+                                      </a:rPr>
                                       <m:t>𝑎</m:t>
                                     </m:r>
                                   </m:e>
                                 </m:d>
                                 <m:r>
-                                  <a:rPr lang="en-US" sz="2400" b="0" smtClean="0"/>
+                                  <a:rPr lang="en-US" sz="3200" b="0" smtClean="0">
+                                    <a:latin typeface="Cambria Math" panose="02040503050406030204" pitchFamily="18" charset="0"/>
+                                  </a:rPr>
                                   <m:t>=</m:t>
                                 </m:r>
                                 <m:d>
@@ -5345,57 +5293,81 @@
                                     <m:begChr m:val="{"/>
                                     <m:endChr m:val=""/>
                                     <m:ctrlPr>
-                                      <a:rPr lang="en-US" sz="2400" b="0" smtClean="0"/>
+                                      <a:rPr lang="en-US" sz="3200" b="0" i="1" smtClean="0">
+                                        <a:latin typeface="Cambria Math" panose="02040503050406030204" pitchFamily="18" charset="0"/>
+                                      </a:rPr>
                                     </m:ctrlPr>
                                   </m:dPr>
                                   <m:e>
                                     <m:eqArr>
                                       <m:eqArrPr>
                                         <m:ctrlPr>
-                                          <a:rPr lang="en-US" sz="2400" b="0" smtClean="0"/>
+                                          <a:rPr lang="en-US" sz="3200" b="0" i="1" smtClean="0">
+                                            <a:latin typeface="Cambria Math" panose="02040503050406030204" pitchFamily="18" charset="0"/>
+                                          </a:rPr>
                                         </m:ctrlPr>
                                       </m:eqArrPr>
                                       <m:e>
                                         <m:r>
-                                          <a:rPr lang="en-US" sz="2400" b="0" smtClean="0"/>
+                                          <a:rPr lang="en-US" sz="3200" b="0" smtClean="0">
+                                            <a:latin typeface="Cambria Math" panose="02040503050406030204" pitchFamily="18" charset="0"/>
+                                          </a:rPr>
                                           <m:t>1        </m:t>
                                         </m:r>
                                         <m:r>
-                                          <a:rPr lang="en-US" sz="2400" b="0" smtClean="0"/>
+                                          <a:rPr lang="en-US" sz="3200" b="0" smtClean="0">
+                                            <a:latin typeface="Cambria Math" panose="02040503050406030204" pitchFamily="18" charset="0"/>
+                                          </a:rPr>
                                           <m:t>𝑎</m:t>
                                         </m:r>
                                         <m:r>
-                                          <a:rPr lang="en-US" sz="2400" b="0" smtClean="0"/>
+                                          <a:rPr lang="en-US" sz="3200" b="0" smtClean="0">
+                                            <a:latin typeface="Cambria Math" panose="02040503050406030204" pitchFamily="18" charset="0"/>
+                                          </a:rPr>
                                           <m:t>&lt;100</m:t>
                                         </m:r>
                                         <m:r>
-                                          <a:rPr lang="en-US" sz="2400" b="0" smtClean="0"/>
+                                          <a:rPr lang="en-US" sz="3200" b="0" smtClean="0">
+                                            <a:latin typeface="Cambria Math" panose="02040503050406030204" pitchFamily="18" charset="0"/>
+                                          </a:rPr>
                                           <m:t>𝐴𝑈</m:t>
                                         </m:r>
                                       </m:e>
                                       <m:e>
                                         <m:r>
-                                          <a:rPr lang="en-US" sz="2400" b="0" smtClean="0"/>
+                                          <a:rPr lang="en-US" sz="3200" b="0" smtClean="0">
+                                            <a:latin typeface="Cambria Math" panose="02040503050406030204" pitchFamily="18" charset="0"/>
+                                          </a:rPr>
                                           <m:t>2</m:t>
                                         </m:r>
                                         <m:r>
-                                          <a:rPr lang="en-US" sz="2400" b="0" smtClean="0"/>
+                                          <a:rPr lang="en-US" sz="3200" b="0" smtClean="0">
+                                            <a:latin typeface="Cambria Math" panose="02040503050406030204" pitchFamily="18" charset="0"/>
+                                          </a:rPr>
                                           <m:t>𝑒</m:t>
                                         </m:r>
                                         <m:r>
-                                          <a:rPr lang="en-US" sz="2400" b="0" smtClean="0"/>
+                                          <a:rPr lang="en-US" sz="3200" b="0" smtClean="0">
+                                            <a:latin typeface="Cambria Math" panose="02040503050406030204" pitchFamily="18" charset="0"/>
+                                          </a:rPr>
                                           <m:t>       </m:t>
                                         </m:r>
                                         <m:r>
-                                          <a:rPr lang="en-US" sz="2400" b="0" smtClean="0"/>
+                                          <a:rPr lang="en-US" sz="3200" b="0" smtClean="0">
+                                            <a:latin typeface="Cambria Math" panose="02040503050406030204" pitchFamily="18" charset="0"/>
+                                          </a:rPr>
                                           <m:t>𝑎</m:t>
                                         </m:r>
                                         <m:r>
-                                          <a:rPr lang="en-US" sz="2400" b="0" smtClean="0"/>
+                                          <a:rPr lang="en-US" sz="3200" b="0" smtClean="0">
+                                            <a:latin typeface="Cambria Math" panose="02040503050406030204" pitchFamily="18" charset="0"/>
+                                          </a:rPr>
                                           <m:t>&gt;100 </m:t>
                                         </m:r>
                                         <m:r>
-                                          <a:rPr lang="en-US" sz="2400" b="0" smtClean="0"/>
+                                          <a:rPr lang="en-US" sz="3200" b="0" smtClean="0">
+                                            <a:latin typeface="Cambria Math" panose="02040503050406030204" pitchFamily="18" charset="0"/>
+                                          </a:rPr>
                                           <m:t>𝐴𝑈</m:t>
                                         </m:r>
                                       </m:e>
@@ -5405,7 +5377,7 @@
                               </m:oMath>
                             </m:oMathPara>
                           </a14:m>
-                          <a:endParaRPr lang="en-US" sz="2400" dirty="0">
+                          <a:endParaRPr lang="en-US" sz="3200" dirty="0">
                             <a:latin typeface="Garamond" panose="02020404030301010803" pitchFamily="18" charset="0"/>
                           </a:endParaRPr>
                         </a:p>
@@ -5436,10 +5408,10 @@
                         <a:p>
                           <a:pPr algn="ctr"/>
                           <a:r>
-                            <a:rPr lang="en-US" sz="2400" b="0" dirty="0"/>
+                            <a:rPr lang="en-US" sz="3200" b="0" dirty="0"/>
                             <a:t>Mass ratio q</a:t>
                           </a:r>
-                          <a:endParaRPr lang="en-US" sz="2400" b="0" i="0" dirty="0">
+                          <a:endParaRPr lang="en-US" sz="3200" b="0" i="0" dirty="0">
                             <a:latin typeface="Garamond" panose="02020404030301010803" pitchFamily="18" charset="0"/>
                           </a:endParaRPr>
                         </a:p>
@@ -5462,7 +5434,7 @@
                         <a:lstStyle/>
                         <a:p>
                           <a:pPr algn="l"/>
-                          <a:endParaRPr lang="en-US" sz="2400" b="0" i="0" dirty="0">
+                          <a:endParaRPr lang="en-US" sz="3200" b="0" i="0" dirty="0">
                             <a:solidFill>
                               <a:srgbClr val="2A2A2A"/>
                             </a:solidFill>
@@ -5497,10 +5469,10 @@
                         <a:p>
                           <a:pPr algn="ctr"/>
                           <a:r>
-                            <a:rPr lang="en-US" sz="2400" b="0" dirty="0"/>
+                            <a:rPr lang="en-US" sz="3200" b="0" dirty="0"/>
                             <a:t>Orbital Period P</a:t>
                           </a:r>
-                          <a:endParaRPr lang="en-US" sz="2400" b="0" i="0" dirty="0">
+                          <a:endParaRPr lang="en-US" sz="3200" b="0" i="0" dirty="0">
                             <a:latin typeface="Garamond" panose="02020404030301010803" pitchFamily="18" charset="0"/>
                           </a:endParaRPr>
                         </a:p>
@@ -5523,7 +5495,7 @@
                         <a:lstStyle/>
                         <a:p>
                           <a:pPr algn="l"/>
-                          <a:endParaRPr lang="en-US" sz="2400" b="0" i="0" dirty="0">
+                          <a:endParaRPr lang="en-US" sz="3200" b="0" i="0" dirty="0">
                             <a:solidFill>
                               <a:srgbClr val="2A2A2A"/>
                             </a:solidFill>
@@ -5558,10 +5530,10 @@
                         <a:p>
                           <a:pPr algn="ctr"/>
                           <a:r>
-                            <a:rPr lang="en-US" sz="2400" b="0" dirty="0"/>
+                            <a:rPr lang="en-US" sz="3200" b="0" dirty="0"/>
                             <a:t>Semi major axis a</a:t>
                           </a:r>
-                          <a:endParaRPr lang="en-US" sz="2400" b="0" i="0" dirty="0">
+                          <a:endParaRPr lang="en-US" sz="3200" b="0" i="0" dirty="0">
                             <a:latin typeface="Garamond" panose="02020404030301010803" pitchFamily="18" charset="0"/>
                           </a:endParaRPr>
                         </a:p>
@@ -5584,7 +5556,7 @@
                         <a:lstStyle/>
                         <a:p>
                           <a:pPr algn="l"/>
-                          <a:endParaRPr lang="en-US" sz="2400" b="0" i="0" dirty="0">
+                          <a:endParaRPr lang="en-US" sz="3200" b="0" i="0" dirty="0">
                             <a:solidFill>
                               <a:srgbClr val="2A2A2A"/>
                             </a:solidFill>
@@ -5619,10 +5591,10 @@
                         <a:p>
                           <a:pPr algn="ctr"/>
                           <a:r>
-                            <a:rPr lang="en-US" sz="2400" b="0" dirty="0"/>
+                            <a:rPr lang="en-US" sz="3200" b="0" dirty="0"/>
                             <a:t>Radius ratio R</a:t>
                           </a:r>
-                          <a:endParaRPr lang="en-US" sz="2400" b="0" i="0" dirty="0">
+                          <a:endParaRPr lang="en-US" sz="3200" b="0" i="0" dirty="0">
                             <a:latin typeface="Garamond" panose="02020404030301010803" pitchFamily="18" charset="0"/>
                           </a:endParaRPr>
                         </a:p>
@@ -5645,7 +5617,7 @@
                         <a:lstStyle/>
                         <a:p>
                           <a:pPr algn="l"/>
-                          <a:endParaRPr lang="en-US" sz="2400" b="0" i="0" dirty="0">
+                          <a:endParaRPr lang="en-US" sz="3200" b="0" i="0" dirty="0">
                             <a:solidFill>
                               <a:srgbClr val="2A2A2A"/>
                             </a:solidFill>
@@ -5693,14 +5665,14 @@
               <p:nvPr>
                 <p:extLst>
                   <p:ext uri="{D42A27DB-BD31-4B8C-83A1-F6EECF244321}">
-                    <p14:modId xmlns:p14="http://schemas.microsoft.com/office/powerpoint/2010/main" val="3485859075"/>
+                    <p14:modId xmlns:p14="http://schemas.microsoft.com/office/powerpoint/2010/main" val="2033232533"/>
                   </p:ext>
                 </p:extLst>
               </p:nvPr>
             </p:nvGraphicFramePr>
             <p:xfrm>
               <a:off x="274119" y="11791702"/>
-              <a:ext cx="7845519" cy="3559048"/>
+              <a:ext cx="7845519" cy="5537962"/>
             </p:xfrm>
             <a:graphic>
               <a:graphicData uri="http://schemas.openxmlformats.org/drawingml/2006/table">
@@ -5724,7 +5696,7 @@
                       </a:extLst>
                     </a:gridCol>
                   </a:tblGrid>
-                  <a:tr h="457200">
+                  <a:tr h="579120">
                     <a:tc>
                       <a:txBody>
                         <a:bodyPr/>
@@ -5732,10 +5704,10 @@
                         <a:p>
                           <a:pPr algn="ctr"/>
                           <a:r>
-                            <a:rPr lang="en-US" sz="2400" b="1" dirty="0"/>
+                            <a:rPr lang="en-US" sz="3200" b="1" dirty="0"/>
                             <a:t>Parameter</a:t>
                           </a:r>
-                          <a:endParaRPr lang="en-US" sz="2400" b="1" dirty="0">
+                          <a:endParaRPr lang="en-US" sz="3200" b="1" dirty="0">
                             <a:latin typeface="Garamond" panose="02020404030301010803" pitchFamily="18" charset="0"/>
                           </a:endParaRPr>
                         </a:p>
@@ -5759,10 +5731,10 @@
                         <a:p>
                           <a:pPr algn="ctr"/>
                           <a:r>
-                            <a:rPr lang="en-US" sz="2400" b="1" dirty="0"/>
+                            <a:rPr lang="en-US" sz="3200" b="1" dirty="0"/>
                             <a:t>PDF</a:t>
                           </a:r>
-                          <a:endParaRPr lang="en-US" sz="2400" b="0" i="0" dirty="0">
+                          <a:endParaRPr lang="en-US" sz="3200" b="0" i="0" dirty="0">
                             <a:solidFill>
                               <a:srgbClr val="2A2A2A"/>
                             </a:solidFill>
@@ -5789,7 +5761,7 @@
                       </a:ext>
                     </a:extLst>
                   </a:tr>
-                  <a:tr h="907288">
+                  <a:tr h="1179322">
                     <a:tc>
                       <a:txBody>
                         <a:bodyPr/>
@@ -5813,10 +5785,10 @@
                             <a:defRPr/>
                           </a:pPr>
                           <a:r>
-                            <a:rPr lang="en-US" sz="2400" b="0" dirty="0"/>
+                            <a:rPr lang="en-US" sz="3200" b="0" dirty="0"/>
                             <a:t>Eccentricity e</a:t>
                           </a:r>
-                          <a:endParaRPr lang="en-US" sz="2400" b="0" dirty="0">
+                          <a:endParaRPr lang="en-US" sz="3200" b="0" dirty="0">
                             <a:latin typeface="Garamond" panose="02020404030301010803" pitchFamily="18" charset="0"/>
                           </a:endParaRPr>
                         </a:p>
@@ -5852,9 +5824,9 @@
                           <a:tailEnd type="none" w="med" len="med"/>
                         </a:lnL>
                         <a:blipFill>
-                          <a:blip r:embed="rId9"/>
+                          <a:blip r:embed="rId8"/>
                           <a:stretch>
-                            <a:fillRect l="-45209" t="-55705" b="-257047"/>
+                            <a:fillRect l="-45209" t="-55670" b="-336598"/>
                           </a:stretch>
                         </a:blipFill>
                       </a:tcPr>
@@ -5865,7 +5837,7 @@
                       </a:ext>
                     </a:extLst>
                   </a:tr>
-                  <a:tr h="457200">
+                  <a:tr h="579120">
                     <a:tc>
                       <a:txBody>
                         <a:bodyPr/>
@@ -5873,10 +5845,10 @@
                         <a:p>
                           <a:pPr algn="ctr"/>
                           <a:r>
-                            <a:rPr lang="en-US" sz="2400" b="0" dirty="0"/>
+                            <a:rPr lang="en-US" sz="3200" b="0" dirty="0"/>
                             <a:t>Mass ratio q</a:t>
                           </a:r>
-                          <a:endParaRPr lang="en-US" sz="2400" b="0" i="0" dirty="0">
+                          <a:endParaRPr lang="en-US" sz="3200" b="0" i="0" dirty="0">
                             <a:latin typeface="Garamond" panose="02020404030301010803" pitchFamily="18" charset="0"/>
                           </a:endParaRPr>
                         </a:p>
@@ -5899,7 +5871,7 @@
                         <a:lstStyle/>
                         <a:p>
                           <a:pPr algn="l"/>
-                          <a:endParaRPr lang="en-US" sz="2400" b="0" i="0" dirty="0">
+                          <a:endParaRPr lang="en-US" sz="3200" b="0" i="0" dirty="0">
                             <a:solidFill>
                               <a:srgbClr val="2A2A2A"/>
                             </a:solidFill>
@@ -5926,7 +5898,7 @@
                       </a:ext>
                     </a:extLst>
                   </a:tr>
-                  <a:tr h="457200">
+                  <a:tr h="1066800">
                     <a:tc>
                       <a:txBody>
                         <a:bodyPr/>
@@ -5934,10 +5906,10 @@
                         <a:p>
                           <a:pPr algn="ctr"/>
                           <a:r>
-                            <a:rPr lang="en-US" sz="2400" b="0" dirty="0"/>
+                            <a:rPr lang="en-US" sz="3200" b="0" dirty="0"/>
                             <a:t>Orbital Period P</a:t>
                           </a:r>
-                          <a:endParaRPr lang="en-US" sz="2400" b="0" i="0" dirty="0">
+                          <a:endParaRPr lang="en-US" sz="3200" b="0" i="0" dirty="0">
                             <a:latin typeface="Garamond" panose="02020404030301010803" pitchFamily="18" charset="0"/>
                           </a:endParaRPr>
                         </a:p>
@@ -5960,7 +5932,7 @@
                         <a:lstStyle/>
                         <a:p>
                           <a:pPr algn="l"/>
-                          <a:endParaRPr lang="en-US" sz="2400" b="0" i="0" dirty="0">
+                          <a:endParaRPr lang="en-US" sz="3200" b="0" i="0" dirty="0">
                             <a:solidFill>
                               <a:srgbClr val="2A2A2A"/>
                             </a:solidFill>
@@ -5987,7 +5959,7 @@
                       </a:ext>
                     </a:extLst>
                   </a:tr>
-                  <a:tr h="822960">
+                  <a:tr h="1066800">
                     <a:tc>
                       <a:txBody>
                         <a:bodyPr/>
@@ -5995,10 +5967,10 @@
                         <a:p>
                           <a:pPr algn="ctr"/>
                           <a:r>
-                            <a:rPr lang="en-US" sz="2400" b="0" dirty="0"/>
+                            <a:rPr lang="en-US" sz="3200" b="0" dirty="0"/>
                             <a:t>Semi major axis a</a:t>
                           </a:r>
-                          <a:endParaRPr lang="en-US" sz="2400" b="0" i="0" dirty="0">
+                          <a:endParaRPr lang="en-US" sz="3200" b="0" i="0" dirty="0">
                             <a:latin typeface="Garamond" panose="02020404030301010803" pitchFamily="18" charset="0"/>
                           </a:endParaRPr>
                         </a:p>
@@ -6021,7 +5993,7 @@
                         <a:lstStyle/>
                         <a:p>
                           <a:pPr algn="l"/>
-                          <a:endParaRPr lang="en-US" sz="2400" b="0" i="0" dirty="0">
+                          <a:endParaRPr lang="en-US" sz="3200" b="0" i="0" dirty="0">
                             <a:solidFill>
                               <a:srgbClr val="2A2A2A"/>
                             </a:solidFill>
@@ -6048,7 +6020,7 @@
                       </a:ext>
                     </a:extLst>
                   </a:tr>
-                  <a:tr h="457200">
+                  <a:tr h="1066800">
                     <a:tc>
                       <a:txBody>
                         <a:bodyPr/>
@@ -6056,10 +6028,10 @@
                         <a:p>
                           <a:pPr algn="ctr"/>
                           <a:r>
-                            <a:rPr lang="en-US" sz="2400" b="0" dirty="0"/>
+                            <a:rPr lang="en-US" sz="3200" b="0" dirty="0"/>
                             <a:t>Radius ratio R</a:t>
                           </a:r>
-                          <a:endParaRPr lang="en-US" sz="2400" b="0" i="0" dirty="0">
+                          <a:endParaRPr lang="en-US" sz="3200" b="0" i="0" dirty="0">
                             <a:latin typeface="Garamond" panose="02020404030301010803" pitchFamily="18" charset="0"/>
                           </a:endParaRPr>
                         </a:p>
@@ -6082,7 +6054,7 @@
                         <a:lstStyle/>
                         <a:p>
                           <a:pPr algn="l"/>
-                          <a:endParaRPr lang="en-US" sz="2400" b="0" i="0" dirty="0">
+                          <a:endParaRPr lang="en-US" sz="3200" b="0" i="0" dirty="0">
                             <a:solidFill>
                               <a:srgbClr val="2A2A2A"/>
                             </a:solidFill>
@@ -6129,8 +6101,8 @@
         </p:nvSpPr>
         <p:spPr>
           <a:xfrm>
-            <a:off x="365760" y="25467153"/>
-            <a:ext cx="12070080" cy="2080057"/>
+            <a:off x="136936" y="28963246"/>
+            <a:ext cx="12070080" cy="1587614"/>
           </a:xfrm>
           <a:prstGeom prst="rect">
             <a:avLst/>
@@ -6143,15 +6115,7 @@
           </a:bodyPr>
           <a:lstStyle/>
           <a:p>
-            <a:r>
-              <a:rPr lang="en-US" sz="2400" dirty="0">
-                <a:latin typeface="Garamond" panose="02020404030301010803" pitchFamily="18" charset="0"/>
-              </a:rPr>
-              <a:t>lower eccentricity orbits are easier to fully characterize. ORB6 only includes fully characterized orbits, which is dine more completely for lower eccentricities.</a:t>
-            </a:r>
-          </a:p>
-          <a:p>
-            <a:endParaRPr lang="en-US" sz="2400" dirty="0">
+            <a:endParaRPr lang="en-US" sz="3200" dirty="0">
               <a:latin typeface="Garamond" panose="02020404030301010803" pitchFamily="18" charset="0"/>
             </a:endParaRPr>
           </a:p>
@@ -6163,7 +6127,7 @@
               <a:buNone/>
             </a:pPr>
             <a:r>
-              <a:rPr lang="en-US" sz="2400" dirty="0">
+              <a:rPr lang="en-US" sz="3200" dirty="0">
                 <a:highlight>
                   <a:srgbClr val="FFFF00"/>
                 </a:highlight>
@@ -6171,7 +6135,7 @@
               </a:rPr>
               <a:t>Put conclusion here </a:t>
             </a:r>
-            <a:endParaRPr lang="en-US" sz="2400" dirty="0">
+            <a:endParaRPr lang="en-US" sz="3200" dirty="0">
               <a:solidFill>
                 <a:srgbClr val="000000"/>
               </a:solidFill>

</xml_diff>

<commit_message>
updated plots in poster
</commit_message>
<xml_diff>
--- a/Poster.pptx
+++ b/Poster.pptx
@@ -4,8 +4,12 @@
   <p:sldMasterIdLst>
     <p:sldMasterId id="2147483660" r:id="rId1"/>
   </p:sldMasterIdLst>
+  <p:notesMasterIdLst>
+    <p:notesMasterId r:id="rId4"/>
+  </p:notesMasterIdLst>
   <p:sldIdLst>
     <p:sldId id="256" r:id="rId2"/>
+    <p:sldId id="257" r:id="rId3"/>
   </p:sldIdLst>
   <p:sldSz cx="21383625" cy="30275213"/>
   <p:notesSz cx="7104063" cy="10234613"/>
@@ -116,6 +120,7 @@
 <p1510:revInfo xmlns:a="http://schemas.openxmlformats.org/drawingml/2006/main" xmlns:r="http://schemas.openxmlformats.org/officeDocument/2006/relationships" xmlns:p1510="http://schemas.microsoft.com/office/powerpoint/2015/10/main">
   <p1510:revLst>
     <p1510:client id="{311DFCA6-C4A5-40AC-B792-0C93A456EA9E}" v="345" dt="2026-05-17T16:55:04.145"/>
+    <p1510:client id="{7885A197-381A-465D-A948-96F1A941B31A}" v="114" dt="2026-05-18T07:53:14.601"/>
   </p1510:revLst>
 </p1510:revInfo>
 </file>
@@ -125,18 +130,18 @@
   <pc:docChgLst>
     <pc:chgData name="Elja Meuter" userId="b1e1bb923a19bf75" providerId="LiveId" clId="{D71E6ABD-519B-41F0-9374-E926C1080144}"/>
     <pc:docChg chg="undo redo custSel addSld delSld modSld">
-      <pc:chgData name="Elja Meuter" userId="b1e1bb923a19bf75" providerId="LiveId" clId="{D71E6ABD-519B-41F0-9374-E926C1080144}" dt="2026-05-15T06:50:52.234" v="9184" actId="255"/>
+      <pc:chgData name="Elja Meuter" userId="b1e1bb923a19bf75" providerId="LiveId" clId="{D71E6ABD-519B-41F0-9374-E926C1080144}" dt="2026-05-18T07:53:14.601" v="10873" actId="120"/>
       <pc:docMkLst>
         <pc:docMk/>
       </pc:docMkLst>
-      <pc:sldChg chg="addSp delSp modSp mod setBg">
-        <pc:chgData name="Elja Meuter" userId="b1e1bb923a19bf75" providerId="LiveId" clId="{D71E6ABD-519B-41F0-9374-E926C1080144}" dt="2026-05-15T06:50:52.234" v="9184" actId="255"/>
+      <pc:sldChg chg="addSp delSp modSp mod setBg modNotesTx">
+        <pc:chgData name="Elja Meuter" userId="b1e1bb923a19bf75" providerId="LiveId" clId="{D71E6ABD-519B-41F0-9374-E926C1080144}" dt="2026-05-18T07:53:14.601" v="10873" actId="120"/>
         <pc:sldMkLst>
           <pc:docMk/>
           <pc:sldMk cId="1631260291" sldId="256"/>
         </pc:sldMkLst>
         <pc:spChg chg="add mod">
-          <ac:chgData name="Elja Meuter" userId="b1e1bb923a19bf75" providerId="LiveId" clId="{D71E6ABD-519B-41F0-9374-E926C1080144}" dt="2026-05-15T06:46:59.220" v="9021" actId="1076"/>
+          <ac:chgData name="Elja Meuter" userId="b1e1bb923a19bf75" providerId="LiveId" clId="{D71E6ABD-519B-41F0-9374-E926C1080144}" dt="2026-05-18T07:50:38.633" v="10832" actId="207"/>
           <ac:spMkLst>
             <pc:docMk/>
             <pc:sldMk cId="1631260291" sldId="256"/>
@@ -160,7 +165,7 @@
           </ac:spMkLst>
         </pc:spChg>
         <pc:spChg chg="add mod">
-          <ac:chgData name="Elja Meuter" userId="b1e1bb923a19bf75" providerId="LiveId" clId="{D71E6ABD-519B-41F0-9374-E926C1080144}" dt="2026-05-15T06:50:52.234" v="9184" actId="255"/>
+          <ac:chgData name="Elja Meuter" userId="b1e1bb923a19bf75" providerId="LiveId" clId="{D71E6ABD-519B-41F0-9374-E926C1080144}" dt="2026-05-18T07:41:47.475" v="10368" actId="1076"/>
           <ac:spMkLst>
             <pc:docMk/>
             <pc:sldMk cId="1631260291" sldId="256"/>
@@ -175,8 +180,8 @@
             <ac:spMk id="9" creationId="{92C232B5-1E0E-ADAC-220A-118557C703BD}"/>
           </ac:spMkLst>
         </pc:spChg>
-        <pc:spChg chg="add mod">
-          <ac:chgData name="Elja Meuter" userId="b1e1bb923a19bf75" providerId="LiveId" clId="{D71E6ABD-519B-41F0-9374-E926C1080144}" dt="2026-05-15T06:49:32.147" v="9162" actId="113"/>
+        <pc:spChg chg="add del mod">
+          <ac:chgData name="Elja Meuter" userId="b1e1bb923a19bf75" providerId="LiveId" clId="{D71E6ABD-519B-41F0-9374-E926C1080144}" dt="2026-05-18T07:53:14.601" v="10873" actId="120"/>
           <ac:spMkLst>
             <pc:docMk/>
             <pc:sldMk cId="1631260291" sldId="256"/>
@@ -200,7 +205,7 @@
           </ac:spMkLst>
         </pc:spChg>
         <pc:spChg chg="add mod">
-          <ac:chgData name="Elja Meuter" userId="b1e1bb923a19bf75" providerId="LiveId" clId="{D71E6ABD-519B-41F0-9374-E926C1080144}" dt="2026-05-14T18:32:22.477" v="8493" actId="255"/>
+          <ac:chgData name="Elja Meuter" userId="b1e1bb923a19bf75" providerId="LiveId" clId="{D71E6ABD-519B-41F0-9374-E926C1080144}" dt="2026-05-18T07:51:15.521" v="10862" actId="1036"/>
           <ac:spMkLst>
             <pc:docMk/>
             <pc:sldMk cId="1631260291" sldId="256"/>
@@ -216,6 +221,22 @@
           </ac:spMkLst>
         </pc:spChg>
         <pc:spChg chg="add mod ord">
+          <ac:chgData name="Elja Meuter" userId="b1e1bb923a19bf75" providerId="LiveId" clId="{D71E6ABD-519B-41F0-9374-E926C1080144}" dt="2026-05-18T07:50:38.885" v="10833" actId="207"/>
+          <ac:spMkLst>
+            <pc:docMk/>
+            <pc:sldMk cId="1631260291" sldId="256"/>
+            <ac:spMk id="25" creationId="{77969D52-DE5C-42BF-121B-27045EB0367C}"/>
+          </ac:spMkLst>
+        </pc:spChg>
+        <pc:spChg chg="add mod">
+          <ac:chgData name="Elja Meuter" userId="b1e1bb923a19bf75" providerId="LiveId" clId="{D71E6ABD-519B-41F0-9374-E926C1080144}" dt="2026-05-18T07:41:16.945" v="10364" actId="1037"/>
+          <ac:spMkLst>
+            <pc:docMk/>
+            <pc:sldMk cId="1631260291" sldId="256"/>
+            <ac:spMk id="26" creationId="{EA8F6643-E188-E9B9-4278-A3D486B64E53}"/>
+          </ac:spMkLst>
+        </pc:spChg>
+        <pc:spChg chg="add mod ord">
           <ac:chgData name="Elja Meuter" userId="b1e1bb923a19bf75" providerId="LiveId" clId="{D71E6ABD-519B-41F0-9374-E926C1080144}" dt="2026-05-08T11:36:30.877" v="6635" actId="1076"/>
           <ac:spMkLst>
             <pc:docMk/>
@@ -224,7 +245,7 @@
           </ac:spMkLst>
         </pc:spChg>
         <pc:spChg chg="add mod ord">
-          <ac:chgData name="Elja Meuter" userId="b1e1bb923a19bf75" providerId="LiveId" clId="{D71E6ABD-519B-41F0-9374-E926C1080144}" dt="2026-05-15T06:43:40.331" v="8868" actId="1035"/>
+          <ac:chgData name="Elja Meuter" userId="b1e1bb923a19bf75" providerId="LiveId" clId="{D71E6ABD-519B-41F0-9374-E926C1080144}" dt="2026-05-18T07:32:58.015" v="9775" actId="1076"/>
           <ac:spMkLst>
             <pc:docMk/>
             <pc:sldMk cId="1631260291" sldId="256"/>
@@ -232,7 +253,7 @@
           </ac:spMkLst>
         </pc:spChg>
         <pc:spChg chg="add mod">
-          <ac:chgData name="Elja Meuter" userId="b1e1bb923a19bf75" providerId="LiveId" clId="{D71E6ABD-519B-41F0-9374-E926C1080144}" dt="2026-05-15T06:43:40.331" v="8868" actId="1035"/>
+          <ac:chgData name="Elja Meuter" userId="b1e1bb923a19bf75" providerId="LiveId" clId="{D71E6ABD-519B-41F0-9374-E926C1080144}" dt="2026-05-18T07:47:49.934" v="10758" actId="1036"/>
           <ac:spMkLst>
             <pc:docMk/>
             <pc:sldMk cId="1631260291" sldId="256"/>
@@ -256,7 +277,7 @@
           </ac:spMkLst>
         </pc:spChg>
         <pc:spChg chg="add mod">
-          <ac:chgData name="Elja Meuter" userId="b1e1bb923a19bf75" providerId="LiveId" clId="{D71E6ABD-519B-41F0-9374-E926C1080144}" dt="2026-05-08T11:01:44.828" v="5199" actId="20577"/>
+          <ac:chgData name="Elja Meuter" userId="b1e1bb923a19bf75" providerId="LiveId" clId="{D71E6ABD-519B-41F0-9374-E926C1080144}" dt="2026-05-18T07:51:03.381" v="10845" actId="1036"/>
           <ac:spMkLst>
             <pc:docMk/>
             <pc:sldMk cId="1631260291" sldId="256"/>
@@ -264,7 +285,7 @@
           </ac:spMkLst>
         </pc:spChg>
         <pc:spChg chg="add mod">
-          <ac:chgData name="Elja Meuter" userId="b1e1bb923a19bf75" providerId="LiveId" clId="{D71E6ABD-519B-41F0-9374-E926C1080144}" dt="2026-05-14T18:30:25.308" v="8412" actId="255"/>
+          <ac:chgData name="Elja Meuter" userId="b1e1bb923a19bf75" providerId="LiveId" clId="{D71E6ABD-519B-41F0-9374-E926C1080144}" dt="2026-05-18T07:47:59.364" v="10759" actId="20577"/>
           <ac:spMkLst>
             <pc:docMk/>
             <pc:sldMk cId="1631260291" sldId="256"/>
@@ -280,7 +301,7 @@
           </ac:spMkLst>
         </pc:spChg>
         <pc:spChg chg="add mod">
-          <ac:chgData name="Elja Meuter" userId="b1e1bb923a19bf75" providerId="LiveId" clId="{D71E6ABD-519B-41F0-9374-E926C1080144}" dt="2026-05-15T06:50:10.357" v="9168" actId="1076"/>
+          <ac:chgData name="Elja Meuter" userId="b1e1bb923a19bf75" providerId="LiveId" clId="{D71E6ABD-519B-41F0-9374-E926C1080144}" dt="2026-05-18T07:32:54.018" v="9774" actId="14100"/>
           <ac:spMkLst>
             <pc:docMk/>
             <pc:sldMk cId="1631260291" sldId="256"/>
@@ -288,7 +309,7 @@
           </ac:spMkLst>
         </pc:spChg>
         <pc:spChg chg="add mod">
-          <ac:chgData name="Elja Meuter" userId="b1e1bb923a19bf75" providerId="LiveId" clId="{D71E6ABD-519B-41F0-9374-E926C1080144}" dt="2026-05-15T06:49:42.863" v="9164" actId="1076"/>
+          <ac:chgData name="Elja Meuter" userId="b1e1bb923a19bf75" providerId="LiveId" clId="{D71E6ABD-519B-41F0-9374-E926C1080144}" dt="2026-05-18T07:42:25.578" v="10396" actId="6549"/>
           <ac:spMkLst>
             <pc:docMk/>
             <pc:sldMk cId="1631260291" sldId="256"/>
@@ -296,7 +317,7 @@
           </ac:spMkLst>
         </pc:spChg>
         <pc:spChg chg="add del mod">
-          <ac:chgData name="Elja Meuter" userId="b1e1bb923a19bf75" providerId="LiveId" clId="{D71E6ABD-519B-41F0-9374-E926C1080144}" dt="2026-05-15T06:42:55.471" v="8840" actId="1076"/>
+          <ac:chgData name="Elja Meuter" userId="b1e1bb923a19bf75" providerId="LiveId" clId="{D71E6ABD-519B-41F0-9374-E926C1080144}" dt="2026-05-18T07:38:03.723" v="10081" actId="1035"/>
           <ac:spMkLst>
             <pc:docMk/>
             <pc:sldMk cId="1631260291" sldId="256"/>
@@ -312,7 +333,7 @@
           </ac:spMkLst>
         </pc:spChg>
         <pc:graphicFrameChg chg="add mod modGraphic">
-          <ac:chgData name="Elja Meuter" userId="b1e1bb923a19bf75" providerId="LiveId" clId="{D71E6ABD-519B-41F0-9374-E926C1080144}" dt="2026-05-15T06:50:32.225" v="9183" actId="14100"/>
+          <ac:chgData name="Elja Meuter" userId="b1e1bb923a19bf75" providerId="LiveId" clId="{D71E6ABD-519B-41F0-9374-E926C1080144}" dt="2026-05-18T07:17:59.769" v="9190" actId="20577"/>
           <ac:graphicFrameMkLst>
             <pc:docMk/>
             <pc:sldMk cId="1631260291" sldId="256"/>
@@ -327,6 +348,22 @@
             <ac:graphicFrameMk id="16" creationId="{94399FEF-B43E-87CD-14AE-705E86E62D60}"/>
           </ac:graphicFrameMkLst>
         </pc:graphicFrameChg>
+        <pc:picChg chg="add del mod">
+          <ac:chgData name="Elja Meuter" userId="b1e1bb923a19bf75" providerId="LiveId" clId="{D71E6ABD-519B-41F0-9374-E926C1080144}" dt="2026-05-18T07:22:18.300" v="9345" actId="478"/>
+          <ac:picMkLst>
+            <pc:docMk/>
+            <pc:sldMk cId="1631260291" sldId="256"/>
+            <ac:picMk id="7" creationId="{B3FD3927-E6F9-14D1-169D-51649A6EE22A}"/>
+          </ac:picMkLst>
+        </pc:picChg>
+        <pc:picChg chg="add mod">
+          <ac:chgData name="Elja Meuter" userId="b1e1bb923a19bf75" providerId="LiveId" clId="{D71E6ABD-519B-41F0-9374-E926C1080144}" dt="2026-05-18T07:41:16.945" v="10364" actId="1037"/>
+          <ac:picMkLst>
+            <pc:docMk/>
+            <pc:sldMk cId="1631260291" sldId="256"/>
+            <ac:picMk id="14" creationId="{CE8CF416-836D-AFEE-A1C3-3C92DDBF7BAD}"/>
+          </ac:picMkLst>
+        </pc:picChg>
         <pc:picChg chg="add mod">
           <ac:chgData name="Elja Meuter" userId="b1e1bb923a19bf75" providerId="LiveId" clId="{D71E6ABD-519B-41F0-9374-E926C1080144}" dt="2026-05-08T11:07:05.910" v="5371" actId="2085"/>
           <ac:picMkLst>
@@ -335,12 +372,68 @@
             <ac:picMk id="15" creationId="{B4A26CA4-34CA-DED0-A2B6-609667DB6946}"/>
           </ac:picMkLst>
         </pc:picChg>
+        <pc:picChg chg="add del mod">
+          <ac:chgData name="Elja Meuter" userId="b1e1bb923a19bf75" providerId="LiveId" clId="{D71E6ABD-519B-41F0-9374-E926C1080144}" dt="2026-05-18T07:38:56.267" v="10083" actId="478"/>
+          <ac:picMkLst>
+            <pc:docMk/>
+            <pc:sldMk cId="1631260291" sldId="256"/>
+            <ac:picMk id="18" creationId="{3CF83738-EBA7-413C-2D17-CFA20036C084}"/>
+          </ac:picMkLst>
+        </pc:picChg>
         <pc:picChg chg="add mod">
           <ac:chgData name="Elja Meuter" userId="b1e1bb923a19bf75" providerId="LiveId" clId="{D71E6ABD-519B-41F0-9374-E926C1080144}" dt="2026-05-08T11:25:57.218" v="6227"/>
           <ac:picMkLst>
             <pc:docMk/>
             <pc:sldMk cId="1631260291" sldId="256"/>
             <ac:picMk id="20" creationId="{CBC2D1EC-58A7-8E38-5A62-5F95B4794C0D}"/>
+          </ac:picMkLst>
+        </pc:picChg>
+        <pc:picChg chg="add mod">
+          <ac:chgData name="Elja Meuter" userId="b1e1bb923a19bf75" providerId="LiveId" clId="{D71E6ABD-519B-41F0-9374-E926C1080144}" dt="2026-05-18T07:41:16.945" v="10364" actId="1037"/>
+          <ac:picMkLst>
+            <pc:docMk/>
+            <pc:sldMk cId="1631260291" sldId="256"/>
+            <ac:picMk id="21" creationId="{D1644647-075B-DFB4-CE0E-B4BEBDE89E6A}"/>
+          </ac:picMkLst>
+        </pc:picChg>
+        <pc:picChg chg="add mod">
+          <ac:chgData name="Elja Meuter" userId="b1e1bb923a19bf75" providerId="LiveId" clId="{D71E6ABD-519B-41F0-9374-E926C1080144}" dt="2026-05-18T07:41:16.945" v="10364" actId="1037"/>
+          <ac:picMkLst>
+            <pc:docMk/>
+            <pc:sldMk cId="1631260291" sldId="256"/>
+            <ac:picMk id="24" creationId="{6D2E5C82-84B6-5B08-A829-953CBFFCA94F}"/>
+          </ac:picMkLst>
+        </pc:picChg>
+        <pc:picChg chg="del mod modCrop">
+          <ac:chgData name="Elja Meuter" userId="b1e1bb923a19bf75" providerId="LiveId" clId="{D71E6ABD-519B-41F0-9374-E926C1080144}" dt="2026-05-18T07:28:42.243" v="9592" actId="478"/>
+          <ac:picMkLst>
+            <pc:docMk/>
+            <pc:sldMk cId="1631260291" sldId="256"/>
+            <ac:picMk id="28" creationId="{81D6B83C-5842-E5B0-D913-111BD46C8DC1}"/>
+          </ac:picMkLst>
+        </pc:picChg>
+        <pc:picChg chg="add mod ord modCrop">
+          <ac:chgData name="Elja Meuter" userId="b1e1bb923a19bf75" providerId="LiveId" clId="{D71E6ABD-519B-41F0-9374-E926C1080144}" dt="2026-05-18T07:41:16.945" v="10364" actId="1037"/>
+          <ac:picMkLst>
+            <pc:docMk/>
+            <pc:sldMk cId="1631260291" sldId="256"/>
+            <ac:picMk id="29" creationId="{2A130629-8A6B-D6BC-8480-73A945782973}"/>
+          </ac:picMkLst>
+        </pc:picChg>
+        <pc:picChg chg="del mod modCrop">
+          <ac:chgData name="Elja Meuter" userId="b1e1bb923a19bf75" providerId="LiveId" clId="{D71E6ABD-519B-41F0-9374-E926C1080144}" dt="2026-05-18T07:28:41.778" v="9591" actId="478"/>
+          <ac:picMkLst>
+            <pc:docMk/>
+            <pc:sldMk cId="1631260291" sldId="256"/>
+            <ac:picMk id="30" creationId="{A53BF8A8-1E80-08BE-5B95-28ABA1130BFA}"/>
+          </ac:picMkLst>
+        </pc:picChg>
+        <pc:picChg chg="del mod modCrop">
+          <ac:chgData name="Elja Meuter" userId="b1e1bb923a19bf75" providerId="LiveId" clId="{D71E6ABD-519B-41F0-9374-E926C1080144}" dt="2026-05-18T07:28:43.074" v="9593" actId="478"/>
+          <ac:picMkLst>
+            <pc:docMk/>
+            <pc:sldMk cId="1631260291" sldId="256"/>
+            <ac:picMk id="32" creationId="{B159EC36-2432-212A-875E-29EBA97128FE}"/>
           </ac:picMkLst>
         </pc:picChg>
         <pc:cxnChg chg="add mod">
@@ -352,7 +445,7 @@
           </ac:cxnSpMkLst>
         </pc:cxnChg>
         <pc:cxnChg chg="add mod">
-          <ac:chgData name="Elja Meuter" userId="b1e1bb923a19bf75" providerId="LiveId" clId="{D71E6ABD-519B-41F0-9374-E926C1080144}" dt="2026-05-15T06:48:39.050" v="9087" actId="1582"/>
+          <ac:chgData name="Elja Meuter" userId="b1e1bb923a19bf75" providerId="LiveId" clId="{D71E6ABD-519B-41F0-9374-E926C1080144}" dt="2026-05-18T07:52:09.457" v="10863" actId="14100"/>
           <ac:cxnSpMkLst>
             <pc:docMk/>
             <pc:sldMk cId="1631260291" sldId="256"/>
@@ -360,13 +453,68 @@
           </ac:cxnSpMkLst>
         </pc:cxnChg>
         <pc:cxnChg chg="add mod">
-          <ac:chgData name="Elja Meuter" userId="b1e1bb923a19bf75" providerId="LiveId" clId="{D71E6ABD-519B-41F0-9374-E926C1080144}" dt="2026-05-15T06:49:18.085" v="9161" actId="14100"/>
+          <ac:chgData name="Elja Meuter" userId="b1e1bb923a19bf75" providerId="LiveId" clId="{D71E6ABD-519B-41F0-9374-E926C1080144}" dt="2026-05-18T07:52:15.236" v="10864" actId="14100"/>
           <ac:cxnSpMkLst>
             <pc:docMk/>
             <pc:sldMk cId="1631260291" sldId="256"/>
             <ac:cxnSpMk id="23" creationId="{87701C8F-B0BD-60F4-4A76-2E0CEE344469}"/>
           </ac:cxnSpMkLst>
         </pc:cxnChg>
+      </pc:sldChg>
+      <pc:sldChg chg="addSp delSp modSp new mod">
+        <pc:chgData name="Elja Meuter" userId="b1e1bb923a19bf75" providerId="LiveId" clId="{D71E6ABD-519B-41F0-9374-E926C1080144}" dt="2026-05-18T07:28:11.472" v="9590" actId="14826"/>
+        <pc:sldMkLst>
+          <pc:docMk/>
+          <pc:sldMk cId="4112512561" sldId="257"/>
+        </pc:sldMkLst>
+        <pc:spChg chg="del">
+          <ac:chgData name="Elja Meuter" userId="b1e1bb923a19bf75" providerId="LiveId" clId="{D71E6ABD-519B-41F0-9374-E926C1080144}" dt="2026-05-18T07:22:59.559" v="9350" actId="478"/>
+          <ac:spMkLst>
+            <pc:docMk/>
+            <pc:sldMk cId="4112512561" sldId="257"/>
+            <ac:spMk id="3" creationId="{4EA1C412-FC4A-0F54-2A52-A99CE750B477}"/>
+          </ac:spMkLst>
+        </pc:spChg>
+        <pc:picChg chg="add del">
+          <ac:chgData name="Elja Meuter" userId="b1e1bb923a19bf75" providerId="LiveId" clId="{D71E6ABD-519B-41F0-9374-E926C1080144}" dt="2026-05-18T07:22:57.765" v="9349" actId="478"/>
+          <ac:picMkLst>
+            <pc:docMk/>
+            <pc:sldMk cId="4112512561" sldId="257"/>
+            <ac:picMk id="5" creationId="{5FEABE4C-2B7D-CF62-C397-095BDD4CF637}"/>
+          </ac:picMkLst>
+        </pc:picChg>
+        <pc:picChg chg="add mod">
+          <ac:chgData name="Elja Meuter" userId="b1e1bb923a19bf75" providerId="LiveId" clId="{D71E6ABD-519B-41F0-9374-E926C1080144}" dt="2026-05-18T07:24:31.077" v="9486" actId="1038"/>
+          <ac:picMkLst>
+            <pc:docMk/>
+            <pc:sldMk cId="4112512561" sldId="257"/>
+            <ac:picMk id="6" creationId="{B4A84105-F697-6038-FA53-883DE08304A8}"/>
+          </ac:picMkLst>
+        </pc:picChg>
+        <pc:picChg chg="add mod">
+          <ac:chgData name="Elja Meuter" userId="b1e1bb923a19bf75" providerId="LiveId" clId="{D71E6ABD-519B-41F0-9374-E926C1080144}" dt="2026-05-18T07:24:21.719" v="9445" actId="14100"/>
+          <ac:picMkLst>
+            <pc:docMk/>
+            <pc:sldMk cId="4112512561" sldId="257"/>
+            <ac:picMk id="7" creationId="{B005335D-76EF-FEBD-F9F4-737A0A4E4CD1}"/>
+          </ac:picMkLst>
+        </pc:picChg>
+        <pc:picChg chg="add mod ord">
+          <ac:chgData name="Elja Meuter" userId="b1e1bb923a19bf75" providerId="LiveId" clId="{D71E6ABD-519B-41F0-9374-E926C1080144}" dt="2026-05-18T07:24:42.051" v="9569" actId="1036"/>
+          <ac:picMkLst>
+            <pc:docMk/>
+            <pc:sldMk cId="4112512561" sldId="257"/>
+            <ac:picMk id="8" creationId="{308E6AF5-BDC0-98E6-7276-17E80AE90DD1}"/>
+          </ac:picMkLst>
+        </pc:picChg>
+        <pc:picChg chg="add del mod ord">
+          <ac:chgData name="Elja Meuter" userId="b1e1bb923a19bf75" providerId="LiveId" clId="{D71E6ABD-519B-41F0-9374-E926C1080144}" dt="2026-05-18T07:28:11.472" v="9590" actId="14826"/>
+          <ac:picMkLst>
+            <pc:docMk/>
+            <pc:sldMk cId="4112512561" sldId="257"/>
+            <ac:picMk id="10" creationId="{4C8B8DA4-8A9F-A571-8BDA-5BE0C92907A4}"/>
+          </ac:picMkLst>
+        </pc:picChg>
       </pc:sldChg>
     </pc:docChg>
   </pc:docChgLst>
@@ -541,6 +689,740 @@
 </pc:chgInfo>
 </file>
 
+<file path=ppt/notesMasters/notesMaster1.xml><?xml version="1.0" encoding="utf-8"?>
+<p:notesMaster xmlns:a="http://schemas.openxmlformats.org/drawingml/2006/main" xmlns:r="http://schemas.openxmlformats.org/officeDocument/2006/relationships" xmlns:p="http://schemas.openxmlformats.org/presentationml/2006/main">
+  <p:cSld>
+    <p:bg>
+      <p:bgRef idx="1001">
+        <a:schemeClr val="bg1"/>
+      </p:bgRef>
+    </p:bg>
+    <p:spTree>
+      <p:nvGrpSpPr>
+        <p:cNvPr id="1" name=""/>
+        <p:cNvGrpSpPr/>
+        <p:nvPr/>
+      </p:nvGrpSpPr>
+      <p:grpSpPr>
+        <a:xfrm>
+          <a:off x="0" y="0"/>
+          <a:ext cx="0" cy="0"/>
+          <a:chOff x="0" y="0"/>
+          <a:chExt cx="0" cy="0"/>
+        </a:xfrm>
+      </p:grpSpPr>
+      <p:sp>
+        <p:nvSpPr>
+          <p:cNvPr id="2" name="Kopfzeilenplatzhalter 1"/>
+          <p:cNvSpPr>
+            <a:spLocks noGrp="1"/>
+          </p:cNvSpPr>
+          <p:nvPr>
+            <p:ph type="hdr" sz="quarter"/>
+          </p:nvPr>
+        </p:nvSpPr>
+        <p:spPr>
+          <a:xfrm>
+            <a:off x="0" y="0"/>
+            <a:ext cx="3078163" cy="512763"/>
+          </a:xfrm>
+          <a:prstGeom prst="rect">
+            <a:avLst/>
+          </a:prstGeom>
+        </p:spPr>
+        <p:txBody>
+          <a:bodyPr vert="horz" lIns="91440" tIns="45720" rIns="91440" bIns="45720" rtlCol="0"/>
+          <a:lstStyle>
+            <a:lvl1pPr algn="l">
+              <a:defRPr sz="1200"/>
+            </a:lvl1pPr>
+          </a:lstStyle>
+          <a:p>
+            <a:endParaRPr lang="en-US"/>
+          </a:p>
+        </p:txBody>
+      </p:sp>
+      <p:sp>
+        <p:nvSpPr>
+          <p:cNvPr id="3" name="Datumsplatzhalter 2"/>
+          <p:cNvSpPr>
+            <a:spLocks noGrp="1"/>
+          </p:cNvSpPr>
+          <p:nvPr>
+            <p:ph type="dt" idx="1"/>
+          </p:nvPr>
+        </p:nvSpPr>
+        <p:spPr>
+          <a:xfrm>
+            <a:off x="4024313" y="0"/>
+            <a:ext cx="3078162" cy="512763"/>
+          </a:xfrm>
+          <a:prstGeom prst="rect">
+            <a:avLst/>
+          </a:prstGeom>
+        </p:spPr>
+        <p:txBody>
+          <a:bodyPr vert="horz" lIns="91440" tIns="45720" rIns="91440" bIns="45720" rtlCol="0"/>
+          <a:lstStyle>
+            <a:lvl1pPr algn="r">
+              <a:defRPr sz="1200"/>
+            </a:lvl1pPr>
+          </a:lstStyle>
+          <a:p>
+            <a:fld id="{00D2EB66-73ED-4501-88BB-5CA3983A06AE}" type="datetimeFigureOut">
+              <a:rPr lang="en-US" smtClean="0"/>
+              <a:t>5/18/2026</a:t>
+            </a:fld>
+            <a:endParaRPr lang="en-US"/>
+          </a:p>
+        </p:txBody>
+      </p:sp>
+      <p:sp>
+        <p:nvSpPr>
+          <p:cNvPr id="4" name="Folienbildplatzhalter 3"/>
+          <p:cNvSpPr>
+            <a:spLocks noGrp="1" noRot="1" noChangeAspect="1"/>
+          </p:cNvSpPr>
+          <p:nvPr>
+            <p:ph type="sldImg" idx="2"/>
+          </p:nvPr>
+        </p:nvSpPr>
+        <p:spPr>
+          <a:xfrm>
+            <a:off x="2333625" y="1279525"/>
+            <a:ext cx="2438400" cy="3454400"/>
+          </a:xfrm>
+          <a:prstGeom prst="rect">
+            <a:avLst/>
+          </a:prstGeom>
+          <a:noFill/>
+          <a:ln w="12700">
+            <a:solidFill>
+              <a:prstClr val="black"/>
+            </a:solidFill>
+          </a:ln>
+        </p:spPr>
+        <p:txBody>
+          <a:bodyPr vert="horz" lIns="91440" tIns="45720" rIns="91440" bIns="45720" rtlCol="0" anchor="ctr"/>
+          <a:lstStyle/>
+          <a:p>
+            <a:endParaRPr lang="en-US"/>
+          </a:p>
+        </p:txBody>
+      </p:sp>
+      <p:sp>
+        <p:nvSpPr>
+          <p:cNvPr id="5" name="Notizenplatzhalter 4"/>
+          <p:cNvSpPr>
+            <a:spLocks noGrp="1"/>
+          </p:cNvSpPr>
+          <p:nvPr>
+            <p:ph type="body" sz="quarter" idx="3"/>
+          </p:nvPr>
+        </p:nvSpPr>
+        <p:spPr>
+          <a:xfrm>
+            <a:off x="711200" y="4926013"/>
+            <a:ext cx="5683250" cy="4029075"/>
+          </a:xfrm>
+          <a:prstGeom prst="rect">
+            <a:avLst/>
+          </a:prstGeom>
+        </p:spPr>
+        <p:txBody>
+          <a:bodyPr vert="horz" lIns="91440" tIns="45720" rIns="91440" bIns="45720" rtlCol="0"/>
+          <a:lstStyle/>
+          <a:p>
+            <a:pPr lvl="0"/>
+            <a:r>
+              <a:rPr lang="de-DE"/>
+              <a:t>Mastertextformat bearbeiten</a:t>
+            </a:r>
+          </a:p>
+          <a:p>
+            <a:pPr lvl="1"/>
+            <a:r>
+              <a:rPr lang="de-DE"/>
+              <a:t>Zweite Ebene</a:t>
+            </a:r>
+          </a:p>
+          <a:p>
+            <a:pPr lvl="2"/>
+            <a:r>
+              <a:rPr lang="de-DE"/>
+              <a:t>Dritte Ebene</a:t>
+            </a:r>
+          </a:p>
+          <a:p>
+            <a:pPr lvl="3"/>
+            <a:r>
+              <a:rPr lang="de-DE"/>
+              <a:t>Vierte Ebene</a:t>
+            </a:r>
+          </a:p>
+          <a:p>
+            <a:pPr lvl="4"/>
+            <a:r>
+              <a:rPr lang="de-DE"/>
+              <a:t>Fünfte Ebene</a:t>
+            </a:r>
+            <a:endParaRPr lang="en-US"/>
+          </a:p>
+        </p:txBody>
+      </p:sp>
+      <p:sp>
+        <p:nvSpPr>
+          <p:cNvPr id="6" name="Fußzeilenplatzhalter 5"/>
+          <p:cNvSpPr>
+            <a:spLocks noGrp="1"/>
+          </p:cNvSpPr>
+          <p:nvPr>
+            <p:ph type="ftr" sz="quarter" idx="4"/>
+          </p:nvPr>
+        </p:nvSpPr>
+        <p:spPr>
+          <a:xfrm>
+            <a:off x="0" y="9721850"/>
+            <a:ext cx="3078163" cy="512763"/>
+          </a:xfrm>
+          <a:prstGeom prst="rect">
+            <a:avLst/>
+          </a:prstGeom>
+        </p:spPr>
+        <p:txBody>
+          <a:bodyPr vert="horz" lIns="91440" tIns="45720" rIns="91440" bIns="45720" rtlCol="0" anchor="b"/>
+          <a:lstStyle>
+            <a:lvl1pPr algn="l">
+              <a:defRPr sz="1200"/>
+            </a:lvl1pPr>
+          </a:lstStyle>
+          <a:p>
+            <a:endParaRPr lang="en-US"/>
+          </a:p>
+        </p:txBody>
+      </p:sp>
+      <p:sp>
+        <p:nvSpPr>
+          <p:cNvPr id="7" name="Foliennummernplatzhalter 6"/>
+          <p:cNvSpPr>
+            <a:spLocks noGrp="1"/>
+          </p:cNvSpPr>
+          <p:nvPr>
+            <p:ph type="sldNum" sz="quarter" idx="5"/>
+          </p:nvPr>
+        </p:nvSpPr>
+        <p:spPr>
+          <a:xfrm>
+            <a:off x="4024313" y="9721850"/>
+            <a:ext cx="3078162" cy="512763"/>
+          </a:xfrm>
+          <a:prstGeom prst="rect">
+            <a:avLst/>
+          </a:prstGeom>
+        </p:spPr>
+        <p:txBody>
+          <a:bodyPr vert="horz" lIns="91440" tIns="45720" rIns="91440" bIns="45720" rtlCol="0" anchor="b"/>
+          <a:lstStyle>
+            <a:lvl1pPr algn="r">
+              <a:defRPr sz="1200"/>
+            </a:lvl1pPr>
+          </a:lstStyle>
+          <a:p>
+            <a:fld id="{1C45D65C-AA27-466F-A034-108F18461898}" type="slidenum">
+              <a:rPr lang="en-US" smtClean="0"/>
+              <a:t>‹Nr.›</a:t>
+            </a:fld>
+            <a:endParaRPr lang="en-US"/>
+          </a:p>
+        </p:txBody>
+      </p:sp>
+    </p:spTree>
+    <p:extLst>
+      <p:ext uri="{BB962C8B-B14F-4D97-AF65-F5344CB8AC3E}">
+        <p14:creationId xmlns:p14="http://schemas.microsoft.com/office/powerpoint/2010/main" val="1231647185"/>
+      </p:ext>
+    </p:extLst>
+  </p:cSld>
+  <p:clrMap bg1="lt1" tx1="dk1" bg2="lt2" tx2="dk2" accent1="accent1" accent2="accent2" accent3="accent3" accent4="accent4" accent5="accent5" accent6="accent6" hlink="hlink" folHlink="folHlink"/>
+  <p:notesStyle>
+    <a:lvl1pPr marL="0" algn="l" defTabSz="914400" rtl="0" eaLnBrk="1" latinLnBrk="0" hangingPunct="1">
+      <a:defRPr sz="1200" kern="1200">
+        <a:solidFill>
+          <a:schemeClr val="tx1"/>
+        </a:solidFill>
+        <a:latin typeface="+mn-lt"/>
+        <a:ea typeface="+mn-ea"/>
+        <a:cs typeface="+mn-cs"/>
+      </a:defRPr>
+    </a:lvl1pPr>
+    <a:lvl2pPr marL="457200" algn="l" defTabSz="914400" rtl="0" eaLnBrk="1" latinLnBrk="0" hangingPunct="1">
+      <a:defRPr sz="1200" kern="1200">
+        <a:solidFill>
+          <a:schemeClr val="tx1"/>
+        </a:solidFill>
+        <a:latin typeface="+mn-lt"/>
+        <a:ea typeface="+mn-ea"/>
+        <a:cs typeface="+mn-cs"/>
+      </a:defRPr>
+    </a:lvl2pPr>
+    <a:lvl3pPr marL="914400" algn="l" defTabSz="914400" rtl="0" eaLnBrk="1" latinLnBrk="0" hangingPunct="1">
+      <a:defRPr sz="1200" kern="1200">
+        <a:solidFill>
+          <a:schemeClr val="tx1"/>
+        </a:solidFill>
+        <a:latin typeface="+mn-lt"/>
+        <a:ea typeface="+mn-ea"/>
+        <a:cs typeface="+mn-cs"/>
+      </a:defRPr>
+    </a:lvl3pPr>
+    <a:lvl4pPr marL="1371600" algn="l" defTabSz="914400" rtl="0" eaLnBrk="1" latinLnBrk="0" hangingPunct="1">
+      <a:defRPr sz="1200" kern="1200">
+        <a:solidFill>
+          <a:schemeClr val="tx1"/>
+        </a:solidFill>
+        <a:latin typeface="+mn-lt"/>
+        <a:ea typeface="+mn-ea"/>
+        <a:cs typeface="+mn-cs"/>
+      </a:defRPr>
+    </a:lvl4pPr>
+    <a:lvl5pPr marL="1828800" algn="l" defTabSz="914400" rtl="0" eaLnBrk="1" latinLnBrk="0" hangingPunct="1">
+      <a:defRPr sz="1200" kern="1200">
+        <a:solidFill>
+          <a:schemeClr val="tx1"/>
+        </a:solidFill>
+        <a:latin typeface="+mn-lt"/>
+        <a:ea typeface="+mn-ea"/>
+        <a:cs typeface="+mn-cs"/>
+      </a:defRPr>
+    </a:lvl5pPr>
+    <a:lvl6pPr marL="2286000" algn="l" defTabSz="914400" rtl="0" eaLnBrk="1" latinLnBrk="0" hangingPunct="1">
+      <a:defRPr sz="1200" kern="1200">
+        <a:solidFill>
+          <a:schemeClr val="tx1"/>
+        </a:solidFill>
+        <a:latin typeface="+mn-lt"/>
+        <a:ea typeface="+mn-ea"/>
+        <a:cs typeface="+mn-cs"/>
+      </a:defRPr>
+    </a:lvl6pPr>
+    <a:lvl7pPr marL="2743200" algn="l" defTabSz="914400" rtl="0" eaLnBrk="1" latinLnBrk="0" hangingPunct="1">
+      <a:defRPr sz="1200" kern="1200">
+        <a:solidFill>
+          <a:schemeClr val="tx1"/>
+        </a:solidFill>
+        <a:latin typeface="+mn-lt"/>
+        <a:ea typeface="+mn-ea"/>
+        <a:cs typeface="+mn-cs"/>
+      </a:defRPr>
+    </a:lvl7pPr>
+    <a:lvl8pPr marL="3200400" algn="l" defTabSz="914400" rtl="0" eaLnBrk="1" latinLnBrk="0" hangingPunct="1">
+      <a:defRPr sz="1200" kern="1200">
+        <a:solidFill>
+          <a:schemeClr val="tx1"/>
+        </a:solidFill>
+        <a:latin typeface="+mn-lt"/>
+        <a:ea typeface="+mn-ea"/>
+        <a:cs typeface="+mn-cs"/>
+      </a:defRPr>
+    </a:lvl8pPr>
+    <a:lvl9pPr marL="3657600" algn="l" defTabSz="914400" rtl="0" eaLnBrk="1" latinLnBrk="0" hangingPunct="1">
+      <a:defRPr sz="1200" kern="1200">
+        <a:solidFill>
+          <a:schemeClr val="tx1"/>
+        </a:solidFill>
+        <a:latin typeface="+mn-lt"/>
+        <a:ea typeface="+mn-ea"/>
+        <a:cs typeface="+mn-cs"/>
+      </a:defRPr>
+    </a:lvl9pPr>
+  </p:notesStyle>
+</p:notesMaster>
+</file>
+
+<file path=ppt/notesSlides/notesSlide1.xml><?xml version="1.0" encoding="utf-8"?>
+<p:notes xmlns:a="http://schemas.openxmlformats.org/drawingml/2006/main" xmlns:r="http://schemas.openxmlformats.org/officeDocument/2006/relationships" xmlns:p="http://schemas.openxmlformats.org/presentationml/2006/main">
+  <p:cSld>
+    <p:spTree>
+      <p:nvGrpSpPr>
+        <p:cNvPr id="1" name=""/>
+        <p:cNvGrpSpPr/>
+        <p:nvPr/>
+      </p:nvGrpSpPr>
+      <p:grpSpPr>
+        <a:xfrm>
+          <a:off x="0" y="0"/>
+          <a:ext cx="0" cy="0"/>
+          <a:chOff x="0" y="0"/>
+          <a:chExt cx="0" cy="0"/>
+        </a:xfrm>
+      </p:grpSpPr>
+      <p:sp>
+        <p:nvSpPr>
+          <p:cNvPr id="2" name="Folienbildplatzhalter 1"/>
+          <p:cNvSpPr>
+            <a:spLocks noGrp="1" noRot="1" noChangeAspect="1"/>
+          </p:cNvSpPr>
+          <p:nvPr>
+            <p:ph type="sldImg"/>
+          </p:nvPr>
+        </p:nvSpPr>
+        <p:spPr/>
+      </p:sp>
+      <mc:AlternateContent xmlns:mc="http://schemas.openxmlformats.org/markup-compatibility/2006">
+        <mc:Choice xmlns:a14="http://schemas.microsoft.com/office/drawing/2010/main" Requires="a14">
+          <p:sp>
+            <p:nvSpPr>
+              <p:cNvPr id="3" name="Notizenplatzhalter 2"/>
+              <p:cNvSpPr>
+                <a:spLocks noGrp="1"/>
+              </p:cNvSpPr>
+              <p:nvPr>
+                <p:ph type="body" idx="1"/>
+              </p:nvPr>
+            </p:nvSpPr>
+            <p:spPr/>
+            <p:txBody>
+              <a:bodyPr/>
+              <a:lstStyle/>
+              <a:p>
+                <a:r>
+                  <a:rPr lang="en-US" sz="3200" b="1" dirty="0"/>
+                  <a:t>Results</a:t>
+                </a:r>
+                <a:r>
+                  <a:rPr lang="en-US" dirty="0"/>
+                  <a:t> </a:t>
+                </a:r>
+              </a:p>
+              <a:p>
+                <a:r>
+                  <a:rPr kumimoji="0" lang="en-US" sz="1200" i="0" u="none" strike="noStrike" kern="1200" cap="none" spc="0" normalizeH="0" baseline="0" noProof="0" dirty="0">
+                    <a:ln>
+                      <a:noFill/>
+                    </a:ln>
+                    <a:solidFill>
+                      <a:prstClr val="black"/>
+                    </a:solidFill>
+                    <a:effectLst/>
+                    <a:uLnTx/>
+                    <a:uFillTx/>
+                    <a:latin typeface="Garamond" panose="02020404030301010803" pitchFamily="18" charset="0"/>
+                    <a:ea typeface="+mn-ea"/>
+                    <a:cs typeface="+mn-cs"/>
+                  </a:rPr>
+                  <a:t>We find that SB9 is  biased </a:t>
+                </a:r>
+                <a:r>
+                  <a:rPr kumimoji="0" lang="en-US" sz="1200" b="0" i="0" u="none" strike="noStrike" kern="1200" cap="none" spc="0" normalizeH="0" baseline="0" noProof="0" dirty="0">
+                    <a:ln>
+                      <a:noFill/>
+                    </a:ln>
+                    <a:solidFill>
+                      <a:prstClr val="black"/>
+                    </a:solidFill>
+                    <a:effectLst/>
+                    <a:uLnTx/>
+                    <a:uFillTx/>
+                    <a:latin typeface="Garamond" panose="02020404030301010803" pitchFamily="18" charset="0"/>
+                    <a:ea typeface="+mn-ea"/>
+                    <a:cs typeface="+mn-cs"/>
+                  </a:rPr>
+                  <a:t>towards lower eccentricities,</a:t>
+                </a:r>
+              </a:p>
+              <a:p>
+                <a:r>
+                  <a:rPr kumimoji="0" lang="en-US" sz="1200" b="0" i="0" u="none" strike="noStrike" kern="1200" cap="none" spc="0" normalizeH="0" baseline="0" noProof="0" dirty="0">
+                    <a:ln>
+                      <a:noFill/>
+                    </a:ln>
+                    <a:solidFill>
+                      <a:prstClr val="black"/>
+                    </a:solidFill>
+                    <a:effectLst/>
+                    <a:uLnTx/>
+                    <a:uFillTx/>
+                    <a:latin typeface="Garamond" panose="02020404030301010803" pitchFamily="18" charset="0"/>
+                    <a:ea typeface="+mn-ea"/>
+                    <a:cs typeface="+mn-cs"/>
+                  </a:rPr>
+                  <a:t> with a very strong preference for </a:t>
+                </a:r>
+                <a14:m>
+                  <m:oMath xmlns:m="http://schemas.openxmlformats.org/officeDocument/2006/math">
+                    <m:r>
+                      <a:rPr kumimoji="0" lang="en-US" sz="1200" b="0" i="1" u="none" strike="noStrike" kern="1200" cap="none" spc="0" normalizeH="0" baseline="0" noProof="0">
+                        <a:ln>
+                          <a:noFill/>
+                        </a:ln>
+                        <a:solidFill>
+                          <a:prstClr val="black"/>
+                        </a:solidFill>
+                        <a:effectLst/>
+                        <a:uLnTx/>
+                        <a:uFillTx/>
+                        <a:latin typeface="Cambria Math" panose="02040503050406030204" pitchFamily="18" charset="0"/>
+                        <a:ea typeface="+mn-ea"/>
+                        <a:cs typeface="+mn-cs"/>
+                      </a:rPr>
+                      <m:t>𝑒</m:t>
+                    </m:r>
+                    <m:r>
+                      <a:rPr kumimoji="0" lang="en-US" sz="1200" b="0" i="1" u="none" strike="noStrike" kern="1200" cap="none" spc="0" normalizeH="0" baseline="0" noProof="0">
+                        <a:ln>
+                          <a:noFill/>
+                        </a:ln>
+                        <a:solidFill>
+                          <a:prstClr val="black"/>
+                        </a:solidFill>
+                        <a:effectLst/>
+                        <a:uLnTx/>
+                        <a:uFillTx/>
+                        <a:latin typeface="Cambria Math" panose="02040503050406030204" pitchFamily="18" charset="0"/>
+                        <a:ea typeface="+mn-ea"/>
+                        <a:cs typeface="+mn-cs"/>
+                      </a:rPr>
+                      <m:t>=0</m:t>
+                    </m:r>
+                  </m:oMath>
+                </a14:m>
+                <a:r>
+                  <a:rPr kumimoji="0" lang="en-US" sz="1200" b="0" i="0" u="none" strike="noStrike" kern="1200" cap="none" spc="0" normalizeH="0" baseline="0" noProof="0" dirty="0">
+                    <a:ln>
+                      <a:noFill/>
+                    </a:ln>
+                    <a:solidFill>
+                      <a:prstClr val="black"/>
+                    </a:solidFill>
+                    <a:effectLst/>
+                    <a:uLnTx/>
+                    <a:uFillTx/>
+                    <a:latin typeface="Garamond" panose="02020404030301010803" pitchFamily="18" charset="0"/>
+                    <a:ea typeface="+mn-ea"/>
+                    <a:cs typeface="+mn-cs"/>
+                  </a:rPr>
+                  <a:t>. ORB6 is biased</a:t>
+                </a:r>
+                <a:r>
+                  <a:rPr kumimoji="0" lang="en-US" sz="1200" b="0" i="0" u="none" strike="noStrike" kern="1200" cap="none" spc="0" normalizeH="0" noProof="0" dirty="0">
+                    <a:ln>
+                      <a:noFill/>
+                    </a:ln>
+                    <a:solidFill>
+                      <a:prstClr val="black"/>
+                    </a:solidFill>
+                    <a:effectLst/>
+                    <a:uLnTx/>
+                    <a:uFillTx/>
+                    <a:latin typeface="Garamond" panose="02020404030301010803" pitchFamily="18" charset="0"/>
+                    <a:ea typeface="+mn-ea"/>
+                    <a:cs typeface="+mn-cs"/>
+                  </a:rPr>
+                  <a:t> </a:t>
+                </a:r>
+              </a:p>
+              <a:p>
+                <a:r>
+                  <a:rPr lang="en-US" sz="1200" dirty="0">
+                    <a:latin typeface="Garamond" panose="02020404030301010803" pitchFamily="18" charset="0"/>
+                  </a:rPr>
+                  <a:t>We find that ORB6 is biased towards middle eccentricities, between 0.2 and 0.6.. There is a preference for circular orbits. It is also biased towards shorter periods</a:t>
+                </a:r>
+              </a:p>
+              <a:p>
+                <a:endParaRPr lang="en-US" dirty="0"/>
+              </a:p>
+              <a:p>
+                <a:endParaRPr lang="en-US" dirty="0"/>
+              </a:p>
+            </p:txBody>
+          </p:sp>
+        </mc:Choice>
+        <mc:Fallback>
+          <p:sp>
+            <p:nvSpPr>
+              <p:cNvPr id="3" name="Notizenplatzhalter 2"/>
+              <p:cNvSpPr>
+                <a:spLocks noGrp="1"/>
+              </p:cNvSpPr>
+              <p:nvPr>
+                <p:ph type="body" idx="1"/>
+              </p:nvPr>
+            </p:nvSpPr>
+            <p:spPr/>
+            <p:txBody>
+              <a:bodyPr/>
+              <a:lstStyle/>
+              <a:p>
+                <a:r>
+                  <a:rPr lang="en-US" sz="3200" b="1" dirty="0"/>
+                  <a:t>Results</a:t>
+                </a:r>
+                <a:r>
+                  <a:rPr lang="en-US" dirty="0"/>
+                  <a:t> </a:t>
+                </a:r>
+              </a:p>
+              <a:p>
+                <a:r>
+                  <a:rPr kumimoji="0" lang="en-US" sz="1200" i="0" u="none" strike="noStrike" kern="1200" cap="none" spc="0" normalizeH="0" baseline="0" noProof="0" dirty="0">
+                    <a:ln>
+                      <a:noFill/>
+                    </a:ln>
+                    <a:solidFill>
+                      <a:prstClr val="black"/>
+                    </a:solidFill>
+                    <a:effectLst/>
+                    <a:uLnTx/>
+                    <a:uFillTx/>
+                    <a:latin typeface="Garamond" panose="02020404030301010803" pitchFamily="18" charset="0"/>
+                    <a:ea typeface="+mn-ea"/>
+                    <a:cs typeface="+mn-cs"/>
+                  </a:rPr>
+                  <a:t>We find that SB9 is  biased </a:t>
+                </a:r>
+                <a:r>
+                  <a:rPr kumimoji="0" lang="en-US" sz="1200" b="0" i="0" u="none" strike="noStrike" kern="1200" cap="none" spc="0" normalizeH="0" baseline="0" noProof="0" dirty="0">
+                    <a:ln>
+                      <a:noFill/>
+                    </a:ln>
+                    <a:solidFill>
+                      <a:prstClr val="black"/>
+                    </a:solidFill>
+                    <a:effectLst/>
+                    <a:uLnTx/>
+                    <a:uFillTx/>
+                    <a:latin typeface="Garamond" panose="02020404030301010803" pitchFamily="18" charset="0"/>
+                    <a:ea typeface="+mn-ea"/>
+                    <a:cs typeface="+mn-cs"/>
+                  </a:rPr>
+                  <a:t>towards lower eccentricities,</a:t>
+                </a:r>
+              </a:p>
+              <a:p>
+                <a:r>
+                  <a:rPr kumimoji="0" lang="en-US" sz="1200" b="0" i="0" u="none" strike="noStrike" kern="1200" cap="none" spc="0" normalizeH="0" baseline="0" noProof="0" dirty="0">
+                    <a:ln>
+                      <a:noFill/>
+                    </a:ln>
+                    <a:solidFill>
+                      <a:prstClr val="black"/>
+                    </a:solidFill>
+                    <a:effectLst/>
+                    <a:uLnTx/>
+                    <a:uFillTx/>
+                    <a:latin typeface="Garamond" panose="02020404030301010803" pitchFamily="18" charset="0"/>
+                    <a:ea typeface="+mn-ea"/>
+                    <a:cs typeface="+mn-cs"/>
+                  </a:rPr>
+                  <a:t> with a very strong preference for </a:t>
+                </a:r>
+                <a:r>
+                  <a:rPr kumimoji="0" lang="en-US" sz="1200" b="0" i="0" u="none" strike="noStrike" kern="1200" cap="none" spc="0" normalizeH="0" baseline="0" noProof="0">
+                    <a:ln>
+                      <a:noFill/>
+                    </a:ln>
+                    <a:solidFill>
+                      <a:prstClr val="black"/>
+                    </a:solidFill>
+                    <a:effectLst/>
+                    <a:uLnTx/>
+                    <a:uFillTx/>
+                    <a:latin typeface="Cambria Math" panose="02040503050406030204" pitchFamily="18" charset="0"/>
+                    <a:ea typeface="+mn-ea"/>
+                    <a:cs typeface="+mn-cs"/>
+                  </a:rPr>
+                  <a:t>𝑒=0</a:t>
+                </a:r>
+                <a:r>
+                  <a:rPr kumimoji="0" lang="en-US" sz="1200" b="0" i="0" u="none" strike="noStrike" kern="1200" cap="none" spc="0" normalizeH="0" baseline="0" noProof="0" dirty="0">
+                    <a:ln>
+                      <a:noFill/>
+                    </a:ln>
+                    <a:solidFill>
+                      <a:prstClr val="black"/>
+                    </a:solidFill>
+                    <a:effectLst/>
+                    <a:uLnTx/>
+                    <a:uFillTx/>
+                    <a:latin typeface="Garamond" panose="02020404030301010803" pitchFamily="18" charset="0"/>
+                    <a:ea typeface="+mn-ea"/>
+                    <a:cs typeface="+mn-cs"/>
+                  </a:rPr>
+                  <a:t>. ORB6 is biased</a:t>
+                </a:r>
+                <a:r>
+                  <a:rPr kumimoji="0" lang="en-US" sz="1200" b="0" i="0" u="none" strike="noStrike" kern="1200" cap="none" spc="0" normalizeH="0" noProof="0" dirty="0">
+                    <a:ln>
+                      <a:noFill/>
+                    </a:ln>
+                    <a:solidFill>
+                      <a:prstClr val="black"/>
+                    </a:solidFill>
+                    <a:effectLst/>
+                    <a:uLnTx/>
+                    <a:uFillTx/>
+                    <a:latin typeface="Garamond" panose="02020404030301010803" pitchFamily="18" charset="0"/>
+                    <a:ea typeface="+mn-ea"/>
+                    <a:cs typeface="+mn-cs"/>
+                  </a:rPr>
+                  <a:t> </a:t>
+                </a:r>
+              </a:p>
+              <a:p>
+                <a:r>
+                  <a:rPr lang="en-US" sz="1200" dirty="0">
+                    <a:latin typeface="Garamond" panose="02020404030301010803" pitchFamily="18" charset="0"/>
+                  </a:rPr>
+                  <a:t>We find that ORB6 is biased towards middle eccentricities, between 0.2 and 0.6.. There is a preference for circular orbits. It is also biased towards shorter periods</a:t>
+                </a:r>
+              </a:p>
+              <a:p>
+                <a:endParaRPr lang="en-US" dirty="0"/>
+              </a:p>
+              <a:p>
+                <a:endParaRPr lang="en-US" dirty="0"/>
+              </a:p>
+            </p:txBody>
+          </p:sp>
+        </mc:Fallback>
+      </mc:AlternateContent>
+      <p:sp>
+        <p:nvSpPr>
+          <p:cNvPr id="4" name="Foliennummernplatzhalter 3"/>
+          <p:cNvSpPr>
+            <a:spLocks noGrp="1"/>
+          </p:cNvSpPr>
+          <p:nvPr>
+            <p:ph type="sldNum" sz="quarter" idx="5"/>
+          </p:nvPr>
+        </p:nvSpPr>
+        <p:spPr/>
+        <p:txBody>
+          <a:bodyPr/>
+          <a:lstStyle/>
+          <a:p>
+            <a:fld id="{1C45D65C-AA27-466F-A034-108F18461898}" type="slidenum">
+              <a:rPr lang="en-US" smtClean="0"/>
+              <a:t>1</a:t>
+            </a:fld>
+            <a:endParaRPr lang="en-US"/>
+          </a:p>
+        </p:txBody>
+      </p:sp>
+    </p:spTree>
+    <p:extLst>
+      <p:ext uri="{BB962C8B-B14F-4D97-AF65-F5344CB8AC3E}">
+        <p14:creationId xmlns:p14="http://schemas.microsoft.com/office/powerpoint/2010/main" val="3126494380"/>
+      </p:ext>
+    </p:extLst>
+  </p:cSld>
+  <p:clrMapOvr>
+    <a:masterClrMapping/>
+  </p:clrMapOvr>
+</p:notes>
+</file>
+
 <file path=ppt/slideLayouts/slideLayout1.xml><?xml version="1.0" encoding="utf-8"?>
 <p:sldLayout xmlns:a="http://schemas.openxmlformats.org/drawingml/2006/main" xmlns:r="http://schemas.openxmlformats.org/officeDocument/2006/relationships" xmlns:p="http://schemas.openxmlformats.org/presentationml/2006/main" type="title" preserve="1">
   <p:cSld name="Titelfolie">
@@ -672,7 +1554,7 @@
           <a:p>
             <a:fld id="{A1915611-89FC-422F-9E33-70C527C3BC07}" type="datetimeFigureOut">
               <a:rPr lang="en-US" smtClean="0"/>
-              <a:t>5/17/2026</a:t>
+              <a:t>5/18/2026</a:t>
             </a:fld>
             <a:endParaRPr lang="en-US"/>
           </a:p>
@@ -714,7 +1596,7 @@
           <a:p>
             <a:fld id="{0DD496AA-A241-456D-9BED-07627A88E3ED}" type="slidenum">
               <a:rPr lang="en-US" smtClean="0"/>
-              <a:t>‹nr.›</a:t>
+              <a:t>‹Nr.›</a:t>
             </a:fld>
             <a:endParaRPr lang="en-US"/>
           </a:p>
@@ -842,7 +1724,7 @@
           <a:p>
             <a:fld id="{A1915611-89FC-422F-9E33-70C527C3BC07}" type="datetimeFigureOut">
               <a:rPr lang="en-US" smtClean="0"/>
-              <a:t>5/17/2026</a:t>
+              <a:t>5/18/2026</a:t>
             </a:fld>
             <a:endParaRPr lang="en-US"/>
           </a:p>
@@ -884,7 +1766,7 @@
           <a:p>
             <a:fld id="{0DD496AA-A241-456D-9BED-07627A88E3ED}" type="slidenum">
               <a:rPr lang="en-US" smtClean="0"/>
-              <a:t>‹nr.›</a:t>
+              <a:t>‹Nr.›</a:t>
             </a:fld>
             <a:endParaRPr lang="en-US"/>
           </a:p>
@@ -1022,7 +1904,7 @@
           <a:p>
             <a:fld id="{A1915611-89FC-422F-9E33-70C527C3BC07}" type="datetimeFigureOut">
               <a:rPr lang="en-US" smtClean="0"/>
-              <a:t>5/17/2026</a:t>
+              <a:t>5/18/2026</a:t>
             </a:fld>
             <a:endParaRPr lang="en-US"/>
           </a:p>
@@ -1064,7 +1946,7 @@
           <a:p>
             <a:fld id="{0DD496AA-A241-456D-9BED-07627A88E3ED}" type="slidenum">
               <a:rPr lang="en-US" smtClean="0"/>
-              <a:t>‹nr.›</a:t>
+              <a:t>‹Nr.›</a:t>
             </a:fld>
             <a:endParaRPr lang="en-US"/>
           </a:p>
@@ -1192,7 +2074,7 @@
           <a:p>
             <a:fld id="{A1915611-89FC-422F-9E33-70C527C3BC07}" type="datetimeFigureOut">
               <a:rPr lang="en-US" smtClean="0"/>
-              <a:t>5/17/2026</a:t>
+              <a:t>5/18/2026</a:t>
             </a:fld>
             <a:endParaRPr lang="en-US"/>
           </a:p>
@@ -1234,7 +2116,7 @@
           <a:p>
             <a:fld id="{0DD496AA-A241-456D-9BED-07627A88E3ED}" type="slidenum">
               <a:rPr lang="en-US" smtClean="0"/>
-              <a:t>‹nr.›</a:t>
+              <a:t>‹Nr.›</a:t>
             </a:fld>
             <a:endParaRPr lang="en-US"/>
           </a:p>
@@ -1438,7 +2320,7 @@
           <a:p>
             <a:fld id="{A1915611-89FC-422F-9E33-70C527C3BC07}" type="datetimeFigureOut">
               <a:rPr lang="en-US" smtClean="0"/>
-              <a:t>5/17/2026</a:t>
+              <a:t>5/18/2026</a:t>
             </a:fld>
             <a:endParaRPr lang="en-US"/>
           </a:p>
@@ -1480,7 +2362,7 @@
           <a:p>
             <a:fld id="{0DD496AA-A241-456D-9BED-07627A88E3ED}" type="slidenum">
               <a:rPr lang="en-US" smtClean="0"/>
-              <a:t>‹nr.›</a:t>
+              <a:t>‹Nr.›</a:t>
             </a:fld>
             <a:endParaRPr lang="en-US"/>
           </a:p>
@@ -1670,7 +2552,7 @@
           <a:p>
             <a:fld id="{A1915611-89FC-422F-9E33-70C527C3BC07}" type="datetimeFigureOut">
               <a:rPr lang="en-US" smtClean="0"/>
-              <a:t>5/17/2026</a:t>
+              <a:t>5/18/2026</a:t>
             </a:fld>
             <a:endParaRPr lang="en-US"/>
           </a:p>
@@ -1712,7 +2594,7 @@
           <a:p>
             <a:fld id="{0DD496AA-A241-456D-9BED-07627A88E3ED}" type="slidenum">
               <a:rPr lang="en-US" smtClean="0"/>
-              <a:t>‹nr.›</a:t>
+              <a:t>‹Nr.›</a:t>
             </a:fld>
             <a:endParaRPr lang="en-US"/>
           </a:p>
@@ -2037,7 +2919,7 @@
           <a:p>
             <a:fld id="{A1915611-89FC-422F-9E33-70C527C3BC07}" type="datetimeFigureOut">
               <a:rPr lang="en-US" smtClean="0"/>
-              <a:t>5/17/2026</a:t>
+              <a:t>5/18/2026</a:t>
             </a:fld>
             <a:endParaRPr lang="en-US"/>
           </a:p>
@@ -2079,7 +2961,7 @@
           <a:p>
             <a:fld id="{0DD496AA-A241-456D-9BED-07627A88E3ED}" type="slidenum">
               <a:rPr lang="en-US" smtClean="0"/>
-              <a:t>‹nr.›</a:t>
+              <a:t>‹Nr.›</a:t>
             </a:fld>
             <a:endParaRPr lang="en-US"/>
           </a:p>
@@ -2155,7 +3037,7 @@
           <a:p>
             <a:fld id="{A1915611-89FC-422F-9E33-70C527C3BC07}" type="datetimeFigureOut">
               <a:rPr lang="en-US" smtClean="0"/>
-              <a:t>5/17/2026</a:t>
+              <a:t>5/18/2026</a:t>
             </a:fld>
             <a:endParaRPr lang="en-US"/>
           </a:p>
@@ -2197,7 +3079,7 @@
           <a:p>
             <a:fld id="{0DD496AA-A241-456D-9BED-07627A88E3ED}" type="slidenum">
               <a:rPr lang="en-US" smtClean="0"/>
-              <a:t>‹nr.›</a:t>
+              <a:t>‹Nr.›</a:t>
             </a:fld>
             <a:endParaRPr lang="en-US"/>
           </a:p>
@@ -2250,7 +3132,7 @@
           <a:p>
             <a:fld id="{A1915611-89FC-422F-9E33-70C527C3BC07}" type="datetimeFigureOut">
               <a:rPr lang="en-US" smtClean="0"/>
-              <a:t>5/17/2026</a:t>
+              <a:t>5/18/2026</a:t>
             </a:fld>
             <a:endParaRPr lang="en-US"/>
           </a:p>
@@ -2292,7 +3174,7 @@
           <a:p>
             <a:fld id="{0DD496AA-A241-456D-9BED-07627A88E3ED}" type="slidenum">
               <a:rPr lang="en-US" smtClean="0"/>
-              <a:t>‹nr.›</a:t>
+              <a:t>‹Nr.›</a:t>
             </a:fld>
             <a:endParaRPr lang="en-US"/>
           </a:p>
@@ -2527,7 +3409,7 @@
           <a:p>
             <a:fld id="{A1915611-89FC-422F-9E33-70C527C3BC07}" type="datetimeFigureOut">
               <a:rPr lang="en-US" smtClean="0"/>
-              <a:t>5/17/2026</a:t>
+              <a:t>5/18/2026</a:t>
             </a:fld>
             <a:endParaRPr lang="en-US"/>
           </a:p>
@@ -2569,7 +3451,7 @@
           <a:p>
             <a:fld id="{0DD496AA-A241-456D-9BED-07627A88E3ED}" type="slidenum">
               <a:rPr lang="en-US" smtClean="0"/>
-              <a:t>‹nr.›</a:t>
+              <a:t>‹Nr.›</a:t>
             </a:fld>
             <a:endParaRPr lang="en-US"/>
           </a:p>
@@ -2784,7 +3666,7 @@
           <a:p>
             <a:fld id="{A1915611-89FC-422F-9E33-70C527C3BC07}" type="datetimeFigureOut">
               <a:rPr lang="en-US" smtClean="0"/>
-              <a:t>5/17/2026</a:t>
+              <a:t>5/18/2026</a:t>
             </a:fld>
             <a:endParaRPr lang="en-US"/>
           </a:p>
@@ -2826,7 +3708,7 @@
           <a:p>
             <a:fld id="{0DD496AA-A241-456D-9BED-07627A88E3ED}" type="slidenum">
               <a:rPr lang="en-US" smtClean="0"/>
-              <a:t>‹nr.›</a:t>
+              <a:t>‹Nr.›</a:t>
             </a:fld>
             <a:endParaRPr lang="en-US"/>
           </a:p>
@@ -2997,7 +3879,7 @@
           <a:p>
             <a:fld id="{A1915611-89FC-422F-9E33-70C527C3BC07}" type="datetimeFigureOut">
               <a:rPr lang="en-US" smtClean="0"/>
-              <a:t>5/17/2026</a:t>
+              <a:t>5/18/2026</a:t>
             </a:fld>
             <a:endParaRPr lang="en-US"/>
           </a:p>
@@ -3075,7 +3957,7 @@
           <a:p>
             <a:fld id="{0DD496AA-A241-456D-9BED-07627A88E3ED}" type="slidenum">
               <a:rPr lang="en-US" smtClean="0"/>
-              <a:t>‹nr.›</a:t>
+              <a:t>‹Nr.›</a:t>
             </a:fld>
             <a:endParaRPr lang="en-US"/>
           </a:p>
@@ -3412,6 +4294,60 @@
       </p:grpSpPr>
       <p:sp>
         <p:nvSpPr>
+          <p:cNvPr id="25" name="Rechteck 24">
+            <a:extLst>
+              <a:ext uri="{FF2B5EF4-FFF2-40B4-BE49-F238E27FC236}">
+                <a16:creationId xmlns:a16="http://schemas.microsoft.com/office/drawing/2014/main" id="{77969D52-DE5C-42BF-121B-27045EB0367C}"/>
+              </a:ext>
+            </a:extLst>
+          </p:cNvPr>
+          <p:cNvSpPr/>
+          <p:nvPr/>
+        </p:nvSpPr>
+        <p:spPr>
+          <a:xfrm>
+            <a:off x="105077" y="17783672"/>
+            <a:ext cx="20874503" cy="6385802"/>
+          </a:xfrm>
+          <a:prstGeom prst="rect">
+            <a:avLst/>
+          </a:prstGeom>
+          <a:solidFill>
+            <a:schemeClr val="bg1"/>
+          </a:solidFill>
+          <a:ln>
+            <a:solidFill>
+              <a:schemeClr val="bg1"/>
+            </a:solidFill>
+          </a:ln>
+        </p:spPr>
+        <p:style>
+          <a:lnRef idx="2">
+            <a:schemeClr val="accent1">
+              <a:shade val="15000"/>
+            </a:schemeClr>
+          </a:lnRef>
+          <a:fillRef idx="1">
+            <a:schemeClr val="accent1"/>
+          </a:fillRef>
+          <a:effectRef idx="0">
+            <a:schemeClr val="accent1"/>
+          </a:effectRef>
+          <a:fontRef idx="minor">
+            <a:schemeClr val="lt1"/>
+          </a:fontRef>
+        </p:style>
+        <p:txBody>
+          <a:bodyPr rtlCol="0" anchor="ctr"/>
+          <a:lstStyle/>
+          <a:p>
+            <a:pPr algn="ctr"/>
+            <a:endParaRPr lang="en-US"/>
+          </a:p>
+        </p:txBody>
+      </p:sp>
+      <p:sp>
+        <p:nvSpPr>
           <p:cNvPr id="40" name="Ellipse 39">
             <a:extLst>
               <a:ext uri="{FF2B5EF4-FFF2-40B4-BE49-F238E27FC236}">
@@ -3423,9 +4359,9 @@
           <p:nvPr/>
         </p:nvSpPr>
         <p:spPr>
-          <a:xfrm rot="20002223">
-            <a:off x="-4175127" y="7147150"/>
-            <a:ext cx="18355988" cy="10028893"/>
+          <a:xfrm rot="20355398">
+            <a:off x="-4251929" y="6888166"/>
+            <a:ext cx="18307299" cy="10062396"/>
           </a:xfrm>
           <a:prstGeom prst="ellipse">
             <a:avLst/>
@@ -3476,7 +4412,7 @@
         </p:nvSpPr>
         <p:spPr>
           <a:xfrm>
-            <a:off x="552331" y="7402784"/>
+            <a:off x="277079" y="7101030"/>
             <a:ext cx="1800000" cy="1800000"/>
           </a:xfrm>
           <a:prstGeom prst="ellipse">
@@ -3634,7 +4570,7 @@
         </p:nvSpPr>
         <p:spPr>
           <a:xfrm>
-            <a:off x="579121" y="2652053"/>
+            <a:off x="579121" y="2463367"/>
             <a:ext cx="15346680" cy="1015663"/>
           </a:xfrm>
           <a:prstGeom prst="rect">
@@ -3675,7 +4611,7 @@
         <p:spPr>
           <a:xfrm>
             <a:off x="650507" y="4073185"/>
-            <a:ext cx="11136183" cy="3170099"/>
+            <a:ext cx="12817843" cy="3662541"/>
           </a:xfrm>
           <a:prstGeom prst="rect">
             <a:avLst/>
@@ -3723,7 +4659,35 @@
                 </a:solidFill>
                 <a:latin typeface="Garamond" panose="02020404030301010803" pitchFamily="18" charset="0"/>
               </a:rPr>
-              <a:t>When observing stars, we only find those that are significantly detectible with our current detection methods. This introduces a bias in the acquired data.</a:t>
+              <a:t>When observing stars, we only find those that are significantly detectible with our current detection methods. This introduces a bias in the acquired data. The goal of this research project is </a:t>
+            </a:r>
+          </a:p>
+          <a:p>
+            <a:pPr marL="0" marR="0" lvl="0" indent="0" algn="l" defTabSz="457200" rtl="0" eaLnBrk="1" fontAlgn="auto" latinLnBrk="0" hangingPunct="1">
+              <a:lnSpc>
+                <a:spcPct val="100000"/>
+              </a:lnSpc>
+              <a:spcBef>
+                <a:spcPts val="0"/>
+              </a:spcBef>
+              <a:spcAft>
+                <a:spcPts val="0"/>
+              </a:spcAft>
+              <a:buClrTx/>
+              <a:buSzTx/>
+              <a:buFontTx/>
+              <a:buNone/>
+              <a:tabLst/>
+              <a:defRPr/>
+            </a:pPr>
+            <a:r>
+              <a:rPr lang="en-US" sz="3200" dirty="0">
+                <a:solidFill>
+                  <a:prstClr val="black"/>
+                </a:solidFill>
+                <a:latin typeface="Garamond" panose="02020404030301010803" pitchFamily="18" charset="0"/>
+              </a:rPr>
+              <a:t>to quantify that bias.</a:t>
             </a:r>
             <a:endParaRPr kumimoji="0" lang="en-US" sz="3200" b="0" i="0" u="none" strike="noStrike" kern="1200" cap="none" spc="0" normalizeH="0" baseline="0" noProof="0" dirty="0">
               <a:ln>
@@ -3818,7 +4782,7 @@
         <p:spPr>
           <a:xfrm>
             <a:off x="2440997" y="6663083"/>
-            <a:ext cx="9496976" cy="2492990"/>
+            <a:ext cx="9098663" cy="2985433"/>
           </a:xfrm>
           <a:prstGeom prst="rect">
             <a:avLst/>
@@ -3920,7 +4884,7 @@
         </p:nvSpPr>
         <p:spPr>
           <a:xfrm>
-            <a:off x="136936" y="25423687"/>
+            <a:off x="136936" y="24293390"/>
             <a:ext cx="12768766" cy="3970318"/>
           </a:xfrm>
           <a:prstGeom prst="rect">
@@ -4097,7 +5061,7 @@
                   <a:srgbClr val="FFFF00"/>
                 </a:highlight>
                 <a:latin typeface="Garamond" panose="02020404030301010803" pitchFamily="18" charset="0"/>
-                <a:hlinkClick r:id="rId2"/>
+                <a:hlinkClick r:id="rId3"/>
               </a:rPr>
               <a:t>here</a:t>
             </a:r>
@@ -4349,7 +5313,7 @@
         </p:nvSpPr>
         <p:spPr>
           <a:xfrm>
-            <a:off x="651691" y="3483050"/>
+            <a:off x="651691" y="3323396"/>
             <a:ext cx="15263409" cy="492443"/>
           </a:xfrm>
           <a:prstGeom prst="rect">
@@ -4402,7 +5366,7 @@
           <a:blip>
             <a:extLst>
               <a:ext uri="{96DAC541-7B7A-43D3-8B79-37D633B846F1}">
-                <asvg:svgBlip xmlns:asvg="http://schemas.microsoft.com/office/drawing/2016/SVG/main" r:embed="rId3"/>
+                <asvg:svgBlip xmlns:asvg="http://schemas.microsoft.com/office/drawing/2016/SVG/main" r:embed="rId4"/>
               </a:ext>
             </a:extLst>
           </a:blip>
@@ -4746,7 +5710,7 @@
                           <a:tailEnd type="none" w="med" len="med"/>
                         </a:lnB>
                         <a:blipFill>
-                          <a:blip r:embed="rId4"/>
+                          <a:blip r:embed="rId5"/>
                           <a:stretch>
                             <a:fillRect t="-899" r="-100000" b="-75"/>
                           </a:stretch>
@@ -4849,7 +5813,7 @@
           <p:nvPr/>
         </p:nvPicPr>
         <p:blipFill>
-          <a:blip r:embed="rId5">
+          <a:blip r:embed="rId6">
             <a:duotone>
               <a:prstClr val="black"/>
               <a:srgbClr val="F2EBE2">
@@ -4872,8 +5836,8 @@
           </a:prstGeom>
         </p:spPr>
       </p:pic>
-      <mc:AlternateContent xmlns:mc="http://schemas.openxmlformats.org/markup-compatibility/2006" xmlns:a14="http://schemas.microsoft.com/office/drawing/2010/main">
-        <mc:Choice Requires="a14">
+      <mc:AlternateContent xmlns:mc="http://schemas.openxmlformats.org/markup-compatibility/2006">
+        <mc:Choice xmlns:a14="http://schemas.microsoft.com/office/drawing/2010/main" Requires="a14">
           <p:graphicFrame>
             <p:nvGraphicFramePr>
               <p:cNvPr id="3" name="Tabelle 2">
@@ -4889,7 +5853,7 @@
               <p:nvPr>
                 <p:extLst>
                   <p:ext uri="{D42A27DB-BD31-4B8C-83A1-F6EECF244321}">
-                    <p14:modId xmlns:p14="http://schemas.microsoft.com/office/powerpoint/2010/main" val="2238848801"/>
+                    <p14:modId xmlns:p14="http://schemas.microsoft.com/office/powerpoint/2010/main" val="3981946127"/>
                   </p:ext>
                 </p:extLst>
               </p:nvPr>
@@ -5251,27 +6215,14 @@
                               </m:oMathParaPr>
                               <m:oMath xmlns:m="http://schemas.openxmlformats.org/officeDocument/2006/math">
                                 <m:r>
-                                  <a:rPr lang="nl-NL" sz="2800" b="0" i="1" smtClean="0">
+                                  <a:rPr lang="en-US" sz="2800" b="0" i="1" smtClean="0">
                                     <a:solidFill>
                                       <a:srgbClr val="2A2A2A"/>
                                     </a:solidFill>
                                     <a:effectLst/>
                                     <a:latin typeface="Cambria Math" panose="02040503050406030204" pitchFamily="18" charset="0"/>
                                   </a:rPr>
-                                  <m:t>𝑃𝐷</m:t>
-                                </m:r>
-                                <m:r>
-                                  <m:rPr>
-                                    <m:sty m:val="p"/>
-                                  </m:rPr>
-                                  <a:rPr lang="nl-NL" sz="2800" b="0" i="1" smtClean="0">
-                                    <a:solidFill>
-                                      <a:srgbClr val="2A2A2A"/>
-                                    </a:solidFill>
-                                    <a:effectLst/>
-                                    <a:latin typeface="Cambria Math" panose="02040503050406030204" pitchFamily="18" charset="0"/>
-                                  </a:rPr>
-                                  <m:t>F</m:t>
+                                  <m:t>𝑓</m:t>
                                 </m:r>
                                 <m:d>
                                   <m:dPr>
@@ -5644,7 +6595,7 @@
             </a:graphic>
           </p:graphicFrame>
         </mc:Choice>
-        <mc:Fallback xmlns="">
+        <mc:Fallback>
           <p:graphicFrame>
             <p:nvGraphicFramePr>
               <p:cNvPr id="3" name="Tabelle 2">
@@ -5660,7 +6611,7 @@
               <p:nvPr>
                 <p:extLst>
                   <p:ext uri="{D42A27DB-BD31-4B8C-83A1-F6EECF244321}">
-                    <p14:modId xmlns:p14="http://schemas.microsoft.com/office/powerpoint/2010/main" val="2238848801"/>
+                    <p14:modId xmlns:p14="http://schemas.microsoft.com/office/powerpoint/2010/main" val="3981946127"/>
                   </p:ext>
                 </p:extLst>
               </p:nvPr>
@@ -5805,7 +6756,7 @@
                         <a:bodyPr/>
                         <a:lstStyle/>
                         <a:p>
-                          <a:endParaRPr lang="nl-NL"/>
+                          <a:endParaRPr lang="en-US"/>
                         </a:p>
                       </a:txBody>
                       <a:tcPr marL="92354" marR="92354">
@@ -5819,7 +6770,7 @@
                           <a:tailEnd type="none" w="med" len="med"/>
                         </a:lnL>
                         <a:blipFill>
-                          <a:blip r:embed="rId6"/>
+                          <a:blip r:embed="rId7"/>
                           <a:stretch>
                             <a:fillRect l="-45256" t="-55046" b="-322477"/>
                           </a:stretch>
@@ -5865,7 +6816,7 @@
                         <a:bodyPr/>
                         <a:lstStyle/>
                         <a:p>
-                          <a:endParaRPr lang="nl-NL"/>
+                          <a:endParaRPr lang="en-US"/>
                         </a:p>
                       </a:txBody>
                       <a:tcPr marL="92354" marR="92354">
@@ -5879,7 +6830,7 @@
                           <a:tailEnd type="none" w="med" len="med"/>
                         </a:lnL>
                         <a:blipFill>
-                          <a:blip r:embed="rId6"/>
+                          <a:blip r:embed="rId7"/>
                           <a:stretch>
                             <a:fillRect l="-45256" t="-312963" b="-550926"/>
                           </a:stretch>
@@ -6167,8 +7118,8 @@
         </p:nvSpPr>
         <p:spPr>
           <a:xfrm>
-            <a:off x="192162" y="24180675"/>
-            <a:ext cx="9412906" cy="584775"/>
+            <a:off x="167933" y="23257475"/>
+            <a:ext cx="20706044" cy="830997"/>
           </a:xfrm>
           <a:prstGeom prst="rect">
             <a:avLst/>
@@ -6182,7 +7133,7 @@
           <a:lstStyle/>
           <a:p>
             <a:r>
-              <a:rPr lang="en-US" sz="3200" b="1" i="1" dirty="0">
+              <a:rPr lang="en-US" sz="2400" b="1" i="1" dirty="0">
                 <a:solidFill>
                   <a:srgbClr val="000000"/>
                 </a:solidFill>
@@ -6191,15 +7142,15 @@
               <a:t>Figure 1</a:t>
             </a:r>
             <a:r>
-              <a:rPr lang="en-US" sz="3200" dirty="0">
+              <a:rPr lang="en-US" sz="2400" dirty="0">
                 <a:solidFill>
                   <a:srgbClr val="000000"/>
                 </a:solidFill>
                 <a:latin typeface="Garamond" panose="02020404030301010803" pitchFamily="18" charset="0"/>
               </a:rPr>
-              <a:t>. </a:t>
-            </a:r>
-            <a:endParaRPr lang="en-US" sz="3200" dirty="0">
+              <a:t>. Observational and theoretical distributions for the BDB. The upper plot shows the expected and the theoretical distribution. The residual probabilities is the observational bias for each parameter. The x axis indicates which parameter is evaluated. </a:t>
+            </a:r>
+            <a:endParaRPr lang="en-US" sz="2400" dirty="0">
               <a:latin typeface="Garamond" panose="02020404030301010803" pitchFamily="18" charset="0"/>
             </a:endParaRPr>
           </a:p>
@@ -6218,8 +7169,8 @@
           <p:nvPr/>
         </p:nvSpPr>
         <p:spPr>
-          <a:xfrm rot="5400000">
-            <a:off x="-12894540" y="15166640"/>
+          <a:xfrm>
+            <a:off x="-19713425" y="16518739"/>
             <a:ext cx="10692000" cy="7560000"/>
           </a:xfrm>
           <a:prstGeom prst="rect">
@@ -6258,8 +7209,8 @@
           </a:p>
         </p:txBody>
       </p:sp>
-      <mc:AlternateContent xmlns:mc="http://schemas.openxmlformats.org/markup-compatibility/2006" xmlns:a14="http://schemas.microsoft.com/office/drawing/2010/main">
-        <mc:Choice Requires="a14">
+      <mc:AlternateContent xmlns:mc="http://schemas.openxmlformats.org/markup-compatibility/2006">
+        <mc:Choice xmlns:a14="http://schemas.microsoft.com/office/drawing/2010/main" Requires="a14">
           <p:sp>
             <p:nvSpPr>
               <p:cNvPr id="10" name="Textfeld 9">
@@ -6274,8 +7225,8 @@
             </p:nvSpPr>
             <p:spPr>
               <a:xfrm>
-                <a:off x="10553699" y="14826888"/>
-                <a:ext cx="10829925" cy="3323987"/>
+                <a:off x="9217400" y="14822587"/>
+                <a:ext cx="11749341" cy="1446550"/>
               </a:xfrm>
               <a:prstGeom prst="rect">
                 <a:avLst/>
@@ -6288,180 +7239,209 @@
               </a:bodyPr>
               <a:lstStyle/>
               <a:p>
+                <a:pPr algn="ctr"/>
                 <a:r>
-                  <a:rPr kumimoji="0" lang="en-US" sz="3200" i="0" u="none" strike="noStrike" kern="1200" cap="none" spc="0" normalizeH="0" baseline="0" noProof="0" dirty="0">
-                    <a:ln>
-                      <a:noFill/>
-                    </a:ln>
+                  <a:rPr lang="en-US" sz="2800" dirty="0">
                     <a:solidFill>
                       <a:prstClr val="black"/>
                     </a:solidFill>
-                    <a:effectLst/>
-                    <a:uLnTx/>
-                    <a:uFillTx/>
                     <a:latin typeface="Garamond" panose="02020404030301010803" pitchFamily="18" charset="0"/>
-                    <a:ea typeface="+mn-ea"/>
-                    <a:cs typeface="+mn-cs"/>
                   </a:rPr>
-                  <a:t>We find that SB9 is  biased </a:t>
+                  <a:t>We find various </a:t>
                 </a:r>
                 <a:r>
-                  <a:rPr kumimoji="0" lang="en-US" sz="3200" b="0" i="0" u="none" strike="noStrike" kern="1200" cap="none" spc="0" normalizeH="0" baseline="0" noProof="0" dirty="0">
-                    <a:ln>
-                      <a:noFill/>
-                    </a:ln>
+                  <a:rPr lang="en-US" sz="3200" dirty="0">
                     <a:solidFill>
                       <a:prstClr val="black"/>
                     </a:solidFill>
-                    <a:effectLst/>
-                    <a:uLnTx/>
-                    <a:uFillTx/>
                     <a:latin typeface="Garamond" panose="02020404030301010803" pitchFamily="18" charset="0"/>
-                    <a:ea typeface="+mn-ea"/>
-                    <a:cs typeface="+mn-cs"/>
                   </a:rPr>
-                  <a:t>towards lower eccentricities,</a:t>
+                  <a:t>observational</a:t>
+                </a:r>
+                <a:r>
+                  <a:rPr lang="en-US" sz="2800" dirty="0">
+                    <a:solidFill>
+                      <a:prstClr val="black"/>
+                    </a:solidFill>
+                    <a:latin typeface="Garamond" panose="02020404030301010803" pitchFamily="18" charset="0"/>
+                  </a:rPr>
+                  <a:t> biases as shown in </a:t>
+                </a:r>
+                <a:r>
+                  <a:rPr lang="en-US" sz="2800" i="1" dirty="0">
+                    <a:solidFill>
+                      <a:prstClr val="black"/>
+                    </a:solidFill>
+                    <a:latin typeface="Garamond" panose="02020404030301010803" pitchFamily="18" charset="0"/>
+                  </a:rPr>
+                  <a:t>Figure 1. </a:t>
+                </a:r>
+                <a:r>
+                  <a:rPr lang="en-US" sz="2800" dirty="0">
+                    <a:solidFill>
+                      <a:prstClr val="black"/>
+                    </a:solidFill>
+                    <a:latin typeface="Garamond" panose="02020404030301010803" pitchFamily="18" charset="0"/>
+                  </a:rPr>
+                  <a:t>In the </a:t>
                 </a:r>
               </a:p>
               <a:p>
                 <a:r>
-                  <a:rPr kumimoji="0" lang="en-US" sz="3200" b="0" i="0" u="none" strike="noStrike" kern="1200" cap="none" spc="0" normalizeH="0" baseline="0" noProof="0" dirty="0">
-                    <a:ln>
-                      <a:noFill/>
-                    </a:ln>
+                  <a:rPr lang="en-US" sz="2800" dirty="0">
                     <a:solidFill>
                       <a:prstClr val="black"/>
                     </a:solidFill>
-                    <a:effectLst/>
-                    <a:uLnTx/>
-                    <a:uFillTx/>
                     <a:latin typeface="Garamond" panose="02020404030301010803" pitchFamily="18" charset="0"/>
-                    <a:ea typeface="+mn-ea"/>
-                    <a:cs typeface="+mn-cs"/>
                   </a:rPr>
-                  <a:t> with a very strong preference for </a:t>
+                  <a:t>BDB the period is </a:t>
+                </a:r>
+                <a:r>
+                  <a:rPr lang="en-US" sz="2800" dirty="0">
+                    <a:solidFill>
+                      <a:prstClr val="black"/>
+                    </a:solidFill>
+                    <a:highlight>
+                      <a:srgbClr val="FFFF00"/>
+                    </a:highlight>
+                    <a:latin typeface="Garamond" panose="02020404030301010803" pitchFamily="18" charset="0"/>
+                  </a:rPr>
+                  <a:t>biased towards lower periods (</a:t>
                 </a:r>
                 <a14:m>
                   <m:oMath xmlns:m="http://schemas.openxmlformats.org/officeDocument/2006/math">
                     <m:r>
-                      <a:rPr kumimoji="0" lang="en-US" sz="3200" b="0" i="1" u="none" strike="noStrike" kern="1200" cap="none" spc="0" normalizeH="0" baseline="0" noProof="0">
-                        <a:ln>
-                          <a:noFill/>
-                        </a:ln>
+                      <a:rPr lang="en-US" sz="2800" b="0" i="1" smtClean="0">
                         <a:solidFill>
                           <a:prstClr val="black"/>
                         </a:solidFill>
-                        <a:effectLst/>
-                        <a:uLnTx/>
-                        <a:uFillTx/>
+                        <a:highlight>
+                          <a:srgbClr val="FFFF00"/>
+                        </a:highlight>
                         <a:latin typeface="Cambria Math" panose="02040503050406030204" pitchFamily="18" charset="0"/>
-                        <a:ea typeface="+mn-ea"/>
-                        <a:cs typeface="+mn-cs"/>
                       </a:rPr>
-                      <m:t>𝑒</m:t>
+                      <m:t>&lt;</m:t>
                     </m:r>
+                    <m:sSup>
+                      <m:sSupPr>
+                        <m:ctrlPr>
+                          <a:rPr lang="en-US" sz="2800" b="0" i="1" smtClean="0">
+                            <a:solidFill>
+                              <a:prstClr val="black"/>
+                            </a:solidFill>
+                            <a:highlight>
+                              <a:srgbClr val="FFFF00"/>
+                            </a:highlight>
+                            <a:latin typeface="Cambria Math" panose="02040503050406030204" pitchFamily="18" charset="0"/>
+                          </a:rPr>
+                        </m:ctrlPr>
+                      </m:sSupPr>
+                      <m:e>
+                        <m:r>
+                          <a:rPr lang="en-US" sz="2800" b="0" i="1" smtClean="0">
+                            <a:solidFill>
+                              <a:prstClr val="black"/>
+                            </a:solidFill>
+                            <a:highlight>
+                              <a:srgbClr val="FFFF00"/>
+                            </a:highlight>
+                            <a:latin typeface="Cambria Math" panose="02040503050406030204" pitchFamily="18" charset="0"/>
+                          </a:rPr>
+                          <m:t>10</m:t>
+                        </m:r>
+                      </m:e>
+                      <m:sup>
+                        <m:r>
+                          <a:rPr lang="en-US" sz="2800" b="0" i="1" smtClean="0">
+                            <a:solidFill>
+                              <a:prstClr val="black"/>
+                            </a:solidFill>
+                            <a:highlight>
+                              <a:srgbClr val="FFFF00"/>
+                            </a:highlight>
+                            <a:latin typeface="Cambria Math" panose="02040503050406030204" pitchFamily="18" charset="0"/>
+                          </a:rPr>
+                          <m:t>1.7</m:t>
+                        </m:r>
+                      </m:sup>
+                    </m:sSup>
                     <m:r>
-                      <a:rPr kumimoji="0" lang="en-US" sz="3200" b="0" i="1" u="none" strike="noStrike" kern="1200" cap="none" spc="0" normalizeH="0" baseline="0" noProof="0">
-                        <a:ln>
-                          <a:noFill/>
-                        </a:ln>
+                      <a:rPr lang="en-US" sz="2800" b="0" i="1" smtClean="0">
                         <a:solidFill>
                           <a:prstClr val="black"/>
                         </a:solidFill>
-                        <a:effectLst/>
-                        <a:uLnTx/>
-                        <a:uFillTx/>
                         <a:latin typeface="Cambria Math" panose="02040503050406030204" pitchFamily="18" charset="0"/>
-                        <a:ea typeface="+mn-ea"/>
-                        <a:cs typeface="+mn-cs"/>
                       </a:rPr>
-                      <m:t>=0</m:t>
+                      <m:t>)</m:t>
                     </m:r>
                   </m:oMath>
                 </a14:m>
                 <a:r>
-                  <a:rPr kumimoji="0" lang="en-US" sz="3200" b="0" i="0" u="none" strike="noStrike" kern="1200" cap="none" spc="0" normalizeH="0" baseline="0" noProof="0" dirty="0">
-                    <a:ln>
-                      <a:noFill/>
-                    </a:ln>
+                  <a:rPr lang="en-US" sz="2800" dirty="0">
                     <a:solidFill>
                       <a:prstClr val="black"/>
                     </a:solidFill>
-                    <a:effectLst/>
-                    <a:uLnTx/>
-                    <a:uFillTx/>
                     <a:latin typeface="Garamond" panose="02020404030301010803" pitchFamily="18" charset="0"/>
-                    <a:ea typeface="+mn-ea"/>
-                    <a:cs typeface="+mn-cs"/>
                   </a:rPr>
-                  <a:t>. ORB6 is biased</a:t>
+                  <a:t> and larger mass </a:t>
                 </a:r>
                 <a:r>
-                  <a:rPr kumimoji="0" lang="en-US" sz="3200" b="0" i="0" u="none" strike="noStrike" kern="1200" cap="none" spc="0" normalizeH="0" noProof="0" dirty="0">
-                    <a:ln>
-                      <a:noFill/>
-                    </a:ln>
+                  <a:rPr lang="en-US" sz="2800" dirty="0">
                     <a:solidFill>
                       <a:prstClr val="black"/>
                     </a:solidFill>
-                    <a:effectLst/>
-                    <a:uLnTx/>
-                    <a:uFillTx/>
-                    <a:latin typeface="Garamond" panose="02020404030301010803" pitchFamily="18" charset="0"/>
-                    <a:ea typeface="+mn-ea"/>
-                    <a:cs typeface="+mn-cs"/>
-                  </a:rPr>
-                  <a:t> </a:t>
-                </a:r>
-              </a:p>
-              <a:p>
-                <a:r>
-                  <a:rPr lang="en-US" sz="3200" dirty="0">
+                    <a:highlight>
+                      <a:srgbClr val="FFFF00"/>
+                    </a:highlight>
                     <a:latin typeface="Garamond" panose="02020404030301010803" pitchFamily="18" charset="0"/>
                   </a:rPr>
-                  <a:t>We find that ORB6 is biased towards middle eccentricities, between 0.2 and 0.6.. There is a preference for circular orbits. It is also biased towards shorter periods</a:t>
+                  <a:t>ratios (</a:t>
                 </a:r>
-              </a:p>
-              <a:p>
-                <a:pPr marL="0" marR="0" lvl="0" indent="0" algn="l" defTabSz="457200" rtl="0" eaLnBrk="1" fontAlgn="auto" latinLnBrk="0" hangingPunct="1">
-                  <a:lnSpc>
-                    <a:spcPct val="100000"/>
-                  </a:lnSpc>
-                  <a:spcBef>
-                    <a:spcPts val="0"/>
-                  </a:spcBef>
-                  <a:spcAft>
-                    <a:spcPts val="0"/>
-                  </a:spcAft>
-                  <a:buClrTx/>
-                  <a:buSzTx/>
-                  <a:buFontTx/>
-                  <a:buNone/>
-                  <a:tabLst/>
-                  <a:defRPr/>
-                </a:pPr>
-                <a:endParaRPr kumimoji="0" lang="en-US" sz="3200" b="0" i="0" u="none" strike="noStrike" kern="1200" cap="none" spc="0" normalizeH="0" baseline="0" noProof="0" dirty="0">
-                  <a:ln>
-                    <a:noFill/>
-                  </a:ln>
-                  <a:solidFill>
-                    <a:prstClr val="black"/>
-                  </a:solidFill>
-                  <a:effectLst/>
-                  <a:uLnTx/>
-                  <a:uFillTx/>
+                <a14:m>
+                  <m:oMath xmlns:m="http://schemas.openxmlformats.org/officeDocument/2006/math">
+                    <m:r>
+                      <a:rPr lang="en-US" sz="2800" b="0" i="1" smtClean="0">
+                        <a:solidFill>
+                          <a:prstClr val="black"/>
+                        </a:solidFill>
+                        <a:highlight>
+                          <a:srgbClr val="FFFF00"/>
+                        </a:highlight>
+                        <a:latin typeface="Cambria Math" panose="02040503050406030204" pitchFamily="18" charset="0"/>
+                      </a:rPr>
+                      <m:t>&lt;0.5</m:t>
+                    </m:r>
+                  </m:oMath>
+                </a14:m>
+                <a:r>
+                  <a:rPr lang="en-US" sz="2800" dirty="0">
+                    <a:solidFill>
+                      <a:prstClr val="black"/>
+                    </a:solidFill>
+                    <a:highlight>
+                      <a:srgbClr val="FFFF00"/>
+                    </a:highlight>
+                    <a:latin typeface="Garamond" panose="02020404030301010803" pitchFamily="18" charset="0"/>
+                  </a:rPr>
+                  <a:t>). </a:t>
+                </a:r>
+                <a:r>
+                  <a:rPr lang="en-US" sz="2800" dirty="0">
+                    <a:solidFill>
+                      <a:prstClr val="black"/>
+                    </a:solidFill>
+                    <a:latin typeface="Garamond" panose="02020404030301010803" pitchFamily="18" charset="0"/>
+                  </a:rPr>
+                  <a:t>The database is strongly biased towards circular orbits.</a:t>
+                </a:r>
+                <a:endParaRPr lang="en-US" sz="2800" dirty="0">
                   <a:latin typeface="Garamond" panose="02020404030301010803" pitchFamily="18" charset="0"/>
-                  <a:ea typeface="+mn-ea"/>
-                  <a:cs typeface="+mn-cs"/>
                 </a:endParaRPr>
-              </a:p>
-              <a:p>
-                <a:endParaRPr lang="en-US" dirty="0"/>
               </a:p>
             </p:txBody>
           </p:sp>
         </mc:Choice>
-        <mc:Fallback xmlns="">
+        <mc:Fallback>
           <p:sp>
             <p:nvSpPr>
               <p:cNvPr id="10" name="Textfeld 9">
@@ -6478,16 +7458,16 @@
             </p:nvSpPr>
             <p:spPr>
               <a:xfrm>
-                <a:off x="10553699" y="14826888"/>
-                <a:ext cx="10829925" cy="3323987"/>
+                <a:off x="9217400" y="14822587"/>
+                <a:ext cx="11749341" cy="1446550"/>
               </a:xfrm>
               <a:prstGeom prst="rect">
                 <a:avLst/>
               </a:prstGeom>
               <a:blipFill>
-                <a:blip r:embed="rId7"/>
+                <a:blip r:embed="rId8"/>
                 <a:stretch>
-                  <a:fillRect l="-1407" t="-2381" r="-2195"/>
+                  <a:fillRect l="-1038" t="-5485" b="-10970"/>
                 </a:stretch>
               </a:blipFill>
             </p:spPr>
@@ -6608,14 +7588,15 @@
             </a:extLst>
           </p:cNvPr>
           <p:cNvCxnSpPr>
+            <a:cxnSpLocks/>
             <a:stCxn id="11" idx="2"/>
           </p:cNvCxnSpPr>
           <p:nvPr/>
         </p:nvCxnSpPr>
         <p:spPr>
           <a:xfrm flipH="1">
-            <a:off x="19120713" y="16296824"/>
-            <a:ext cx="9202117" cy="1351096"/>
+            <a:off x="23964900" y="16296824"/>
+            <a:ext cx="4357930" cy="1486848"/>
           </a:xfrm>
           <a:prstGeom prst="straightConnector1">
             <a:avLst/>
@@ -6709,7 +7690,7 @@
         <p:spPr>
           <a:xfrm>
             <a:off x="-13186566" y="12861282"/>
-            <a:ext cx="1270827" cy="1965606"/>
+            <a:ext cx="2023266" cy="2908793"/>
           </a:xfrm>
           <a:prstGeom prst="straightConnector1">
             <a:avLst/>
@@ -6741,46 +7722,10 @@
       </p:cxnSp>
       <p:pic>
         <p:nvPicPr>
-          <p:cNvPr id="28" name="Graphic 27">
+          <p:cNvPr id="14" name="Grafik 13">
             <a:extLst>
               <a:ext uri="{FF2B5EF4-FFF2-40B4-BE49-F238E27FC236}">
-                <a16:creationId xmlns:a16="http://schemas.microsoft.com/office/drawing/2014/main" id="{81D6B83C-5842-E5B0-D913-111BD46C8DC1}"/>
-              </a:ext>
-            </a:extLst>
-          </p:cNvPr>
-          <p:cNvPicPr>
-            <a:picLocks noChangeAspect="1"/>
-          </p:cNvPicPr>
-          <p:nvPr/>
-        </p:nvPicPr>
-        <p:blipFill>
-          <a:blip>
-            <a:extLst>
-              <a:ext uri="{96DAC541-7B7A-43D3-8B79-37D633B846F1}">
-                <asvg:svgBlip xmlns:asvg="http://schemas.microsoft.com/office/drawing/2016/SVG/main" r:embed="rId8"/>
-              </a:ext>
-            </a:extLst>
-          </a:blip>
-          <a:stretch>
-            <a:fillRect/>
-          </a:stretch>
-        </p:blipFill>
-        <p:spPr>
-          <a:xfrm>
-            <a:off x="5401842" y="17643525"/>
-            <a:ext cx="5273674" cy="6592092"/>
-          </a:xfrm>
-          <a:prstGeom prst="rect">
-            <a:avLst/>
-          </a:prstGeom>
-        </p:spPr>
-      </p:pic>
-      <p:pic>
-        <p:nvPicPr>
-          <p:cNvPr id="30" name="Graphic 29">
-            <a:extLst>
-              <a:ext uri="{FF2B5EF4-FFF2-40B4-BE49-F238E27FC236}">
-                <a16:creationId xmlns:a16="http://schemas.microsoft.com/office/drawing/2014/main" id="{A53BF8A8-1E80-08BE-5B95-28ABA1130BFA}"/>
+                <a16:creationId xmlns:a16="http://schemas.microsoft.com/office/drawing/2014/main" id="{CE8CF416-836D-AFEE-A1C3-3C92DDBF7BAD}"/>
               </a:ext>
             </a:extLst>
           </p:cNvPr>
@@ -6797,14 +7742,13 @@
               </a:ext>
             </a:extLst>
           </a:blip>
-          <a:stretch>
-            <a:fillRect/>
-          </a:stretch>
+          <a:srcRect/>
+          <a:stretch/>
         </p:blipFill>
         <p:spPr>
           <a:xfrm>
-            <a:off x="158388" y="17643524"/>
-            <a:ext cx="5273674" cy="6592093"/>
+            <a:off x="12483645" y="17886562"/>
+            <a:ext cx="4237604" cy="5103645"/>
           </a:xfrm>
           <a:prstGeom prst="rect">
             <a:avLst/>
@@ -6813,10 +7757,10 @@
       </p:pic>
       <p:pic>
         <p:nvPicPr>
-          <p:cNvPr id="32" name="Graphic 31">
+          <p:cNvPr id="29" name="Grafik 28">
             <a:extLst>
               <a:ext uri="{FF2B5EF4-FFF2-40B4-BE49-F238E27FC236}">
-                <a16:creationId xmlns:a16="http://schemas.microsoft.com/office/drawing/2014/main" id="{B159EC36-2432-212A-875E-29EBA97128FE}"/>
+                <a16:creationId xmlns:a16="http://schemas.microsoft.com/office/drawing/2014/main" id="{2A130629-8A6B-D6BC-8480-73A945782973}"/>
               </a:ext>
             </a:extLst>
           </p:cNvPr>
@@ -6833,14 +7777,339 @@
               </a:ext>
             </a:extLst>
           </a:blip>
+          <a:srcRect t="6133" r="6582"/>
           <a:stretch>
             <a:fillRect/>
           </a:stretch>
         </p:blipFill>
         <p:spPr>
           <a:xfrm>
-            <a:off x="10675551" y="17643523"/>
-            <a:ext cx="5287626" cy="6592093"/>
+            <a:off x="7895662" y="17906015"/>
+            <a:ext cx="4909197" cy="5061600"/>
+          </a:xfrm>
+          <a:prstGeom prst="rect">
+            <a:avLst/>
+          </a:prstGeom>
+        </p:spPr>
+      </p:pic>
+      <p:pic>
+        <p:nvPicPr>
+          <p:cNvPr id="21" name="Graphic 27">
+            <a:extLst>
+              <a:ext uri="{FF2B5EF4-FFF2-40B4-BE49-F238E27FC236}">
+                <a16:creationId xmlns:a16="http://schemas.microsoft.com/office/drawing/2014/main" id="{D1644647-075B-DFB4-CE0E-B4BEBDE89E6A}"/>
+              </a:ext>
+            </a:extLst>
+          </p:cNvPr>
+          <p:cNvPicPr>
+            <a:picLocks noChangeAspect="1"/>
+          </p:cNvPicPr>
+          <p:nvPr/>
+        </p:nvPicPr>
+        <p:blipFill>
+          <a:blip>
+            <a:extLst>
+              <a:ext uri="{96DAC541-7B7A-43D3-8B79-37D633B846F1}">
+                <asvg:svgBlip xmlns:asvg="http://schemas.microsoft.com/office/drawing/2016/SVG/main" r:embed="rId11"/>
+              </a:ext>
+            </a:extLst>
+          </a:blip>
+          <a:srcRect t="6188"/>
+          <a:stretch>
+            <a:fillRect/>
+          </a:stretch>
+        </p:blipFill>
+        <p:spPr>
+          <a:xfrm>
+            <a:off x="4166566" y="17896090"/>
+            <a:ext cx="4351973" cy="5103312"/>
+          </a:xfrm>
+          <a:prstGeom prst="rect">
+            <a:avLst/>
+          </a:prstGeom>
+        </p:spPr>
+      </p:pic>
+      <p:pic>
+        <p:nvPicPr>
+          <p:cNvPr id="24" name="Graphic 29">
+            <a:extLst>
+              <a:ext uri="{FF2B5EF4-FFF2-40B4-BE49-F238E27FC236}">
+                <a16:creationId xmlns:a16="http://schemas.microsoft.com/office/drawing/2014/main" id="{6D2E5C82-84B6-5B08-A829-953CBFFCA94F}"/>
+              </a:ext>
+            </a:extLst>
+          </p:cNvPr>
+          <p:cNvPicPr>
+            <a:picLocks noChangeAspect="1"/>
+          </p:cNvPicPr>
+          <p:nvPr/>
+        </p:nvPicPr>
+        <p:blipFill>
+          <a:blip>
+            <a:extLst>
+              <a:ext uri="{96DAC541-7B7A-43D3-8B79-37D633B846F1}">
+                <asvg:svgBlip xmlns:asvg="http://schemas.microsoft.com/office/drawing/2016/SVG/main" r:embed="rId12"/>
+              </a:ext>
+            </a:extLst>
+          </a:blip>
+          <a:srcRect t="6188"/>
+          <a:stretch>
+            <a:fillRect/>
+          </a:stretch>
+        </p:blipFill>
+        <p:spPr>
+          <a:xfrm>
+            <a:off x="193474" y="17896089"/>
+            <a:ext cx="4351973" cy="5103311"/>
+          </a:xfrm>
+          <a:prstGeom prst="rect">
+            <a:avLst/>
+          </a:prstGeom>
+        </p:spPr>
+      </p:pic>
+      <p:sp>
+        <p:nvSpPr>
+          <p:cNvPr id="26" name="Rechteck 25">
+            <a:extLst>
+              <a:ext uri="{FF2B5EF4-FFF2-40B4-BE49-F238E27FC236}">
+                <a16:creationId xmlns:a16="http://schemas.microsoft.com/office/drawing/2014/main" id="{EA8F6643-E188-E9B9-4278-A3D486B64E53}"/>
+              </a:ext>
+            </a:extLst>
+          </p:cNvPr>
+          <p:cNvSpPr/>
+          <p:nvPr/>
+        </p:nvSpPr>
+        <p:spPr>
+          <a:xfrm>
+            <a:off x="16747556" y="17896089"/>
+            <a:ext cx="4062092" cy="5103645"/>
+          </a:xfrm>
+          <a:prstGeom prst="rect">
+            <a:avLst/>
+          </a:prstGeom>
+        </p:spPr>
+        <p:style>
+          <a:lnRef idx="2">
+            <a:schemeClr val="accent1">
+              <a:shade val="15000"/>
+            </a:schemeClr>
+          </a:lnRef>
+          <a:fillRef idx="1">
+            <a:schemeClr val="accent1"/>
+          </a:fillRef>
+          <a:effectRef idx="0">
+            <a:schemeClr val="accent1"/>
+          </a:effectRef>
+          <a:fontRef idx="minor">
+            <a:schemeClr val="lt1"/>
+          </a:fontRef>
+        </p:style>
+        <p:txBody>
+          <a:bodyPr rtlCol="0" anchor="ctr"/>
+          <a:lstStyle/>
+          <a:p>
+            <a:pPr algn="ctr"/>
+            <a:r>
+              <a:rPr lang="en-US" sz="4400" dirty="0"/>
+              <a:t>Semi major axis plot</a:t>
+            </a:r>
+          </a:p>
+        </p:txBody>
+      </p:sp>
+    </p:spTree>
+    <p:extLst>
+      <p:ext uri="{BB962C8B-B14F-4D97-AF65-F5344CB8AC3E}">
+        <p14:creationId xmlns:p14="http://schemas.microsoft.com/office/powerpoint/2010/main" val="1631260291"/>
+      </p:ext>
+    </p:extLst>
+  </p:cSld>
+  <p:clrMapOvr>
+    <a:masterClrMapping/>
+  </p:clrMapOvr>
+</p:sld>
+</file>
+
+<file path=ppt/slides/slide2.xml><?xml version="1.0" encoding="utf-8"?>
+<p:sld xmlns:a="http://schemas.openxmlformats.org/drawingml/2006/main" xmlns:r="http://schemas.openxmlformats.org/officeDocument/2006/relationships" xmlns:p="http://schemas.openxmlformats.org/presentationml/2006/main">
+  <p:cSld>
+    <p:spTree>
+      <p:nvGrpSpPr>
+        <p:cNvPr id="1" name=""/>
+        <p:cNvGrpSpPr/>
+        <p:nvPr/>
+      </p:nvGrpSpPr>
+      <p:grpSpPr>
+        <a:xfrm>
+          <a:off x="0" y="0"/>
+          <a:ext cx="0" cy="0"/>
+          <a:chOff x="0" y="0"/>
+          <a:chExt cx="0" cy="0"/>
+        </a:xfrm>
+      </p:grpSpPr>
+      <p:pic>
+        <p:nvPicPr>
+          <p:cNvPr id="10" name="Grafik 9">
+            <a:extLst>
+              <a:ext uri="{FF2B5EF4-FFF2-40B4-BE49-F238E27FC236}">
+                <a16:creationId xmlns:a16="http://schemas.microsoft.com/office/drawing/2014/main" id="{4C8B8DA4-8A9F-A571-8BDA-5BE0C92907A4}"/>
+              </a:ext>
+            </a:extLst>
+          </p:cNvPr>
+          <p:cNvPicPr>
+            <a:picLocks noChangeAspect="1"/>
+          </p:cNvPicPr>
+          <p:nvPr/>
+        </p:nvPicPr>
+        <p:blipFill>
+          <a:blip>
+            <a:extLst>
+              <a:ext uri="{96DAC541-7B7A-43D3-8B79-37D633B846F1}">
+                <asvg:svgBlip xmlns:asvg="http://schemas.microsoft.com/office/drawing/2016/SVG/main" r:embed="rId2"/>
+              </a:ext>
+            </a:extLst>
+          </a:blip>
+          <a:srcRect/>
+          <a:stretch/>
+        </p:blipFill>
+        <p:spPr>
+          <a:xfrm>
+            <a:off x="13356506" y="10231452"/>
+            <a:ext cx="4573344" cy="5508000"/>
+          </a:xfrm>
+          <a:prstGeom prst="rect">
+            <a:avLst/>
+          </a:prstGeom>
+        </p:spPr>
+      </p:pic>
+      <p:pic>
+        <p:nvPicPr>
+          <p:cNvPr id="8" name="Graphic 31">
+            <a:extLst>
+              <a:ext uri="{FF2B5EF4-FFF2-40B4-BE49-F238E27FC236}">
+                <a16:creationId xmlns:a16="http://schemas.microsoft.com/office/drawing/2014/main" id="{308E6AF5-BDC0-98E6-7276-17E80AE90DD1}"/>
+              </a:ext>
+            </a:extLst>
+          </p:cNvPr>
+          <p:cNvPicPr>
+            <a:picLocks noChangeAspect="1"/>
+          </p:cNvPicPr>
+          <p:nvPr/>
+        </p:nvPicPr>
+        <p:blipFill>
+          <a:blip>
+            <a:extLst>
+              <a:ext uri="{96DAC541-7B7A-43D3-8B79-37D633B846F1}">
+                <asvg:svgBlip xmlns:asvg="http://schemas.microsoft.com/office/drawing/2016/SVG/main" r:embed="rId3"/>
+              </a:ext>
+            </a:extLst>
+          </a:blip>
+          <a:srcRect t="3419"/>
+          <a:stretch>
+            <a:fillRect/>
+          </a:stretch>
+        </p:blipFill>
+        <p:spPr>
+          <a:xfrm>
+            <a:off x="9202316" y="10231454"/>
+            <a:ext cx="4424149" cy="5327021"/>
+          </a:xfrm>
+          <a:prstGeom prst="rect">
+            <a:avLst/>
+          </a:prstGeom>
+        </p:spPr>
+      </p:pic>
+      <p:sp>
+        <p:nvSpPr>
+          <p:cNvPr id="2" name="Titel 1">
+            <a:extLst>
+              <a:ext uri="{FF2B5EF4-FFF2-40B4-BE49-F238E27FC236}">
+                <a16:creationId xmlns:a16="http://schemas.microsoft.com/office/drawing/2014/main" id="{A86EE84D-1E69-4CF1-4E7A-B2F327A9401B}"/>
+              </a:ext>
+            </a:extLst>
+          </p:cNvPr>
+          <p:cNvSpPr>
+            <a:spLocks noGrp="1"/>
+          </p:cNvSpPr>
+          <p:nvPr>
+            <p:ph type="title"/>
+          </p:nvPr>
+        </p:nvSpPr>
+        <p:spPr/>
+        <p:txBody>
+          <a:bodyPr/>
+          <a:lstStyle/>
+          <a:p>
+            <a:endParaRPr lang="en-US"/>
+          </a:p>
+        </p:txBody>
+      </p:sp>
+      <p:pic>
+        <p:nvPicPr>
+          <p:cNvPr id="6" name="Graphic 27">
+            <a:extLst>
+              <a:ext uri="{FF2B5EF4-FFF2-40B4-BE49-F238E27FC236}">
+                <a16:creationId xmlns:a16="http://schemas.microsoft.com/office/drawing/2014/main" id="{B4A84105-F697-6038-FA53-883DE08304A8}"/>
+              </a:ext>
+            </a:extLst>
+          </p:cNvPr>
+          <p:cNvPicPr>
+            <a:picLocks noChangeAspect="1"/>
+          </p:cNvPicPr>
+          <p:nvPr/>
+        </p:nvPicPr>
+        <p:blipFill>
+          <a:blip>
+            <a:extLst>
+              <a:ext uri="{96DAC541-7B7A-43D3-8B79-37D633B846F1}">
+                <asvg:svgBlip xmlns:asvg="http://schemas.microsoft.com/office/drawing/2016/SVG/main" r:embed="rId4"/>
+              </a:ext>
+            </a:extLst>
+          </a:blip>
+          <a:srcRect t="6188"/>
+          <a:stretch>
+            <a:fillRect/>
+          </a:stretch>
+        </p:blipFill>
+        <p:spPr>
+          <a:xfrm>
+            <a:off x="4725567" y="10240979"/>
+            <a:ext cx="4696774" cy="5507641"/>
+          </a:xfrm>
+          <a:prstGeom prst="rect">
+            <a:avLst/>
+          </a:prstGeom>
+        </p:spPr>
+      </p:pic>
+      <p:pic>
+        <p:nvPicPr>
+          <p:cNvPr id="7" name="Graphic 29">
+            <a:extLst>
+              <a:ext uri="{FF2B5EF4-FFF2-40B4-BE49-F238E27FC236}">
+                <a16:creationId xmlns:a16="http://schemas.microsoft.com/office/drawing/2014/main" id="{B005335D-76EF-FEBD-F9F4-737A0A4E4CD1}"/>
+              </a:ext>
+            </a:extLst>
+          </p:cNvPr>
+          <p:cNvPicPr>
+            <a:picLocks noChangeAspect="1"/>
+          </p:cNvPicPr>
+          <p:nvPr/>
+        </p:nvPicPr>
+        <p:blipFill>
+          <a:blip>
+            <a:extLst>
+              <a:ext uri="{96DAC541-7B7A-43D3-8B79-37D633B846F1}">
+                <asvg:svgBlip xmlns:asvg="http://schemas.microsoft.com/office/drawing/2016/SVG/main" r:embed="rId5"/>
+              </a:ext>
+            </a:extLst>
+          </a:blip>
+          <a:srcRect t="6188"/>
+          <a:stretch>
+            <a:fillRect/>
+          </a:stretch>
+        </p:blipFill>
+        <p:spPr>
+          <a:xfrm>
+            <a:off x="438150" y="10240979"/>
+            <a:ext cx="4696774" cy="5507640"/>
           </a:xfrm>
           <a:prstGeom prst="rect">
             <a:avLst/>
@@ -6850,7 +8119,7 @@
     </p:spTree>
     <p:extLst>
       <p:ext uri="{BB962C8B-B14F-4D97-AF65-F5344CB8AC3E}">
-        <p14:creationId xmlns:p14="http://schemas.microsoft.com/office/powerpoint/2010/main" val="1631260291"/>
+        <p14:creationId xmlns:p14="http://schemas.microsoft.com/office/powerpoint/2010/main" val="4112512561"/>
       </p:ext>
     </p:extLst>
   </p:cSld>
@@ -7173,4 +8442,319 @@
     </a:ext>
   </a:extLst>
 </a:theme>
+</file>
+
+<file path=ppt/theme/theme2.xml><?xml version="1.0" encoding="utf-8"?>
+<a:theme xmlns:a="http://schemas.openxmlformats.org/drawingml/2006/main" name="Office">
+  <a:themeElements>
+    <a:clrScheme name="Office">
+      <a:dk1>
+        <a:sysClr val="windowText" lastClr="000000"/>
+      </a:dk1>
+      <a:lt1>
+        <a:sysClr val="window" lastClr="FFFFFF"/>
+      </a:lt1>
+      <a:dk2>
+        <a:srgbClr val="0E2841"/>
+      </a:dk2>
+      <a:lt2>
+        <a:srgbClr val="E8E8E8"/>
+      </a:lt2>
+      <a:accent1>
+        <a:srgbClr val="156082"/>
+      </a:accent1>
+      <a:accent2>
+        <a:srgbClr val="E97132"/>
+      </a:accent2>
+      <a:accent3>
+        <a:srgbClr val="196B24"/>
+      </a:accent3>
+      <a:accent4>
+        <a:srgbClr val="0F9ED5"/>
+      </a:accent4>
+      <a:accent5>
+        <a:srgbClr val="A02B93"/>
+      </a:accent5>
+      <a:accent6>
+        <a:srgbClr val="4EA72E"/>
+      </a:accent6>
+      <a:hlink>
+        <a:srgbClr val="467886"/>
+      </a:hlink>
+      <a:folHlink>
+        <a:srgbClr val="96607D"/>
+      </a:folHlink>
+    </a:clrScheme>
+    <a:fontScheme name="Office">
+      <a:majorFont>
+        <a:latin typeface="Aptos Display" panose="02110004020202020204"/>
+        <a:ea typeface=""/>
+        <a:cs typeface=""/>
+        <a:font script="Jpan" typeface="游ゴシック Light"/>
+        <a:font script="Hang" typeface="맑은 고딕"/>
+        <a:font script="Hans" typeface="等线 Light"/>
+        <a:font script="Hant" typeface="新細明體"/>
+        <a:font script="Arab" typeface="Times New Roman"/>
+        <a:font script="Hebr" typeface="Times New Roman"/>
+        <a:font script="Thai" typeface="Angsana New"/>
+        <a:font script="Ethi" typeface="Nyala"/>
+        <a:font script="Beng" typeface="Vrinda"/>
+        <a:font script="Gujr" typeface="Shruti"/>
+        <a:font script="Khmr" typeface="MoolBoran"/>
+        <a:font script="Knda" typeface="Tunga"/>
+        <a:font script="Guru" typeface="Raavi"/>
+        <a:font script="Cans" typeface="Euphemia"/>
+        <a:font script="Cher" typeface="Plantagenet Cherokee"/>
+        <a:font script="Yiii" typeface="Microsoft Yi Baiti"/>
+        <a:font script="Tibt" typeface="Microsoft Himalaya"/>
+        <a:font script="Thaa" typeface="MV Boli"/>
+        <a:font script="Deva" typeface="Mangal"/>
+        <a:font script="Telu" typeface="Gautami"/>
+        <a:font script="Taml" typeface="Latha"/>
+        <a:font script="Syrc" typeface="Estrangelo Edessa"/>
+        <a:font script="Orya" typeface="Kalinga"/>
+        <a:font script="Mlym" typeface="Kartika"/>
+        <a:font script="Laoo" typeface="DokChampa"/>
+        <a:font script="Sinh" typeface="Iskoola Pota"/>
+        <a:font script="Mong" typeface="Mongolian Baiti"/>
+        <a:font script="Viet" typeface="Times New Roman"/>
+        <a:font script="Uigh" typeface="Microsoft Uighur"/>
+        <a:font script="Geor" typeface="Sylfaen"/>
+        <a:font script="Armn" typeface="Arial"/>
+        <a:font script="Bugi" typeface="Leelawadee UI"/>
+        <a:font script="Bopo" typeface="Microsoft JhengHei"/>
+        <a:font script="Java" typeface="Javanese Text"/>
+        <a:font script="Lisu" typeface="Segoe UI"/>
+        <a:font script="Mymr" typeface="Myanmar Text"/>
+        <a:font script="Nkoo" typeface="Ebrima"/>
+        <a:font script="Olck" typeface="Nirmala UI"/>
+        <a:font script="Osma" typeface="Ebrima"/>
+        <a:font script="Phag" typeface="Phagspa"/>
+        <a:font script="Syrn" typeface="Estrangelo Edessa"/>
+        <a:font script="Syrj" typeface="Estrangelo Edessa"/>
+        <a:font script="Syre" typeface="Estrangelo Edessa"/>
+        <a:font script="Sora" typeface="Nirmala UI"/>
+        <a:font script="Tale" typeface="Microsoft Tai Le"/>
+        <a:font script="Talu" typeface="Microsoft New Tai Lue"/>
+        <a:font script="Tfng" typeface="Ebrima"/>
+      </a:majorFont>
+      <a:minorFont>
+        <a:latin typeface="Aptos" panose="02110004020202020204"/>
+        <a:ea typeface=""/>
+        <a:cs typeface=""/>
+        <a:font script="Jpan" typeface="游ゴシック"/>
+        <a:font script="Hang" typeface="맑은 고딕"/>
+        <a:font script="Hans" typeface="等线"/>
+        <a:font script="Hant" typeface="新細明體"/>
+        <a:font script="Arab" typeface="Arial"/>
+        <a:font script="Hebr" typeface="Arial"/>
+        <a:font script="Thai" typeface="Cordia New"/>
+        <a:font script="Ethi" typeface="Nyala"/>
+        <a:font script="Beng" typeface="Vrinda"/>
+        <a:font script="Gujr" typeface="Shruti"/>
+        <a:font script="Khmr" typeface="DaunPenh"/>
+        <a:font script="Knda" typeface="Tunga"/>
+        <a:font script="Guru" typeface="Raavi"/>
+        <a:font script="Cans" typeface="Euphemia"/>
+        <a:font script="Cher" typeface="Plantagenet Cherokee"/>
+        <a:font script="Yiii" typeface="Microsoft Yi Baiti"/>
+        <a:font script="Tibt" typeface="Microsoft Himalaya"/>
+        <a:font script="Thaa" typeface="MV Boli"/>
+        <a:font script="Deva" typeface="Mangal"/>
+        <a:font script="Telu" typeface="Gautami"/>
+        <a:font script="Taml" typeface="Latha"/>
+        <a:font script="Syrc" typeface="Estrangelo Edessa"/>
+        <a:font script="Orya" typeface="Kalinga"/>
+        <a:font script="Mlym" typeface="Kartika"/>
+        <a:font script="Laoo" typeface="DokChampa"/>
+        <a:font script="Sinh" typeface="Iskoola Pota"/>
+        <a:font script="Mong" typeface="Mongolian Baiti"/>
+        <a:font script="Viet" typeface="Arial"/>
+        <a:font script="Uigh" typeface="Microsoft Uighur"/>
+        <a:font script="Geor" typeface="Sylfaen"/>
+        <a:font script="Armn" typeface="Arial"/>
+        <a:font script="Bugi" typeface="Leelawadee UI"/>
+        <a:font script="Bopo" typeface="Microsoft JhengHei"/>
+        <a:font script="Java" typeface="Javanese Text"/>
+        <a:font script="Lisu" typeface="Segoe UI"/>
+        <a:font script="Mymr" typeface="Myanmar Text"/>
+        <a:font script="Nkoo" typeface="Ebrima"/>
+        <a:font script="Olck" typeface="Nirmala UI"/>
+        <a:font script="Osma" typeface="Ebrima"/>
+        <a:font script="Phag" typeface="Phagspa"/>
+        <a:font script="Syrn" typeface="Estrangelo Edessa"/>
+        <a:font script="Syrj" typeface="Estrangelo Edessa"/>
+        <a:font script="Syre" typeface="Estrangelo Edessa"/>
+        <a:font script="Sora" typeface="Nirmala UI"/>
+        <a:font script="Tale" typeface="Microsoft Tai Le"/>
+        <a:font script="Talu" typeface="Microsoft New Tai Lue"/>
+        <a:font script="Tfng" typeface="Ebrima"/>
+      </a:minorFont>
+    </a:fontScheme>
+    <a:fmtScheme name="Office">
+      <a:fillStyleLst>
+        <a:solidFill>
+          <a:schemeClr val="phClr"/>
+        </a:solidFill>
+        <a:gradFill rotWithShape="1">
+          <a:gsLst>
+            <a:gs pos="0">
+              <a:schemeClr val="phClr">
+                <a:lumMod val="110000"/>
+                <a:satMod val="105000"/>
+                <a:tint val="67000"/>
+              </a:schemeClr>
+            </a:gs>
+            <a:gs pos="50000">
+              <a:schemeClr val="phClr">
+                <a:lumMod val="105000"/>
+                <a:satMod val="103000"/>
+                <a:tint val="73000"/>
+              </a:schemeClr>
+            </a:gs>
+            <a:gs pos="100000">
+              <a:schemeClr val="phClr">
+                <a:lumMod val="105000"/>
+                <a:satMod val="109000"/>
+                <a:tint val="81000"/>
+              </a:schemeClr>
+            </a:gs>
+          </a:gsLst>
+          <a:lin ang="5400000" scaled="0"/>
+        </a:gradFill>
+        <a:gradFill rotWithShape="1">
+          <a:gsLst>
+            <a:gs pos="0">
+              <a:schemeClr val="phClr">
+                <a:satMod val="103000"/>
+                <a:lumMod val="102000"/>
+                <a:tint val="94000"/>
+              </a:schemeClr>
+            </a:gs>
+            <a:gs pos="50000">
+              <a:schemeClr val="phClr">
+                <a:satMod val="110000"/>
+                <a:lumMod val="100000"/>
+                <a:shade val="100000"/>
+              </a:schemeClr>
+            </a:gs>
+            <a:gs pos="100000">
+              <a:schemeClr val="phClr">
+                <a:lumMod val="99000"/>
+                <a:satMod val="120000"/>
+                <a:shade val="78000"/>
+              </a:schemeClr>
+            </a:gs>
+          </a:gsLst>
+          <a:lin ang="5400000" scaled="0"/>
+        </a:gradFill>
+      </a:fillStyleLst>
+      <a:lnStyleLst>
+        <a:ln w="12700" cap="flat" cmpd="sng" algn="ctr">
+          <a:solidFill>
+            <a:schemeClr val="phClr"/>
+          </a:solidFill>
+          <a:prstDash val="solid"/>
+          <a:miter lim="800000"/>
+        </a:ln>
+        <a:ln w="19050" cap="flat" cmpd="sng" algn="ctr">
+          <a:solidFill>
+            <a:schemeClr val="phClr"/>
+          </a:solidFill>
+          <a:prstDash val="solid"/>
+          <a:miter lim="800000"/>
+        </a:ln>
+        <a:ln w="25400" cap="flat" cmpd="sng" algn="ctr">
+          <a:solidFill>
+            <a:schemeClr val="phClr"/>
+          </a:solidFill>
+          <a:prstDash val="solid"/>
+          <a:miter lim="800000"/>
+        </a:ln>
+      </a:lnStyleLst>
+      <a:effectStyleLst>
+        <a:effectStyle>
+          <a:effectLst/>
+        </a:effectStyle>
+        <a:effectStyle>
+          <a:effectLst/>
+        </a:effectStyle>
+        <a:effectStyle>
+          <a:effectLst>
+            <a:outerShdw blurRad="57150" dist="19050" dir="5400000" algn="ctr" rotWithShape="0">
+              <a:srgbClr val="000000">
+                <a:alpha val="63000"/>
+              </a:srgbClr>
+            </a:outerShdw>
+          </a:effectLst>
+        </a:effectStyle>
+      </a:effectStyleLst>
+      <a:bgFillStyleLst>
+        <a:solidFill>
+          <a:schemeClr val="phClr"/>
+        </a:solidFill>
+        <a:solidFill>
+          <a:schemeClr val="phClr">
+            <a:tint val="95000"/>
+            <a:satMod val="170000"/>
+          </a:schemeClr>
+        </a:solidFill>
+        <a:gradFill rotWithShape="1">
+          <a:gsLst>
+            <a:gs pos="0">
+              <a:schemeClr val="phClr">
+                <a:tint val="93000"/>
+                <a:satMod val="150000"/>
+                <a:shade val="98000"/>
+                <a:lumMod val="102000"/>
+              </a:schemeClr>
+            </a:gs>
+            <a:gs pos="50000">
+              <a:schemeClr val="phClr">
+                <a:tint val="98000"/>
+                <a:satMod val="130000"/>
+                <a:shade val="90000"/>
+                <a:lumMod val="103000"/>
+              </a:schemeClr>
+            </a:gs>
+            <a:gs pos="100000">
+              <a:schemeClr val="phClr">
+                <a:shade val="63000"/>
+                <a:satMod val="120000"/>
+              </a:schemeClr>
+            </a:gs>
+          </a:gsLst>
+          <a:lin ang="5400000" scaled="0"/>
+        </a:gradFill>
+      </a:bgFillStyleLst>
+    </a:fmtScheme>
+  </a:themeElements>
+  <a:objectDefaults>
+    <a:lnDef>
+      <a:spPr/>
+      <a:bodyPr/>
+      <a:lstStyle/>
+      <a:style>
+        <a:lnRef idx="2">
+          <a:schemeClr val="accent1"/>
+        </a:lnRef>
+        <a:fillRef idx="0">
+          <a:schemeClr val="accent1"/>
+        </a:fillRef>
+        <a:effectRef idx="1">
+          <a:schemeClr val="accent1"/>
+        </a:effectRef>
+        <a:fontRef idx="minor">
+          <a:schemeClr val="tx1"/>
+        </a:fontRef>
+      </a:style>
+    </a:lnDef>
+  </a:objectDefaults>
+  <a:extraClrSchemeLst/>
+  <a:extLst>
+    <a:ext uri="{05A4C25C-085E-4340-85A3-A5531E510DB2}">
+      <thm15:themeFamily xmlns:thm15="http://schemas.microsoft.com/office/thememl/2012/main" name="Office Theme" id="{2E142A2C-CD16-42D6-873A-C26D2A0506FA}" vid="{1BDDFF52-6CD6-40A5-AB3C-68EB2F1E4D0A}"/>
+    </a:ext>
+  </a:extLst>
+</a:theme>
 </file>
</xml_diff>